<commit_message>
Deck refresh: 23 slides (extended load mix, transaction variants + noLimbo, field diagnostics); fix footer repo URL
</commit_message>
<xml_diff>
--- a/IBSurgeon_LoadGenerator.pptx
+++ b/IBSurgeon_LoadGenerator.pptx
@@ -25,9 +25,12 @@
     <p:sldId id="273" r:id="rId19"/>
     <p:sldId id="274" r:id="rId20"/>
     <p:sldId id="275" r:id="rId21"/>
+    <p:sldId id="276" r:id="rId22"/>
+    <p:sldId id="277" r:id="rId23"/>
+    <p:sldId id="278" r:id="rId24"/>
   </p:sldIdLst>
   <p:notesMasterIdLst>
-    <p:notesMasterId r:id="rId22"/>
+    <p:notesMasterId r:id="rId25"/>
   </p:notesMasterIdLst>
   <p:sldSz cx="12191695" cy="6858000"/>
   <p:notesSz cx="6858000" cy="12191695"/>
@@ -1772,7 +1775,7 @@
           <a:p>
             <a:r>
               <a:rPr lang="en-US" dirty="0"/>
-              <a:t>All three run against the same control plane; recipes adapted from API.md.</a:t>
+              <a:t>All sidecars are part of the extendedLoad config section (CLI flags, UI panel, API). Heavy SELECT and bulk DML run on dedicated objects (EL_BULK_ITEMS); the ops log mirrors the Firebird replication journal printer format with size rotation and a start/terminal pairing check; -plusddl churns its own TST_ columns and verifies rolled-back DDL against rdb$relation_fields.</a:t>
             </a:r>
             <a:endParaRPr lang="en-US" dirty="0"/>
           </a:p>
@@ -1860,7 +1863,7 @@
           <a:p>
             <a:r>
               <a:rPr lang="en-US" dirty="0"/>
-              <a:t>Done items shipped with schedules/history; roadmap from IMPROVEMENTS.md.</a:t>
+              <a:t>The completion axis: commit, rollback, commit/rollback retaining (chain length capped), engine-side two-phase commit via EXECUTE STATEMENT ... WITH COMMON TRANSACTION against an aux database, limbo (prepare-then-die, resolved by the recovery sidecar through the Services API) and a planned hard connection drop after which the worker rebuilds its pool in place. emul-safe mode never draws infinite-wait transactions. limbo and conn-drop are rate-limited run-wide. --no-limbo runs the same mix with limbo generation switched off entirely.</a:t>
             </a:r>
             <a:endParaRPr lang="en-US" dirty="0"/>
           </a:p>
@@ -2036,7 +2039,7 @@
           <a:p>
             <a:r>
               <a:rPr lang="en-US" dirty="0"/>
-              <a:t>Full tables live in API.md and README.md.</a:t>
+              <a:t>lwmprobe: attach-only cycles (no tables, no data) reproduce the HQbird LightWeight Monitoring shared-memory version conflict between mixed builds on one host; a built-in firebird.log watcher turns the result into a go/no-go signal. A pure-Python twin ships in scripts/. limbocrash: a prepared transaction whose connection dies crashes Firebird 4.0.7 / 5.0.x with replication enabled (0xC0000005, every tested build and server mode); the repo carries the minimal reproducer, a build matrix and the investigation plan. Until the engine bug is fixed, --no-limbo keeps replicated targets safe.</a:t>
             </a:r>
             <a:endParaRPr lang="en-US" dirty="0"/>
           </a:p>
@@ -2060,6 +2063,270 @@
             <a:fld id="{F7021451-1387-4CA6-816F-3879F97B5CBC}" type="slidenum">
               <a:rPr lang="en-US"/>
               <a:t>20</a:t>
+            </a:fld>
+            <a:endParaRPr lang="en-US"/>
+          </a:p>
+        </p:txBody>
+      </p:sp>
+    </p:spTree>
+    <p:extLst>
+      <p:ext uri="{BB962C8B-B14F-4D97-AF65-F5344CB8AC3E}">
+        <p14:creationId xmlns:p14="http://schemas.microsoft.com/office/powerpoint/2010/main" val="1024086991"/>
+      </p:ext>
+    </p:extLst>
+  </p:cSld>
+  <p:clrMapOvr>
+    <a:masterClrMapping/>
+  </p:clrMapOvr>
+</p:notes>
+</file>
+
+<file path=ppt/notesSlides/notesSlide21.xml><?xml version="1.0" encoding="utf-8"?>
+<p:notes xmlns:a="http://schemas.openxmlformats.org/drawingml/2006/main" xmlns:r="http://schemas.openxmlformats.org/officeDocument/2006/relationships" xmlns:p="http://schemas.openxmlformats.org/presentationml/2006/main">
+  <p:cSld>
+    <p:spTree>
+      <p:nvGrpSpPr>
+        <p:cNvPr id="1" name=""/>
+        <p:cNvGrpSpPr/>
+        <p:nvPr/>
+      </p:nvGrpSpPr>
+      <p:grpSpPr>
+        <a:xfrm>
+          <a:off x="0" y="0"/>
+          <a:ext cx="0" cy="0"/>
+          <a:chOff x="0" y="0"/>
+          <a:chExt cx="0" cy="0"/>
+        </a:xfrm>
+      </p:grpSpPr>
+      <p:sp>
+        <p:nvSpPr>
+          <p:cNvPr id="2" name="Slide Image Placeholder 1"/>
+          <p:cNvSpPr>
+            <a:spLocks noGrp="1" noRot="1" noChangeAspect="1"/>
+          </p:cNvSpPr>
+          <p:nvPr>
+            <p:ph type="sldImg"/>
+          </p:nvPr>
+        </p:nvSpPr>
+        <p:spPr/>
+      </p:sp>
+      <p:sp>
+        <p:nvSpPr>
+          <p:cNvPr id="3" name="Notes Placeholder 2"/>
+          <p:cNvSpPr>
+            <a:spLocks noGrp="1"/>
+          </p:cNvSpPr>
+          <p:nvPr>
+            <p:ph type="body" idx="1"/>
+          </p:nvPr>
+        </p:nvSpPr>
+        <p:spPr/>
+        <p:txBody>
+          <a:bodyPr/>
+          <a:lstStyle/>
+          <a:p>
+            <a:r>
+              <a:rPr lang="en-US" dirty="0"/>
+              <a:t>All three run against the same control plane; recipes adapted from API.md.</a:t>
+            </a:r>
+            <a:endParaRPr lang="en-US" dirty="0"/>
+          </a:p>
+        </p:txBody>
+      </p:sp>
+      <p:sp>
+        <p:nvSpPr>
+          <p:cNvPr id="4" name="Slide Number Placeholder 3"/>
+          <p:cNvSpPr>
+            <a:spLocks noGrp="1"/>
+          </p:cNvSpPr>
+          <p:nvPr>
+            <p:ph type="sldNum" sz="quarter" idx="10"/>
+          </p:nvPr>
+        </p:nvSpPr>
+        <p:spPr/>
+        <p:txBody>
+          <a:bodyPr/>
+          <a:lstStyle/>
+          <a:p>
+            <a:fld id="{F7021451-1387-4CA6-816F-3879F97B5CBC}" type="slidenum">
+              <a:rPr lang="en-US"/>
+              <a:t>21</a:t>
+            </a:fld>
+            <a:endParaRPr lang="en-US"/>
+          </a:p>
+        </p:txBody>
+      </p:sp>
+    </p:spTree>
+    <p:extLst>
+      <p:ext uri="{BB962C8B-B14F-4D97-AF65-F5344CB8AC3E}">
+        <p14:creationId xmlns:p14="http://schemas.microsoft.com/office/powerpoint/2010/main" val="1024086991"/>
+      </p:ext>
+    </p:extLst>
+  </p:cSld>
+  <p:clrMapOvr>
+    <a:masterClrMapping/>
+  </p:clrMapOvr>
+</p:notes>
+</file>
+
+<file path=ppt/notesSlides/notesSlide22.xml><?xml version="1.0" encoding="utf-8"?>
+<p:notes xmlns:a="http://schemas.openxmlformats.org/drawingml/2006/main" xmlns:r="http://schemas.openxmlformats.org/officeDocument/2006/relationships" xmlns:p="http://schemas.openxmlformats.org/presentationml/2006/main">
+  <p:cSld>
+    <p:spTree>
+      <p:nvGrpSpPr>
+        <p:cNvPr id="1" name=""/>
+        <p:cNvGrpSpPr/>
+        <p:nvPr/>
+      </p:nvGrpSpPr>
+      <p:grpSpPr>
+        <a:xfrm>
+          <a:off x="0" y="0"/>
+          <a:ext cx="0" cy="0"/>
+          <a:chOff x="0" y="0"/>
+          <a:chExt cx="0" cy="0"/>
+        </a:xfrm>
+      </p:grpSpPr>
+      <p:sp>
+        <p:nvSpPr>
+          <p:cNvPr id="2" name="Slide Image Placeholder 1"/>
+          <p:cNvSpPr>
+            <a:spLocks noGrp="1" noRot="1" noChangeAspect="1"/>
+          </p:cNvSpPr>
+          <p:nvPr>
+            <p:ph type="sldImg"/>
+          </p:nvPr>
+        </p:nvSpPr>
+        <p:spPr/>
+      </p:sp>
+      <p:sp>
+        <p:nvSpPr>
+          <p:cNvPr id="3" name="Notes Placeholder 2"/>
+          <p:cNvSpPr>
+            <a:spLocks noGrp="1"/>
+          </p:cNvSpPr>
+          <p:nvPr>
+            <p:ph type="body" idx="1"/>
+          </p:nvPr>
+        </p:nvSpPr>
+        <p:spPr/>
+        <p:txBody>
+          <a:bodyPr/>
+          <a:lstStyle/>
+          <a:p>
+            <a:r>
+              <a:rPr lang="en-US" dirty="0"/>
+              <a:t>Done items shipped with schedules/history; roadmap from IMPROVEMENTS.md.</a:t>
+            </a:r>
+            <a:endParaRPr lang="en-US" dirty="0"/>
+          </a:p>
+        </p:txBody>
+      </p:sp>
+      <p:sp>
+        <p:nvSpPr>
+          <p:cNvPr id="4" name="Slide Number Placeholder 3"/>
+          <p:cNvSpPr>
+            <a:spLocks noGrp="1"/>
+          </p:cNvSpPr>
+          <p:nvPr>
+            <p:ph type="sldNum" sz="quarter" idx="10"/>
+          </p:nvPr>
+        </p:nvSpPr>
+        <p:spPr/>
+        <p:txBody>
+          <a:bodyPr/>
+          <a:lstStyle/>
+          <a:p>
+            <a:fld id="{F7021451-1387-4CA6-816F-3879F97B5CBC}" type="slidenum">
+              <a:rPr lang="en-US"/>
+              <a:t>22</a:t>
+            </a:fld>
+            <a:endParaRPr lang="en-US"/>
+          </a:p>
+        </p:txBody>
+      </p:sp>
+    </p:spTree>
+    <p:extLst>
+      <p:ext uri="{BB962C8B-B14F-4D97-AF65-F5344CB8AC3E}">
+        <p14:creationId xmlns:p14="http://schemas.microsoft.com/office/powerpoint/2010/main" val="1024086991"/>
+      </p:ext>
+    </p:extLst>
+  </p:cSld>
+  <p:clrMapOvr>
+    <a:masterClrMapping/>
+  </p:clrMapOvr>
+</p:notes>
+</file>
+
+<file path=ppt/notesSlides/notesSlide23.xml><?xml version="1.0" encoding="utf-8"?>
+<p:notes xmlns:a="http://schemas.openxmlformats.org/drawingml/2006/main" xmlns:r="http://schemas.openxmlformats.org/officeDocument/2006/relationships" xmlns:p="http://schemas.openxmlformats.org/presentationml/2006/main">
+  <p:cSld>
+    <p:spTree>
+      <p:nvGrpSpPr>
+        <p:cNvPr id="1" name=""/>
+        <p:cNvGrpSpPr/>
+        <p:nvPr/>
+      </p:nvGrpSpPr>
+      <p:grpSpPr>
+        <a:xfrm>
+          <a:off x="0" y="0"/>
+          <a:ext cx="0" cy="0"/>
+          <a:chOff x="0" y="0"/>
+          <a:chExt cx="0" cy="0"/>
+        </a:xfrm>
+      </p:grpSpPr>
+      <p:sp>
+        <p:nvSpPr>
+          <p:cNvPr id="2" name="Slide Image Placeholder 1"/>
+          <p:cNvSpPr>
+            <a:spLocks noGrp="1" noRot="1" noChangeAspect="1"/>
+          </p:cNvSpPr>
+          <p:nvPr>
+            <p:ph type="sldImg"/>
+          </p:nvPr>
+        </p:nvSpPr>
+        <p:spPr/>
+      </p:sp>
+      <p:sp>
+        <p:nvSpPr>
+          <p:cNvPr id="3" name="Notes Placeholder 2"/>
+          <p:cNvSpPr>
+            <a:spLocks noGrp="1"/>
+          </p:cNvSpPr>
+          <p:nvPr>
+            <p:ph type="body" idx="1"/>
+          </p:nvPr>
+        </p:nvSpPr>
+        <p:spPr/>
+        <p:txBody>
+          <a:bodyPr/>
+          <a:lstStyle/>
+          <a:p>
+            <a:r>
+              <a:rPr lang="en-US" dirty="0"/>
+              <a:t>Full tables live in API.md and README.md.</a:t>
+            </a:r>
+            <a:endParaRPr lang="en-US" dirty="0"/>
+          </a:p>
+        </p:txBody>
+      </p:sp>
+      <p:sp>
+        <p:nvSpPr>
+          <p:cNvPr id="4" name="Slide Number Placeholder 3"/>
+          <p:cNvSpPr>
+            <a:spLocks noGrp="1"/>
+          </p:cNvSpPr>
+          <p:nvPr>
+            <p:ph type="sldNum" sz="quarter" idx="10"/>
+          </p:nvPr>
+        </p:nvSpPr>
+        <p:spPr/>
+        <p:txBody>
+          <a:bodyPr/>
+          <a:lstStyle/>
+          <a:p>
+            <a:fld id="{F7021451-1387-4CA6-816F-3879F97B5CBC}" type="slidenum">
+              <a:rPr lang="en-US"/>
+              <a:t>23</a:t>
             </a:fld>
             <a:endParaRPr lang="en-US"/>
           </a:p>
@@ -9550,7 +9817,7 @@
                 <a:ea typeface="Segoe UI" pitchFamily="34" charset="-122"/>
                 <a:cs typeface="Segoe UI" pitchFamily="34" charset="-120"/>
               </a:rPr>
-              <a:t>Typical scenarios</a:t>
+              <a:t>Extended load mix — stress beyond the business process</a:t>
             </a:r>
             <a:endParaRPr lang="en-US" sz="2700" dirty="0"/>
           </a:p>
@@ -9559,6 +9826,45 @@
       <p:sp>
         <p:nvSpPr>
           <p:cNvPr id="3" name="Text 1"/>
+          <p:cNvSpPr/>
+          <p:nvPr/>
+        </p:nvSpPr>
+        <p:spPr>
+          <a:xfrm>
+            <a:off x="521208" y="786384"/>
+            <a:ext cx="11185855" cy="310896"/>
+          </a:xfrm>
+          <a:prstGeom prst="rect">
+            <a:avLst/>
+          </a:prstGeom>
+          <a:noFill/>
+          <a:ln/>
+        </p:spPr>
+        <p:txBody>
+          <a:bodyPr wrap="square" rtlCol="0" anchor="ctr"/>
+          <a:lstStyle/>
+          <a:p>
+            <a:pPr indent="0" marL="0">
+              <a:buNone/>
+            </a:pPr>
+            <a:r>
+              <a:rPr lang="en-US" sz="1300" dirty="0">
+                <a:solidFill>
+                  <a:srgbClr val="5F6F83"/>
+                </a:solidFill>
+                <a:latin typeface="Segoe UI" pitchFamily="34" charset="0"/>
+                <a:ea typeface="Segoe UI" pitchFamily="34" charset="-122"/>
+                <a:cs typeface="Segoe UI" pitchFamily="34" charset="-120"/>
+              </a:rPr>
+              <a:t>Periodic sidecars on top of the regular op mix: heavy reads, mass DML, a replication-style operations log and live DDL churn — each switchable, none touching the score tables.</a:t>
+            </a:r>
+            <a:endParaRPr lang="en-US" sz="1300" dirty="0"/>
+          </a:p>
+        </p:txBody>
+      </p:sp>
+      <p:sp>
+        <p:nvSpPr>
+          <p:cNvPr id="4" name="Text 2"/>
           <p:cNvSpPr/>
           <p:nvPr/>
         </p:nvSpPr>
@@ -9611,18 +9917,18 @@
       </p:sp>
       <p:sp>
         <p:nvSpPr>
-          <p:cNvPr id="5" name="Shape 2"/>
+          <p:cNvPr id="6" name="Shape 3"/>
           <p:cNvSpPr/>
           <p:nvPr/>
         </p:nvSpPr>
         <p:spPr>
           <a:xfrm>
             <a:off x="502920" y="1371600"/>
-            <a:ext cx="3703320" cy="4206240"/>
+            <a:ext cx="4114800" cy="2148840"/>
           </a:xfrm>
           <a:prstGeom prst="roundRect">
             <a:avLst>
-              <a:gd name="adj" fmla="val 1481"/>
+              <a:gd name="adj" fmla="val 2553"/>
             </a:avLst>
           </a:prstGeom>
           <a:solidFill>
@@ -9638,30 +9944,30 @@
       </p:sp>
       <p:sp>
         <p:nvSpPr>
-          <p:cNvPr id="6" name="Text 3"/>
-          <p:cNvSpPr/>
-          <p:nvPr/>
-        </p:nvSpPr>
-        <p:spPr>
-          <a:xfrm>
-            <a:off x="685800" y="1536192"/>
-            <a:ext cx="3337560" cy="365760"/>
-          </a:xfrm>
-          <a:prstGeom prst="rect">
-            <a:avLst/>
-          </a:prstGeom>
-          <a:noFill/>
-          <a:ln/>
-        </p:spPr>
-        <p:txBody>
-          <a:bodyPr wrap="square" rtlCol="0" anchor="ctr"/>
-          <a:lstStyle/>
-          <a:p>
-            <a:pPr indent="0" marL="0">
-              <a:buNone/>
-            </a:pPr>
-            <a:r>
-              <a:rPr lang="en-US" sz="1500" b="1" dirty="0">
+          <p:cNvPr id="7" name="Text 4"/>
+          <p:cNvSpPr/>
+          <p:nvPr/>
+        </p:nvSpPr>
+        <p:spPr>
+          <a:xfrm>
+            <a:off x="685800" y="1499616"/>
+            <a:ext cx="3749040" cy="365760"/>
+          </a:xfrm>
+          <a:prstGeom prst="rect">
+            <a:avLst/>
+          </a:prstGeom>
+          <a:noFill/>
+          <a:ln/>
+        </p:spPr>
+        <p:txBody>
+          <a:bodyPr wrap="square" rtlCol="0" anchor="ctr"/>
+          <a:lstStyle/>
+          <a:p>
+            <a:pPr indent="0" marL="0">
+              <a:buNone/>
+            </a:pPr>
+            <a:r>
+              <a:rPr lang="en-US" sz="1400" b="1" dirty="0">
                 <a:solidFill>
                   <a:srgbClr val="2563EB"/>
                 </a:solidFill>
@@ -9669,194 +9975,65 @@
                 <a:ea typeface="Segoe UI" pitchFamily="34" charset="-122"/>
                 <a:cs typeface="Segoe UI" pitchFamily="34" charset="-120"/>
               </a:rPr>
-              <a:t>Nightly soak</a:t>
-            </a:r>
-            <a:endParaRPr lang="en-US" sz="1500" dirty="0"/>
-          </a:p>
-        </p:txBody>
-      </p:sp>
-      <p:sp>
-        <p:nvSpPr>
-          <p:cNvPr id="7" name="Shape 4"/>
-          <p:cNvSpPr/>
-          <p:nvPr/>
-        </p:nvSpPr>
-        <p:spPr>
-          <a:xfrm>
-            <a:off x="685800" y="2011680"/>
-            <a:ext cx="3337560" cy="2743200"/>
+              <a:t>Heavy JOIN SELECT</a:t>
+            </a:r>
+            <a:endParaRPr lang="en-US" sz="1400" dirty="0"/>
+          </a:p>
+        </p:txBody>
+      </p:sp>
+      <p:sp>
+        <p:nvSpPr>
+          <p:cNvPr id="8" name="Text 5"/>
+          <p:cNvSpPr/>
+          <p:nvPr/>
+        </p:nvSpPr>
+        <p:spPr>
+          <a:xfrm>
+            <a:off x="685800" y="1920240"/>
+            <a:ext cx="3749040" cy="1463040"/>
+          </a:xfrm>
+          <a:prstGeom prst="rect">
+            <a:avLst/>
+          </a:prstGeom>
+          <a:noFill/>
+          <a:ln/>
+        </p:spPr>
+        <p:txBody>
+          <a:bodyPr wrap="square" rtlCol="0" anchor="ctr"/>
+          <a:lstStyle/>
+          <a:p>
+            <a:pPr indent="0" marL="0">
+              <a:buNone/>
+            </a:pPr>
+            <a:r>
+              <a:rPr lang="en-US" sz="1050" dirty="0">
+                <a:solidFill>
+                  <a:srgbClr val="1C2733"/>
+                </a:solidFill>
+                <a:latin typeface="Segoe UI" pitchFamily="34" charset="0"/>
+                <a:ea typeface="Segoe UI" pitchFamily="34" charset="-122"/>
+                <a:cs typeface="Segoe UI" pitchFamily="34" charset="-120"/>
+              </a:rPr>
+              <a:t>every 5 s: a 3–4 table scan over the business tables with a random id-range filter, aggregation and a sorted cut — cache pressure a plain OLTP mix never builds.</a:t>
+            </a:r>
+            <a:endParaRPr lang="en-US" sz="1050" dirty="0"/>
+          </a:p>
+        </p:txBody>
+      </p:sp>
+      <p:sp>
+        <p:nvSpPr>
+          <p:cNvPr id="9" name="Shape 6"/>
+          <p:cNvSpPr/>
+          <p:nvPr/>
+        </p:nvSpPr>
+        <p:spPr>
+          <a:xfrm>
+            <a:off x="4800600" y="1371600"/>
+            <a:ext cx="4114800" cy="2148840"/>
           </a:xfrm>
           <a:prstGeom prst="roundRect">
             <a:avLst>
-              <a:gd name="adj" fmla="val 2000"/>
-            </a:avLst>
-          </a:prstGeom>
-          <a:solidFill>
-            <a:srgbClr val="1C2733"/>
-          </a:solidFill>
-          <a:ln/>
-        </p:spPr>
-      </p:sp>
-      <p:sp>
-        <p:nvSpPr>
-          <p:cNvPr id="8" name="Text 5"/>
-          <p:cNvSpPr/>
-          <p:nvPr/>
-        </p:nvSpPr>
-        <p:spPr>
-          <a:xfrm>
-            <a:off x="822960" y="2103120"/>
-            <a:ext cx="3063240" cy="2560320"/>
-          </a:xfrm>
-          <a:prstGeom prst="rect">
-            <a:avLst/>
-          </a:prstGeom>
-          <a:noFill/>
-          <a:ln/>
-        </p:spPr>
-        <p:txBody>
-          <a:bodyPr wrap="square" rtlCol="0" anchor="t"/>
-          <a:lstStyle/>
-          <a:p>
-            <a:pPr indent="0" marL="0">
-              <a:buNone/>
-            </a:pPr>
-            <a:r>
-              <a:rPr lang="en-US" sz="1050" dirty="0">
-                <a:solidFill>
-                  <a:srgbClr val="E7ECF3"/>
-                </a:solidFill>
-                <a:latin typeface="Consolas" pitchFamily="34" charset="0"/>
-                <a:ea typeface="Consolas" pitchFamily="34" charset="-122"/>
-                <a:cs typeface="Consolas" pitchFamily="34" charset="-120"/>
-              </a:rPr>
-              <a:t>curl -X POST $BASE/api/schedules -d '{</a:t>
-            </a:r>
-            <a:endParaRPr lang="en-US" sz="1050" dirty="0"/>
-          </a:p>
-          <a:p>
-            <a:pPr indent="0" marL="0">
-              <a:buNone/>
-            </a:pPr>
-            <a:r>
-              <a:rPr lang="en-US" sz="1050" dirty="0">
-                <a:solidFill>
-                  <a:srgbClr val="E7ECF3"/>
-                </a:solidFill>
-                <a:latin typeface="Consolas" pitchFamily="34" charset="0"/>
-                <a:ea typeface="Consolas" pitchFamily="34" charset="-122"/>
-                <a:cs typeface="Consolas" pitchFamily="34" charset="-120"/>
-              </a:rPr>
-              <a:t>  "trigger": {"type":"cron",</a:t>
-            </a:r>
-            <a:endParaRPr lang="en-US" sz="1050" dirty="0"/>
-          </a:p>
-          <a:p>
-            <a:pPr indent="0" marL="0">
-              <a:buNone/>
-            </a:pPr>
-            <a:r>
-              <a:rPr lang="en-US" sz="1050" dirty="0">
-                <a:solidFill>
-                  <a:srgbClr val="E7ECF3"/>
-                </a:solidFill>
-                <a:latin typeface="Consolas" pitchFamily="34" charset="0"/>
-                <a:ea typeface="Consolas" pitchFamily="34" charset="-122"/>
-                <a:cs typeface="Consolas" pitchFamily="34" charset="-120"/>
-              </a:rPr>
-              <a:t>   "cron":"0 2 * * *"},</a:t>
-            </a:r>
-            <a:endParaRPr lang="en-US" sz="1050" dirty="0"/>
-          </a:p>
-          <a:p>
-            <a:pPr indent="0" marL="0">
-              <a:buNone/>
-            </a:pPr>
-            <a:r>
-              <a:rPr lang="en-US" sz="1050" dirty="0">
-                <a:solidFill>
-                  <a:srgbClr val="E7ECF3"/>
-                </a:solidFill>
-                <a:latin typeface="Consolas" pitchFamily="34" charset="0"/>
-                <a:ea typeface="Consolas" pitchFamily="34" charset="-122"/>
-                <a:cs typeface="Consolas" pitchFamily="34" charset="-120"/>
-              </a:rPr>
-              <a:t>  "run": {"timeLimitMin":30},</a:t>
-            </a:r>
-            <a:endParaRPr lang="en-US" sz="1050" dirty="0"/>
-          </a:p>
-          <a:p>
-            <a:pPr indent="0" marL="0">
-              <a:buNone/>
-            </a:pPr>
-            <a:r>
-              <a:rPr lang="en-US" sz="1050" dirty="0">
-                <a:solidFill>
-                  <a:srgbClr val="E7ECF3"/>
-                </a:solidFill>
-                <a:latin typeface="Consolas" pitchFamily="34" charset="0"/>
-                <a:ea typeface="Consolas" pitchFamily="34" charset="-122"/>
-                <a:cs typeface="Consolas" pitchFamily="34" charset="-120"/>
-              </a:rPr>
-              <a:t>  "notifyUrl":"https://hooks/…"}'</a:t>
-            </a:r>
-            <a:endParaRPr lang="en-US" sz="1050" dirty="0"/>
-          </a:p>
-        </p:txBody>
-      </p:sp>
-      <p:sp>
-        <p:nvSpPr>
-          <p:cNvPr id="9" name="Text 6"/>
-          <p:cNvSpPr/>
-          <p:nvPr/>
-        </p:nvSpPr>
-        <p:spPr>
-          <a:xfrm>
-            <a:off x="685800" y="4846320"/>
-            <a:ext cx="3337560" cy="640080"/>
-          </a:xfrm>
-          <a:prstGeom prst="rect">
-            <a:avLst/>
-          </a:prstGeom>
-          <a:noFill/>
-          <a:ln/>
-        </p:spPr>
-        <p:txBody>
-          <a:bodyPr wrap="square" rtlCol="0" anchor="ctr"/>
-          <a:lstStyle/>
-          <a:p>
-            <a:pPr indent="0" marL="0">
-              <a:buNone/>
-            </a:pPr>
-            <a:r>
-              <a:rPr lang="en-US" sz="1050" dirty="0">
-                <a:solidFill>
-                  <a:srgbClr val="5F6F83"/>
-                </a:solidFill>
-                <a:latin typeface="Segoe UI" pitchFamily="34" charset="0"/>
-                <a:ea typeface="Segoe UI" pitchFamily="34" charset="-122"/>
-                <a:cs typeface="Segoe UI" pitchFamily="34" charset="-120"/>
-              </a:rPr>
-              <a:t>Every night at 02:00, 30 minutes, webhook tells you the outcome</a:t>
-            </a:r>
-            <a:endParaRPr lang="en-US" sz="1050" dirty="0"/>
-          </a:p>
-        </p:txBody>
-      </p:sp>
-      <p:sp>
-        <p:nvSpPr>
-          <p:cNvPr id="10" name="Shape 7"/>
-          <p:cNvSpPr/>
-          <p:nvPr/>
-        </p:nvSpPr>
-        <p:spPr>
-          <a:xfrm>
-            <a:off x="4416552" y="1371600"/>
-            <a:ext cx="3703320" cy="4206240"/>
-          </a:xfrm>
-          <a:prstGeom prst="roundRect">
-            <a:avLst>
-              <a:gd name="adj" fmla="val 1481"/>
+              <a:gd name="adj" fmla="val 2553"/>
             </a:avLst>
           </a:prstGeom>
           <a:solidFill>
@@ -9872,40 +10049,79 @@
       </p:sp>
       <p:sp>
         <p:nvSpPr>
+          <p:cNvPr id="10" name="Text 7"/>
+          <p:cNvSpPr/>
+          <p:nvPr/>
+        </p:nvSpPr>
+        <p:spPr>
+          <a:xfrm>
+            <a:off x="4983480" y="1499616"/>
+            <a:ext cx="3749040" cy="365760"/>
+          </a:xfrm>
+          <a:prstGeom prst="rect">
+            <a:avLst/>
+          </a:prstGeom>
+          <a:noFill/>
+          <a:ln/>
+        </p:spPr>
+        <p:txBody>
+          <a:bodyPr wrap="square" rtlCol="0" anchor="ctr"/>
+          <a:lstStyle/>
+          <a:p>
+            <a:pPr indent="0" marL="0">
+              <a:buNone/>
+            </a:pPr>
+            <a:r>
+              <a:rPr lang="en-US" sz="1400" b="1" dirty="0">
+                <a:solidFill>
+                  <a:srgbClr val="2563EB"/>
+                </a:solidFill>
+                <a:latin typeface="Segoe UI" pitchFamily="34" charset="0"/>
+                <a:ea typeface="Segoe UI" pitchFamily="34" charset="-122"/>
+                <a:cs typeface="Segoe UI" pitchFamily="34" charset="-120"/>
+              </a:rPr>
+              <a:t>Bulk DML</a:t>
+            </a:r>
+            <a:endParaRPr lang="en-US" sz="1400" dirty="0"/>
+          </a:p>
+        </p:txBody>
+      </p:sp>
+      <p:sp>
+        <p:nvSpPr>
           <p:cNvPr id="11" name="Text 8"/>
           <p:cNvSpPr/>
           <p:nvPr/>
         </p:nvSpPr>
         <p:spPr>
           <a:xfrm>
-            <a:off x="4599432" y="1536192"/>
-            <a:ext cx="3337560" cy="365760"/>
-          </a:xfrm>
-          <a:prstGeom prst="rect">
-            <a:avLst/>
-          </a:prstGeom>
-          <a:noFill/>
-          <a:ln/>
-        </p:spPr>
-        <p:txBody>
-          <a:bodyPr wrap="square" rtlCol="0" anchor="ctr"/>
-          <a:lstStyle/>
-          <a:p>
-            <a:pPr indent="0" marL="0">
-              <a:buNone/>
-            </a:pPr>
-            <a:r>
-              <a:rPr lang="en-US" sz="1500" b="1" dirty="0">
-                <a:solidFill>
-                  <a:srgbClr val="2563EB"/>
-                </a:solidFill>
-                <a:latin typeface="Segoe UI" pitchFamily="34" charset="0"/>
-                <a:ea typeface="Segoe UI" pitchFamily="34" charset="-122"/>
-                <a:cs typeface="Segoe UI" pitchFamily="34" charset="-120"/>
-              </a:rPr>
-              <a:t>CI spike test</a:t>
-            </a:r>
-            <a:endParaRPr lang="en-US" sz="1500" dirty="0"/>
+            <a:off x="4983480" y="1920240"/>
+            <a:ext cx="3749040" cy="1463040"/>
+          </a:xfrm>
+          <a:prstGeom prst="rect">
+            <a:avLst/>
+          </a:prstGeom>
+          <a:noFill/>
+          <a:ln/>
+        </p:spPr>
+        <p:txBody>
+          <a:bodyPr wrap="square" rtlCol="0" anchor="ctr"/>
+          <a:lstStyle/>
+          <a:p>
+            <a:pPr indent="0" marL="0">
+              <a:buNone/>
+            </a:pPr>
+            <a:r>
+              <a:rPr lang="en-US" sz="1050" dirty="0">
+                <a:solidFill>
+                  <a:srgbClr val="1C2733"/>
+                </a:solidFill>
+                <a:latin typeface="Segoe UI" pitchFamily="34" charset="0"/>
+                <a:ea typeface="Segoe UI" pitchFamily="34" charset="-122"/>
+                <a:cs typeface="Segoe UI" pitchFamily="34" charset="-120"/>
+              </a:rPr>
+              <a:t>every 30 s: 100–1000 rows inserted, updated and deleted on a dedicated aux table — long transactions and garbage without touching business data.</a:t>
+            </a:r>
+            <a:endParaRPr lang="en-US" sz="1050" dirty="0"/>
           </a:p>
         </p:txBody>
       </p:sp>
@@ -9917,180 +10133,12 @@
         </p:nvSpPr>
         <p:spPr>
           <a:xfrm>
-            <a:off x="4599432" y="2011680"/>
-            <a:ext cx="3337560" cy="2743200"/>
+            <a:off x="502920" y="3703320"/>
+            <a:ext cx="4114800" cy="2148840"/>
           </a:xfrm>
           <a:prstGeom prst="roundRect">
             <a:avLst>
-              <a:gd name="adj" fmla="val 2000"/>
-            </a:avLst>
-          </a:prstGeom>
-          <a:solidFill>
-            <a:srgbClr val="1C2733"/>
-          </a:solidFill>
-          <a:ln/>
-        </p:spPr>
-      </p:sp>
-      <p:sp>
-        <p:nvSpPr>
-          <p:cNvPr id="13" name="Text 10"/>
-          <p:cNvSpPr/>
-          <p:nvPr/>
-        </p:nvSpPr>
-        <p:spPr>
-          <a:xfrm>
-            <a:off x="4736592" y="2103120"/>
-            <a:ext cx="3063240" cy="2560320"/>
-          </a:xfrm>
-          <a:prstGeom prst="rect">
-            <a:avLst/>
-          </a:prstGeom>
-          <a:noFill/>
-          <a:ln/>
-        </p:spPr>
-        <p:txBody>
-          <a:bodyPr wrap="square" rtlCol="0" anchor="t"/>
-          <a:lstStyle/>
-          <a:p>
-            <a:pPr indent="0" marL="0">
-              <a:buNone/>
-            </a:pPr>
-            <a:r>
-              <a:rPr lang="en-US" sz="1050" dirty="0">
-                <a:solidFill>
-                  <a:srgbClr val="E7ECF3"/>
-                </a:solidFill>
-                <a:latin typeface="Consolas" pitchFamily="34" charset="0"/>
-                <a:ea typeface="Consolas" pitchFamily="34" charset="-122"/>
-                <a:cs typeface="Consolas" pitchFamily="34" charset="-120"/>
-              </a:rPr>
-              <a:t>fb-loadgen --ui --api-only &amp;</a:t>
-            </a:r>
-            <a:endParaRPr lang="en-US" sz="1050" dirty="0"/>
-          </a:p>
-          <a:p>
-            <a:pPr indent="0" marL="0">
-              <a:buNone/>
-            </a:pPr>
-            <a:r>
-              <a:rPr lang="en-US" sz="1050" dirty="0">
-                <a:solidFill>
-                  <a:srgbClr val="E7ECF3"/>
-                </a:solidFill>
-                <a:latin typeface="Consolas" pitchFamily="34" charset="0"/>
-                <a:ea typeface="Consolas" pitchFamily="34" charset="-122"/>
-                <a:cs typeface="Consolas" pitchFamily="34" charset="-120"/>
-              </a:rPr>
-              <a:t>curl -X POST $BASE/api/schedules/</a:t>
-            </a:r>
-            <a:endParaRPr lang="en-US" sz="1050" dirty="0"/>
-          </a:p>
-          <a:p>
-            <a:pPr indent="0" marL="0">
-              <a:buNone/>
-            </a:pPr>
-            <a:r>
-              <a:rPr lang="en-US" sz="1050" dirty="0">
-                <a:solidFill>
-                  <a:srgbClr val="E7ECF3"/>
-                </a:solidFill>
-                <a:latin typeface="Consolas" pitchFamily="34" charset="0"/>
-                <a:ea typeface="Consolas" pitchFamily="34" charset="-122"/>
-                <a:cs typeface="Consolas" pitchFamily="34" charset="-120"/>
-              </a:rPr>
-              <a:t>  $SID/trigger        # fire now</a:t>
-            </a:r>
-            <a:endParaRPr lang="en-US" sz="1050" dirty="0"/>
-          </a:p>
-          <a:p>
-            <a:pPr indent="0" marL="0">
-              <a:buNone/>
-            </a:pPr>
-            <a:r>
-              <a:rPr lang="en-US" sz="1050" dirty="0">
-                <a:solidFill>
-                  <a:srgbClr val="E7ECF3"/>
-                </a:solidFill>
-                <a:latin typeface="Consolas" pitchFamily="34" charset="0"/>
-                <a:ea typeface="Consolas" pitchFamily="34" charset="-122"/>
-                <a:cs typeface="Consolas" pitchFamily="34" charset="-120"/>
-              </a:rPr>
-              <a:t>curl $BASE/api/runs/$RUN   # outcome</a:t>
-            </a:r>
-            <a:endParaRPr lang="en-US" sz="1050" dirty="0"/>
-          </a:p>
-          <a:p>
-            <a:pPr indent="0" marL="0">
-              <a:buNone/>
-            </a:pPr>
-            <a:r>
-              <a:rPr lang="en-US" sz="1050" dirty="0">
-                <a:solidFill>
-                  <a:srgbClr val="E7ECF3"/>
-                </a:solidFill>
-                <a:latin typeface="Consolas" pitchFamily="34" charset="0"/>
-                <a:ea typeface="Consolas" pitchFamily="34" charset="-122"/>
-                <a:cs typeface="Consolas" pitchFamily="34" charset="-120"/>
-              </a:rPr>
-              <a:t># fail the build on outcome != ok</a:t>
-            </a:r>
-            <a:endParaRPr lang="en-US" sz="1050" dirty="0"/>
-          </a:p>
-        </p:txBody>
-      </p:sp>
-      <p:sp>
-        <p:nvSpPr>
-          <p:cNvPr id="14" name="Text 11"/>
-          <p:cNvSpPr/>
-          <p:nvPr/>
-        </p:nvSpPr>
-        <p:spPr>
-          <a:xfrm>
-            <a:off x="4599432" y="4846320"/>
-            <a:ext cx="3337560" cy="640080"/>
-          </a:xfrm>
-          <a:prstGeom prst="rect">
-            <a:avLst/>
-          </a:prstGeom>
-          <a:noFill/>
-          <a:ln/>
-        </p:spPr>
-        <p:txBody>
-          <a:bodyPr wrap="square" rtlCol="0" anchor="ctr"/>
-          <a:lstStyle/>
-          <a:p>
-            <a:pPr indent="0" marL="0">
-              <a:buNone/>
-            </a:pPr>
-            <a:r>
-              <a:rPr lang="en-US" sz="1050" dirty="0">
-                <a:solidFill>
-                  <a:srgbClr val="5F6F83"/>
-                </a:solidFill>
-                <a:latin typeface="Segoe UI" pitchFamily="34" charset="0"/>
-                <a:ea typeface="Segoe UI" pitchFamily="34" charset="-122"/>
-                <a:cs typeface="Segoe UI" pitchFamily="34" charset="-120"/>
-              </a:rPr>
-              <a:t>Headless process in CI; build fails if the run fails</a:t>
-            </a:r>
-            <a:endParaRPr lang="en-US" sz="1050" dirty="0"/>
-          </a:p>
-        </p:txBody>
-      </p:sp>
-      <p:sp>
-        <p:nvSpPr>
-          <p:cNvPr id="15" name="Shape 12"/>
-          <p:cNvSpPr/>
-          <p:nvPr/>
-        </p:nvSpPr>
-        <p:spPr>
-          <a:xfrm>
-            <a:off x="8330184" y="1371600"/>
-            <a:ext cx="3703320" cy="4206240"/>
-          </a:xfrm>
-          <a:prstGeom prst="roundRect">
-            <a:avLst>
-              <a:gd name="adj" fmla="val 1481"/>
+              <a:gd name="adj" fmla="val 2553"/>
             </a:avLst>
           </a:prstGeom>
           <a:solidFill>
@@ -10106,30 +10154,30 @@
       </p:sp>
       <p:sp>
         <p:nvSpPr>
-          <p:cNvPr id="16" name="Text 13"/>
-          <p:cNvSpPr/>
-          <p:nvPr/>
-        </p:nvSpPr>
-        <p:spPr>
-          <a:xfrm>
-            <a:off x="8513064" y="1536192"/>
-            <a:ext cx="3337560" cy="365760"/>
-          </a:xfrm>
-          <a:prstGeom prst="rect">
-            <a:avLst/>
-          </a:prstGeom>
-          <a:noFill/>
-          <a:ln/>
-        </p:spPr>
-        <p:txBody>
-          <a:bodyPr wrap="square" rtlCol="0" anchor="ctr"/>
-          <a:lstStyle/>
-          <a:p>
-            <a:pPr indent="0" marL="0">
-              <a:buNone/>
-            </a:pPr>
-            <a:r>
-              <a:rPr lang="en-US" sz="1500" b="1" dirty="0">
+          <p:cNvPr id="13" name="Text 10"/>
+          <p:cNvSpPr/>
+          <p:nvPr/>
+        </p:nvSpPr>
+        <p:spPr>
+          <a:xfrm>
+            <a:off x="685800" y="3831336"/>
+            <a:ext cx="3749040" cy="365760"/>
+          </a:xfrm>
+          <a:prstGeom prst="rect">
+            <a:avLst/>
+          </a:prstGeom>
+          <a:noFill/>
+          <a:ln/>
+        </p:spPr>
+        <p:txBody>
+          <a:bodyPr wrap="square" rtlCol="0" anchor="ctr"/>
+          <a:lstStyle/>
+          <a:p>
+            <a:pPr indent="0" marL="0">
+              <a:buNone/>
+            </a:pPr>
+            <a:r>
+              <a:rPr lang="en-US" sz="1400" b="1" dirty="0">
                 <a:solidFill>
                   <a:srgbClr val="2563EB"/>
                 </a:solidFill>
@@ -10137,26 +10185,170 @@
                 <a:ea typeface="Segoe UI" pitchFamily="34" charset="-122"/>
                 <a:cs typeface="Segoe UI" pitchFamily="34" charset="-120"/>
               </a:rPr>
-              <a:t>Fleet health</a:t>
-            </a:r>
-            <a:endParaRPr lang="en-US" sz="1500" dirty="0"/>
-          </a:p>
-        </p:txBody>
-      </p:sp>
-      <p:sp>
-        <p:nvSpPr>
-          <p:cNvPr id="17" name="Shape 14"/>
-          <p:cNvSpPr/>
-          <p:nvPr/>
-        </p:nvSpPr>
-        <p:spPr>
-          <a:xfrm>
-            <a:off x="8513064" y="2011680"/>
-            <a:ext cx="3337560" cy="2743200"/>
+              <a:t>Operations log</a:t>
+            </a:r>
+            <a:endParaRPr lang="en-US" sz="1400" dirty="0"/>
+          </a:p>
+        </p:txBody>
+      </p:sp>
+      <p:sp>
+        <p:nvSpPr>
+          <p:cNvPr id="14" name="Text 11"/>
+          <p:cNvSpPr/>
+          <p:nvPr/>
+        </p:nvSpPr>
+        <p:spPr>
+          <a:xfrm>
+            <a:off x="685800" y="4251960"/>
+            <a:ext cx="3749040" cy="1463040"/>
+          </a:xfrm>
+          <a:prstGeom prst="rect">
+            <a:avLst/>
+          </a:prstGeom>
+          <a:noFill/>
+          <a:ln/>
+        </p:spPr>
+        <p:txBody>
+          <a:bodyPr wrap="square" rtlCol="0" anchor="ctr"/>
+          <a:lstStyle/>
+          <a:p>
+            <a:pPr indent="0" marL="0">
+              <a:buNone/>
+            </a:pPr>
+            <a:r>
+              <a:rPr lang="en-US" sz="1050" dirty="0">
+                <a:solidFill>
+                  <a:srgbClr val="1C2733"/>
+                </a:solidFill>
+                <a:latin typeface="Segoe UI" pitchFamily="34" charset="0"/>
+                <a:ea typeface="Segoe UI" pitchFamily="34" charset="-122"/>
+                <a:cs typeface="Segoe UI" pitchFamily="34" charset="-120"/>
+              </a:rPr>
+              <a:t>every transaction — number, parameters, completion, change volume — in the fb_repl_print output format; 50 MB rotation, downloadable via the log API.</a:t>
+            </a:r>
+            <a:endParaRPr lang="en-US" sz="1050" dirty="0"/>
+          </a:p>
+        </p:txBody>
+      </p:sp>
+      <p:sp>
+        <p:nvSpPr>
+          <p:cNvPr id="15" name="Shape 12"/>
+          <p:cNvSpPr/>
+          <p:nvPr/>
+        </p:nvSpPr>
+        <p:spPr>
+          <a:xfrm>
+            <a:off x="4800600" y="3703320"/>
+            <a:ext cx="4114800" cy="2148840"/>
           </a:xfrm>
           <a:prstGeom prst="roundRect">
             <a:avLst>
-              <a:gd name="adj" fmla="val 2000"/>
+              <a:gd name="adj" fmla="val 2553"/>
+            </a:avLst>
+          </a:prstGeom>
+          <a:solidFill>
+            <a:srgbClr val="FFFFFF"/>
+          </a:solidFill>
+          <a:ln w="12700">
+            <a:solidFill>
+              <a:srgbClr val="D8DFE8"/>
+            </a:solidFill>
+            <a:prstDash val="solid"/>
+          </a:ln>
+        </p:spPr>
+      </p:sp>
+      <p:sp>
+        <p:nvSpPr>
+          <p:cNvPr id="16" name="Text 13"/>
+          <p:cNvSpPr/>
+          <p:nvPr/>
+        </p:nvSpPr>
+        <p:spPr>
+          <a:xfrm>
+            <a:off x="4983480" y="3831336"/>
+            <a:ext cx="3749040" cy="365760"/>
+          </a:xfrm>
+          <a:prstGeom prst="rect">
+            <a:avLst/>
+          </a:prstGeom>
+          <a:noFill/>
+          <a:ln/>
+        </p:spPr>
+        <p:txBody>
+          <a:bodyPr wrap="square" rtlCol="0" anchor="ctr"/>
+          <a:lstStyle/>
+          <a:p>
+            <a:pPr indent="0" marL="0">
+              <a:buNone/>
+            </a:pPr>
+            <a:r>
+              <a:rPr lang="en-US" sz="1400" b="1" dirty="0">
+                <a:solidFill>
+                  <a:srgbClr val="2563EB"/>
+                </a:solidFill>
+                <a:latin typeface="Segoe UI" pitchFamily="34" charset="0"/>
+                <a:ea typeface="Segoe UI" pitchFamily="34" charset="-122"/>
+                <a:cs typeface="Segoe UI" pitchFamily="34" charset="-120"/>
+              </a:rPr>
+              <a:t>−plusddl (DDL churn)</a:t>
+            </a:r>
+            <a:endParaRPr lang="en-US" sz="1400" dirty="0"/>
+          </a:p>
+        </p:txBody>
+      </p:sp>
+      <p:sp>
+        <p:nvSpPr>
+          <p:cNvPr id="17" name="Text 14"/>
+          <p:cNvSpPr/>
+          <p:nvPr/>
+        </p:nvSpPr>
+        <p:spPr>
+          <a:xfrm>
+            <a:off x="4983480" y="4251960"/>
+            <a:ext cx="3749040" cy="1463040"/>
+          </a:xfrm>
+          <a:prstGeom prst="rect">
+            <a:avLst/>
+          </a:prstGeom>
+          <a:noFill/>
+          <a:ln/>
+        </p:spPr>
+        <p:txBody>
+          <a:bodyPr wrap="square" rtlCol="0" anchor="ctr"/>
+          <a:lstStyle/>
+          <a:p>
+            <a:pPr indent="0" marL="0">
+              <a:buNone/>
+            </a:pPr>
+            <a:r>
+              <a:rPr lang="en-US" sz="1050" dirty="0">
+                <a:solidFill>
+                  <a:srgbClr val="1C2733"/>
+                </a:solidFill>
+                <a:latin typeface="Segoe UI" pitchFamily="34" charset="0"/>
+                <a:ea typeface="Segoe UI" pitchFamily="34" charset="-122"/>
+                <a:cs typeface="Segoe UI" pitchFamily="34" charset="-120"/>
+              </a:rPr>
+              <a:t>ALTER/CREATE/DROP rounds with deliberately rolled-back DDL, verified against the catalog — metadata cache churn under load.</a:t>
+            </a:r>
+            <a:endParaRPr lang="en-US" sz="1050" dirty="0"/>
+          </a:p>
+        </p:txBody>
+      </p:sp>
+      <p:sp>
+        <p:nvSpPr>
+          <p:cNvPr id="18" name="Shape 15"/>
+          <p:cNvSpPr/>
+          <p:nvPr/>
+        </p:nvSpPr>
+        <p:spPr>
+          <a:xfrm>
+            <a:off x="9144000" y="1371600"/>
+            <a:ext cx="2560320" cy="3977640"/>
+          </a:xfrm>
+          <a:prstGeom prst="roundRect">
+            <a:avLst>
+              <a:gd name="adj" fmla="val 2143"/>
             </a:avLst>
           </a:prstGeom>
           <a:solidFill>
@@ -10167,14 +10359,14 @@
       </p:sp>
       <p:sp>
         <p:nvSpPr>
-          <p:cNvPr id="18" name="Text 15"/>
-          <p:cNvSpPr/>
-          <p:nvPr/>
-        </p:nvSpPr>
-        <p:spPr>
-          <a:xfrm>
-            <a:off x="8650224" y="2103120"/>
-            <a:ext cx="3063240" cy="2560320"/>
+          <p:cNvPr id="19" name="Text 16"/>
+          <p:cNvSpPr/>
+          <p:nvPr/>
+        </p:nvSpPr>
+        <p:spPr>
+          <a:xfrm>
+            <a:off x="9281160" y="1463040"/>
+            <a:ext cx="2286000" cy="3794760"/>
           </a:xfrm>
           <a:prstGeom prst="rect">
             <a:avLst/>
@@ -10198,7 +10390,7 @@
                 <a:ea typeface="Consolas" pitchFamily="34" charset="-122"/>
                 <a:cs typeface="Consolas" pitchFamily="34" charset="-120"/>
               </a:rPr>
-              <a:t>curl $BASE/api/fleet</a:t>
+              <a:t># everything on by default;</a:t>
             </a:r>
             <a:endParaRPr lang="en-US" sz="1050" dirty="0"/>
           </a:p>
@@ -10215,14 +10407,8 @@
                 <a:ea typeface="Consolas" pitchFamily="34" charset="-122"/>
                 <a:cs typeface="Consolas" pitchFamily="34" charset="-120"/>
               </a:rPr>
-              <a:t>curl $BASE/metrics | grep fbloadgen</a:t>
-            </a:r>
-            <a:endParaRPr lang="en-US" sz="1050" dirty="0"/>
-          </a:p>
-          <a:p>
-            <a:pPr indent="0" marL="0">
-              <a:buNone/>
-            </a:pPr>
+              <a:t># classic comparable score run:</a:t>
+            </a:r>
             <a:endParaRPr lang="en-US" sz="1050" dirty="0"/>
           </a:p>
           <a:p>
@@ -10238,8 +10424,14 @@
                 <a:ea typeface="Consolas" pitchFamily="34" charset="-122"/>
                 <a:cs typeface="Consolas" pitchFamily="34" charset="-120"/>
               </a:rPr>
-              <a:t># running, budget, TPS, errors,</a:t>
-            </a:r>
+              <a:t>fb-loadgen --extended-load=false</a:t>
+            </a:r>
+            <a:endParaRPr lang="en-US" sz="1050" dirty="0"/>
+          </a:p>
+          <a:p>
+            <a:pPr indent="0" marL="0">
+              <a:buNone/>
+            </a:pPr>
             <a:endParaRPr lang="en-US" sz="1050" dirty="0"/>
           </a:p>
           <a:p>
@@ -10255,32 +10447,10 @@
                 <a:ea typeface="Consolas" pitchFamily="34" charset="-122"/>
                 <a:cs typeface="Consolas" pitchFamily="34" charset="-120"/>
               </a:rPr>
-              <a:t># next scheduled fire — in Prometheus</a:t>
+              <a:t># pick the mix:</a:t>
             </a:r>
             <a:endParaRPr lang="en-US" sz="1050" dirty="0"/>
           </a:p>
-        </p:txBody>
-      </p:sp>
-      <p:sp>
-        <p:nvSpPr>
-          <p:cNvPr id="19" name="Text 16"/>
-          <p:cNvSpPr/>
-          <p:nvPr/>
-        </p:nvSpPr>
-        <p:spPr>
-          <a:xfrm>
-            <a:off x="8513064" y="4846320"/>
-            <a:ext cx="3337560" cy="640080"/>
-          </a:xfrm>
-          <a:prstGeom prst="rect">
-            <a:avLst/>
-          </a:prstGeom>
-          <a:noFill/>
-          <a:ln/>
-        </p:spPr>
-        <p:txBody>
-          <a:bodyPr wrap="square" rtlCol="0" anchor="ctr"/>
-          <a:lstStyle/>
           <a:p>
             <a:pPr indent="0" marL="0">
               <a:buNone/>
@@ -10288,28 +10458,106 @@
             <a:r>
               <a:rPr lang="en-US" sz="1050" dirty="0">
                 <a:solidFill>
-                  <a:srgbClr val="5F6F83"/>
-                </a:solidFill>
-                <a:latin typeface="Segoe UI" pitchFamily="34" charset="0"/>
-                <a:ea typeface="Segoe UI" pitchFamily="34" charset="-122"/>
-                <a:cs typeface="Segoe UI" pitchFamily="34" charset="-120"/>
-              </a:rPr>
-              <a:t>One scrape shows the whole fleet's load state</a:t>
+                  <a:srgbClr val="E7ECF3"/>
+                </a:solidFill>
+                <a:latin typeface="Consolas" pitchFamily="34" charset="0"/>
+                <a:ea typeface="Consolas" pitchFamily="34" charset="-122"/>
+                <a:cs typeface="Consolas" pitchFamily="34" charset="-120"/>
+              </a:rPr>
+              <a:t>--heavy-every 5  --bulk-every 30</a:t>
             </a:r>
             <a:endParaRPr lang="en-US" sz="1050" dirty="0"/>
           </a:p>
-        </p:txBody>
-      </p:sp>
-      <p:sp>
-        <p:nvSpPr>
-          <p:cNvPr id="20" name="Text 17"/>
-          <p:cNvSpPr/>
-          <p:nvPr/>
-        </p:nvSpPr>
-        <p:spPr>
-          <a:xfrm>
-            <a:off x="521208" y="5897880"/>
-            <a:ext cx="11155680" cy="365760"/>
+          <a:p>
+            <a:pPr indent="0" marL="0">
+              <a:buNone/>
+            </a:pPr>
+            <a:r>
+              <a:rPr lang="en-US" sz="1050" dirty="0">
+                <a:solidFill>
+                  <a:srgbClr val="E7ECF3"/>
+                </a:solidFill>
+                <a:latin typeface="Consolas" pitchFamily="34" charset="0"/>
+                <a:ea typeface="Consolas" pitchFamily="34" charset="-122"/>
+                <a:cs typeface="Consolas" pitchFamily="34" charset="-120"/>
+              </a:rPr>
+              <a:t>--ops-log --ops-log-level all</a:t>
+            </a:r>
+            <a:endParaRPr lang="en-US" sz="1050" dirty="0"/>
+          </a:p>
+          <a:p>
+            <a:pPr indent="0" marL="0">
+              <a:buNone/>
+            </a:pPr>
+            <a:r>
+              <a:rPr lang="en-US" sz="1050" dirty="0">
+                <a:solidFill>
+                  <a:srgbClr val="E7ECF3"/>
+                </a:solidFill>
+                <a:latin typeface="Consolas" pitchFamily="34" charset="0"/>
+                <a:ea typeface="Consolas" pitchFamily="34" charset="-122"/>
+                <a:cs typeface="Consolas" pitchFamily="34" charset="-120"/>
+              </a:rPr>
+              <a:t>--plusddl --ddl-every 60</a:t>
+            </a:r>
+            <a:endParaRPr lang="en-US" sz="1050" dirty="0"/>
+          </a:p>
+          <a:p>
+            <a:pPr indent="0" marL="0">
+              <a:buNone/>
+            </a:pPr>
+            <a:r>
+              <a:rPr lang="en-US" sz="1050" dirty="0">
+                <a:solidFill>
+                  <a:srgbClr val="E7ECF3"/>
+                </a:solidFill>
+                <a:latin typeface="Consolas" pitchFamily="34" charset="0"/>
+                <a:ea typeface="Consolas" pitchFamily="34" charset="-122"/>
+                <a:cs typeface="Consolas" pitchFamily="34" charset="-120"/>
+              </a:rPr>
+              <a:t>--tx-variants emul-safe</a:t>
+            </a:r>
+            <a:endParaRPr lang="en-US" sz="1050" dirty="0"/>
+          </a:p>
+        </p:txBody>
+      </p:sp>
+      <p:sp>
+        <p:nvSpPr>
+          <p:cNvPr id="20" name="Shape 17"/>
+          <p:cNvSpPr/>
+          <p:nvPr/>
+        </p:nvSpPr>
+        <p:spPr>
+          <a:xfrm>
+            <a:off x="502920" y="5897880"/>
+            <a:ext cx="11201400" cy="384048"/>
+          </a:xfrm>
+          <a:prstGeom prst="roundRect">
+            <a:avLst>
+              <a:gd name="adj" fmla="val 47619"/>
+            </a:avLst>
+          </a:prstGeom>
+          <a:solidFill>
+            <a:srgbClr val="EEF2F7"/>
+          </a:solidFill>
+          <a:ln w="12700">
+            <a:solidFill>
+              <a:srgbClr val="D8DFE8"/>
+            </a:solidFill>
+            <a:prstDash val="solid"/>
+          </a:ln>
+        </p:spPr>
+      </p:sp>
+      <p:sp>
+        <p:nvSpPr>
+          <p:cNvPr id="21" name="Text 18"/>
+          <p:cNvSpPr/>
+          <p:nvPr/>
+        </p:nvSpPr>
+        <p:spPr>
+          <a:xfrm>
+            <a:off x="502920" y="5897880"/>
+            <a:ext cx="11201400" cy="384048"/>
           </a:xfrm>
           <a:prstGeom prst="rect">
             <a:avLst/>
@@ -10325,17 +10573,17 @@
               <a:buNone/>
             </a:pPr>
             <a:r>
-              <a:rPr lang="en-US" sz="1300" dirty="0">
-                <a:solidFill>
-                  <a:srgbClr val="5F6F83"/>
-                </a:solidFill>
-                <a:latin typeface="Segoe UI" pitchFamily="34" charset="0"/>
-                <a:ea typeface="Segoe UI" pitchFamily="34" charset="-122"/>
-                <a:cs typeface="Segoe UI" pitchFamily="34" charset="-120"/>
-              </a:rPr>
-              <a:t>Same API drives all three — the UI, CI and cron are interchangeable clients.</a:t>
-            </a:r>
-            <a:endParaRPr lang="en-US" sz="1300" dirty="0"/>
+              <a:rPr lang="en-US" sz="1150" dirty="0">
+                <a:solidFill>
+                  <a:srgbClr val="1C2733"/>
+                </a:solidFill>
+                <a:latin typeface="Segoe UI" pitchFamily="34" charset="0"/>
+                <a:ea typeface="Segoe UI" pitchFamily="34" charset="-122"/>
+                <a:cs typeface="Segoe UI" pitchFamily="34" charset="-120"/>
+              </a:rPr>
+              <a:t>one umbrella switch: the mix changes the score by construction — classic preset for comparable benchmark runs</a:t>
+            </a:r>
+            <a:endParaRPr lang="en-US" sz="1150" dirty="0"/>
           </a:p>
         </p:txBody>
       </p:sp>
@@ -10404,7 +10652,7 @@
                 <a:ea typeface="Segoe UI" pitchFamily="34" charset="-122"/>
                 <a:cs typeface="Segoe UI" pitchFamily="34" charset="-120"/>
               </a:rPr>
-              <a:t>Where we are, where we go</a:t>
+              <a:t>Transaction variants — every operation draws its transaction</a:t>
             </a:r>
             <a:endParaRPr lang="en-US" sz="2700" dirty="0"/>
           </a:p>
@@ -10413,6 +10661,45 @@
       <p:sp>
         <p:nvSpPr>
           <p:cNvPr id="3" name="Text 1"/>
+          <p:cNvSpPr/>
+          <p:nvPr/>
+        </p:nvSpPr>
+        <p:spPr>
+          <a:xfrm>
+            <a:off x="521208" y="786384"/>
+            <a:ext cx="11185855" cy="310896"/>
+          </a:xfrm>
+          <a:prstGeom prst="rect">
+            <a:avLst/>
+          </a:prstGeom>
+          <a:noFill/>
+          <a:ln/>
+        </p:spPr>
+        <p:txBody>
+          <a:bodyPr wrap="square" rtlCol="0" anchor="ctr"/>
+          <a:lstStyle/>
+          <a:p>
+            <a:pPr indent="0" marL="0">
+              <a:buNone/>
+            </a:pPr>
+            <a:r>
+              <a:rPr lang="en-US" sz="1300" dirty="0">
+                <a:solidFill>
+                  <a:srgbClr val="5F6F83"/>
+                </a:solidFill>
+                <a:latin typeface="Segoe UI" pitchFamily="34" charset="0"/>
+                <a:ea typeface="Segoe UI" pitchFamily="34" charset="-122"/>
+                <a:cs typeface="Segoe UI" pitchFamily="34" charset="-120"/>
+              </a:rPr>
+              <a:t>At begin time each transaction draws isolation × read-only × wait resolution and a completion method — the database lives through everything a real application would do.</a:t>
+            </a:r>
+            <a:endParaRPr lang="en-US" sz="1300" dirty="0"/>
+          </a:p>
+        </p:txBody>
+      </p:sp>
+      <p:sp>
+        <p:nvSpPr>
+          <p:cNvPr id="4" name="Text 2"/>
           <p:cNvSpPr/>
           <p:nvPr/>
         </p:nvSpPr>
@@ -10465,18 +10752,18 @@
       </p:sp>
       <p:sp>
         <p:nvSpPr>
-          <p:cNvPr id="5" name="Shape 2"/>
+          <p:cNvPr id="6" name="Shape 3"/>
           <p:cNvSpPr/>
           <p:nvPr/>
         </p:nvSpPr>
         <p:spPr>
           <a:xfrm>
             <a:off x="502920" y="1371600"/>
-            <a:ext cx="5486400" cy="4297680"/>
+            <a:ext cx="3703320" cy="2057400"/>
           </a:xfrm>
           <a:prstGeom prst="roundRect">
             <a:avLst>
-              <a:gd name="adj" fmla="val 1277"/>
+              <a:gd name="adj" fmla="val 2667"/>
             </a:avLst>
           </a:prstGeom>
           <a:solidFill>
@@ -10492,72 +10779,69 @@
       </p:sp>
       <p:sp>
         <p:nvSpPr>
-          <p:cNvPr id="6" name="Text 3"/>
-          <p:cNvSpPr/>
-          <p:nvPr/>
-        </p:nvSpPr>
-        <p:spPr>
-          <a:xfrm>
-            <a:off x="731520" y="1554480"/>
-            <a:ext cx="5029200" cy="365760"/>
-          </a:xfrm>
-          <a:prstGeom prst="rect">
-            <a:avLst/>
-          </a:prstGeom>
-          <a:noFill/>
-          <a:ln/>
-        </p:spPr>
-        <p:txBody>
-          <a:bodyPr wrap="square" rtlCol="0" anchor="ctr"/>
-          <a:lstStyle/>
-          <a:p>
-            <a:pPr indent="0" marL="0">
-              <a:buNone/>
-            </a:pPr>
-            <a:r>
-              <a:rPr lang="en-US" sz="1500" b="1" dirty="0">
-                <a:solidFill>
-                  <a:srgbClr val="15803D"/>
-                </a:solidFill>
-                <a:latin typeface="Segoe UI" pitchFamily="34" charset="0"/>
-                <a:ea typeface="Segoe UI" pitchFamily="34" charset="-122"/>
-                <a:cs typeface="Segoe UI" pitchFamily="34" charset="-120"/>
-              </a:rPr>
-              <a:t>Shipped</a:t>
-            </a:r>
-            <a:endParaRPr lang="en-US" sz="1500" dirty="0"/>
-          </a:p>
-        </p:txBody>
-      </p:sp>
-      <p:sp>
-        <p:nvSpPr>
           <p:cNvPr id="7" name="Text 4"/>
           <p:cNvSpPr/>
           <p:nvPr/>
         </p:nvSpPr>
         <p:spPr>
           <a:xfrm>
-            <a:off x="731520" y="2011680"/>
-            <a:ext cx="5029200" cy="3291840"/>
-          </a:xfrm>
-          <a:prstGeom prst="rect">
-            <a:avLst/>
-          </a:prstGeom>
-          <a:noFill/>
-          <a:ln/>
-        </p:spPr>
-        <p:txBody>
-          <a:bodyPr wrap="square" rtlCol="0" anchor="ctr"/>
-          <a:lstStyle/>
-          <a:p>
-            <a:pPr indent="0" marL="0">
-              <a:lnSpc>
-                <a:spcPct val="140000"/>
-              </a:lnSpc>
-              <a:buNone/>
-            </a:pPr>
-            <a:r>
-              <a:rPr lang="en-US" sz="1350" dirty="0">
+            <a:off x="685800" y="1499616"/>
+            <a:ext cx="3337560" cy="502920"/>
+          </a:xfrm>
+          <a:prstGeom prst="rect">
+            <a:avLst/>
+          </a:prstGeom>
+          <a:noFill/>
+          <a:ln/>
+        </p:spPr>
+        <p:txBody>
+          <a:bodyPr wrap="square" rtlCol="0" anchor="ctr"/>
+          <a:lstStyle/>
+          <a:p>
+            <a:pPr indent="0" marL="0">
+              <a:buNone/>
+            </a:pPr>
+            <a:r>
+              <a:rPr lang="en-US" sz="1250" b="1" dirty="0">
+                <a:solidFill>
+                  <a:srgbClr val="2563EB"/>
+                </a:solidFill>
+                <a:latin typeface="Segoe UI" pitchFamily="34" charset="0"/>
+                <a:ea typeface="Segoe UI" pitchFamily="34" charset="-122"/>
+                <a:cs typeface="Segoe UI" pitchFamily="34" charset="-120"/>
+              </a:rPr>
+              <a:t>commit / rollback</a:t>
+            </a:r>
+            <a:endParaRPr lang="en-US" sz="1250" dirty="0"/>
+          </a:p>
+        </p:txBody>
+      </p:sp>
+      <p:sp>
+        <p:nvSpPr>
+          <p:cNvPr id="8" name="Text 5"/>
+          <p:cNvSpPr/>
+          <p:nvPr/>
+        </p:nvSpPr>
+        <p:spPr>
+          <a:xfrm>
+            <a:off x="685800" y="2029968"/>
+            <a:ext cx="3337560" cy="1325880"/>
+          </a:xfrm>
+          <a:prstGeom prst="rect">
+            <a:avLst/>
+          </a:prstGeom>
+          <a:noFill/>
+          <a:ln/>
+        </p:spPr>
+        <p:txBody>
+          <a:bodyPr wrap="square" rtlCol="0" anchor="ctr"/>
+          <a:lstStyle/>
+          <a:p>
+            <a:pPr indent="0" marL="0">
+              <a:buNone/>
+            </a:pPr>
+            <a:r>
+              <a:rPr lang="en-US" sz="1000" dirty="0">
                 <a:solidFill>
                   <a:srgbClr val="1C2733"/>
                 </a:solidFill>
@@ -10565,166 +10849,26 @@
                 <a:ea typeface="Segoe UI" pitchFamily="34" charset="-122"/>
                 <a:cs typeface="Segoe UI" pitchFamily="34" charset="-120"/>
               </a:rPr>
-              <a:t>Scheduled runs (once / interval / cron)</a:t>
-            </a:r>
-            <a:endParaRPr lang="en-US" sz="1350" dirty="0"/>
-          </a:p>
-          <a:p>
-            <a:pPr indent="0" marL="0">
-              <a:lnSpc>
-                <a:spcPct val="140000"/>
-              </a:lnSpc>
-              <a:buNone/>
-            </a:pPr>
-            <a:r>
-              <a:rPr lang="en-US" sz="1350" dirty="0">
-                <a:solidFill>
-                  <a:srgbClr val="1C2733"/>
-                </a:solidFill>
-                <a:latin typeface="Segoe UI" pitchFamily="34" charset="0"/>
-                <a:ea typeface="Segoe UI" pitchFamily="34" charset="-122"/>
-                <a:cs typeface="Segoe UI" pitchFamily="34" charset="-120"/>
-              </a:rPr>
-              <a:t>Run history with per-session outcomes</a:t>
-            </a:r>
-            <a:endParaRPr lang="en-US" sz="1350" dirty="0"/>
-          </a:p>
-          <a:p>
-            <a:pPr indent="0" marL="0">
-              <a:lnSpc>
-                <a:spcPct val="140000"/>
-              </a:lnSpc>
-              <a:buNone/>
-            </a:pPr>
-            <a:r>
-              <a:rPr lang="en-US" sz="1350" dirty="0">
-                <a:solidFill>
-                  <a:srgbClr val="1C2733"/>
-                </a:solidFill>
-                <a:latin typeface="Segoe UI" pitchFamily="34" charset="0"/>
-                <a:ea typeface="Segoe UI" pitchFamily="34" charset="-122"/>
-                <a:cs typeface="Segoe UI" pitchFamily="34" charset="-120"/>
-              </a:rPr>
-              <a:t>Webhooks + Prometheus /metrics</a:t>
-            </a:r>
-            <a:endParaRPr lang="en-US" sz="1350" dirty="0"/>
-          </a:p>
-          <a:p>
-            <a:pPr indent="0" marL="0">
-              <a:lnSpc>
-                <a:spcPct val="140000"/>
-              </a:lnSpc>
-              <a:buNone/>
-            </a:pPr>
-            <a:r>
-              <a:rPr lang="en-US" sz="1350" dirty="0">
-                <a:solidFill>
-                  <a:srgbClr val="1C2733"/>
-                </a:solidFill>
-                <a:latin typeface="Segoe UI" pitchFamily="34" charset="0"/>
-                <a:ea typeface="Segoe UI" pitchFamily="34" charset="-122"/>
-                <a:cs typeface="Segoe UI" pitchFamily="34" charset="-120"/>
-              </a:rPr>
-              <a:t>API hardening: auth, CORS, headless mode</a:t>
-            </a:r>
-            <a:endParaRPr lang="en-US" sz="1350" dirty="0"/>
-          </a:p>
-          <a:p>
-            <a:pPr indent="0" marL="0">
-              <a:lnSpc>
-                <a:spcPct val="140000"/>
-              </a:lnSpc>
-              <a:buNone/>
-            </a:pPr>
-            <a:r>
-              <a:rPr lang="en-US" sz="1350" dirty="0">
-                <a:solidFill>
-                  <a:srgbClr val="1C2733"/>
-                </a:solidFill>
-                <a:latin typeface="Segoe UI" pitchFamily="34" charset="0"/>
-                <a:ea typeface="Segoe UI" pitchFamily="34" charset="-122"/>
-                <a:cs typeface="Segoe UI" pitchFamily="34" charset="-120"/>
-              </a:rPr>
-              <a:t>OpenAPI 3.1 spec for the whole API</a:t>
-            </a:r>
-            <a:endParaRPr lang="en-US" sz="1350" dirty="0"/>
-          </a:p>
-          <a:p>
-            <a:pPr indent="0" marL="0">
-              <a:lnSpc>
-                <a:spcPct val="140000"/>
-              </a:lnSpc>
-              <a:buNone/>
-            </a:pPr>
-            <a:r>
-              <a:rPr lang="en-US" sz="1350" dirty="0">
-                <a:solidFill>
-                  <a:srgbClr val="1C2733"/>
-                </a:solidFill>
-                <a:latin typeface="Segoe UI" pitchFamily="34" charset="0"/>
-                <a:ea typeface="Segoe UI" pitchFamily="34" charset="-122"/>
-                <a:cs typeface="Segoe UI" pitchFamily="34" charset="-120"/>
-              </a:rPr>
-              <a:t>oltp-emul business-process mode + OLTPEMUL dashboard</a:t>
-            </a:r>
-            <a:endParaRPr lang="en-US" sz="1350" dirty="0"/>
-          </a:p>
-          <a:p>
-            <a:pPr indent="0" marL="0">
-              <a:lnSpc>
-                <a:spcPct val="140000"/>
-              </a:lnSpc>
-              <a:buNone/>
-            </a:pPr>
-            <a:r>
-              <a:rPr lang="en-US" sz="1350" dirty="0">
-                <a:solidFill>
-                  <a:srgbClr val="1C2733"/>
-                </a:solidFill>
-                <a:latin typeface="Segoe UI" pitchFamily="34" charset="0"/>
-                <a:ea typeface="Segoe UI" pitchFamily="34" charset="-122"/>
-                <a:cs typeface="Segoe UI" pitchFamily="34" charset="-120"/>
-              </a:rPr>
-              <a:t>CI (vet + race + 3 OS) and multi-platform releases</a:t>
-            </a:r>
-            <a:endParaRPr lang="en-US" sz="1350" dirty="0"/>
-          </a:p>
-          <a:p>
-            <a:pPr indent="0" marL="0">
-              <a:lnSpc>
-                <a:spcPct val="140000"/>
-              </a:lnSpc>
-              <a:buNone/>
-            </a:pPr>
-            <a:r>
-              <a:rPr lang="en-US" sz="1350" dirty="0">
-                <a:solidFill>
-                  <a:srgbClr val="1C2733"/>
-                </a:solidFill>
-                <a:latin typeface="Segoe UI" pitchFamily="34" charset="0"/>
-                <a:ea typeface="Segoe UI" pitchFamily="34" charset="-122"/>
-                <a:cs typeface="Segoe UI" pitchFamily="34" charset="-120"/>
-              </a:rPr>
-              <a:t>IBSurgeon driver fork under the hood</a:t>
-            </a:r>
-            <a:endParaRPr lang="en-US" sz="1350" dirty="0"/>
-          </a:p>
-        </p:txBody>
-      </p:sp>
-      <p:sp>
-        <p:nvSpPr>
-          <p:cNvPr id="8" name="Shape 5"/>
-          <p:cNvSpPr/>
-          <p:nvPr/>
-        </p:nvSpPr>
-        <p:spPr>
-          <a:xfrm>
-            <a:off x="6217920" y="1371600"/>
-            <a:ext cx="5486400" cy="4297680"/>
+              <a:t>the everyday completions, weighted by config</a:t>
+            </a:r>
+            <a:endParaRPr lang="en-US" sz="1000" dirty="0"/>
+          </a:p>
+        </p:txBody>
+      </p:sp>
+      <p:sp>
+        <p:nvSpPr>
+          <p:cNvPr id="9" name="Shape 6"/>
+          <p:cNvSpPr/>
+          <p:nvPr/>
+        </p:nvSpPr>
+        <p:spPr>
+          <a:xfrm>
+            <a:off x="4416552" y="1371600"/>
+            <a:ext cx="3703320" cy="2057400"/>
           </a:xfrm>
           <a:prstGeom prst="roundRect">
             <a:avLst>
-              <a:gd name="adj" fmla="val 1277"/>
+              <a:gd name="adj" fmla="val 2667"/>
             </a:avLst>
           </a:prstGeom>
           <a:solidFill>
@@ -10740,30 +10884,30 @@
       </p:sp>
       <p:sp>
         <p:nvSpPr>
-          <p:cNvPr id="9" name="Text 6"/>
-          <p:cNvSpPr/>
-          <p:nvPr/>
-        </p:nvSpPr>
-        <p:spPr>
-          <a:xfrm>
-            <a:off x="6446520" y="1554480"/>
-            <a:ext cx="5029200" cy="365760"/>
-          </a:xfrm>
-          <a:prstGeom prst="rect">
-            <a:avLst/>
-          </a:prstGeom>
-          <a:noFill/>
-          <a:ln/>
-        </p:spPr>
-        <p:txBody>
-          <a:bodyPr wrap="square" rtlCol="0" anchor="ctr"/>
-          <a:lstStyle/>
-          <a:p>
-            <a:pPr indent="0" marL="0">
-              <a:buNone/>
-            </a:pPr>
-            <a:r>
-              <a:rPr lang="en-US" sz="1500" b="1" dirty="0">
+          <p:cNvPr id="10" name="Text 7"/>
+          <p:cNvSpPr/>
+          <p:nvPr/>
+        </p:nvSpPr>
+        <p:spPr>
+          <a:xfrm>
+            <a:off x="4599432" y="1499616"/>
+            <a:ext cx="3337560" cy="502920"/>
+          </a:xfrm>
+          <a:prstGeom prst="rect">
+            <a:avLst/>
+          </a:prstGeom>
+          <a:noFill/>
+          <a:ln/>
+        </p:spPr>
+        <p:txBody>
+          <a:bodyPr wrap="square" rtlCol="0" anchor="ctr"/>
+          <a:lstStyle/>
+          <a:p>
+            <a:pPr indent="0" marL="0">
+              <a:buNone/>
+            </a:pPr>
+            <a:r>
+              <a:rPr lang="en-US" sz="1250" b="1" dirty="0">
                 <a:solidFill>
                   <a:srgbClr val="2563EB"/>
                 </a:solidFill>
@@ -10771,41 +10915,38 @@
                 <a:ea typeface="Segoe UI" pitchFamily="34" charset="-122"/>
                 <a:cs typeface="Segoe UI" pitchFamily="34" charset="-120"/>
               </a:rPr>
-              <a:t>Next</a:t>
-            </a:r>
-            <a:endParaRPr lang="en-US" sz="1500" dirty="0"/>
-          </a:p>
-        </p:txBody>
-      </p:sp>
-      <p:sp>
-        <p:nvSpPr>
-          <p:cNvPr id="10" name="Text 7"/>
-          <p:cNvSpPr/>
-          <p:nvPr/>
-        </p:nvSpPr>
-        <p:spPr>
-          <a:xfrm>
-            <a:off x="6446520" y="2011680"/>
-            <a:ext cx="5029200" cy="3291840"/>
-          </a:xfrm>
-          <a:prstGeom prst="rect">
-            <a:avLst/>
-          </a:prstGeom>
-          <a:noFill/>
-          <a:ln/>
-        </p:spPr>
-        <p:txBody>
-          <a:bodyPr wrap="square" rtlCol="0" anchor="ctr"/>
-          <a:lstStyle/>
-          <a:p>
-            <a:pPr indent="0" marL="0">
-              <a:lnSpc>
-                <a:spcPct val="140000"/>
-              </a:lnSpc>
-              <a:buNone/>
-            </a:pPr>
-            <a:r>
-              <a:rPr lang="en-US" sz="1350" dirty="0">
+              <a:t>COMMIT/ROLLBACK RETAINING</a:t>
+            </a:r>
+            <a:endParaRPr lang="en-US" sz="1250" dirty="0"/>
+          </a:p>
+        </p:txBody>
+      </p:sp>
+      <p:sp>
+        <p:nvSpPr>
+          <p:cNvPr id="11" name="Text 8"/>
+          <p:cNvSpPr/>
+          <p:nvPr/>
+        </p:nvSpPr>
+        <p:spPr>
+          <a:xfrm>
+            <a:off x="4599432" y="2029968"/>
+            <a:ext cx="3337560" cy="1325880"/>
+          </a:xfrm>
+          <a:prstGeom prst="rect">
+            <a:avLst/>
+          </a:prstGeom>
+          <a:noFill/>
+          <a:ln/>
+        </p:spPr>
+        <p:txBody>
+          <a:bodyPr wrap="square" rtlCol="0" anchor="ctr"/>
+          <a:lstStyle/>
+          <a:p>
+            <a:pPr indent="0" marL="0">
+              <a:buNone/>
+            </a:pPr>
+            <a:r>
+              <a:rPr lang="en-US" sz="1000" dirty="0">
                 <a:solidFill>
                   <a:srgbClr val="1C2733"/>
                 </a:solidFill>
@@ -10813,19 +10954,104 @@
                 <a:ea typeface="Segoe UI" pitchFamily="34" charset="-122"/>
                 <a:cs typeface="Segoe UI" pitchFamily="34" charset="-120"/>
               </a:rPr>
-              <a:t>Secure credential storage (no plaintext settings)</a:t>
-            </a:r>
-            <a:endParaRPr lang="en-US" sz="1350" dirty="0"/>
-          </a:p>
-          <a:p>
-            <a:pPr indent="0" marL="0">
-              <a:lnSpc>
-                <a:spcPct val="140000"/>
-              </a:lnSpc>
-              <a:buNone/>
-            </a:pPr>
-            <a:r>
-              <a:rPr lang="en-US" sz="1350" dirty="0">
+              <a:t>keeps lock interest after the commit — the retained context holds row locks until the chain ends (capped)</a:t>
+            </a:r>
+            <a:endParaRPr lang="en-US" sz="1000" dirty="0"/>
+          </a:p>
+        </p:txBody>
+      </p:sp>
+      <p:sp>
+        <p:nvSpPr>
+          <p:cNvPr id="12" name="Shape 9"/>
+          <p:cNvSpPr/>
+          <p:nvPr/>
+        </p:nvSpPr>
+        <p:spPr>
+          <a:xfrm>
+            <a:off x="8330184" y="1371600"/>
+            <a:ext cx="3703320" cy="2057400"/>
+          </a:xfrm>
+          <a:prstGeom prst="roundRect">
+            <a:avLst>
+              <a:gd name="adj" fmla="val 2667"/>
+            </a:avLst>
+          </a:prstGeom>
+          <a:solidFill>
+            <a:srgbClr val="FFFFFF"/>
+          </a:solidFill>
+          <a:ln w="12700">
+            <a:solidFill>
+              <a:srgbClr val="D8DFE8"/>
+            </a:solidFill>
+            <a:prstDash val="solid"/>
+          </a:ln>
+        </p:spPr>
+      </p:sp>
+      <p:sp>
+        <p:nvSpPr>
+          <p:cNvPr id="13" name="Text 10"/>
+          <p:cNvSpPr/>
+          <p:nvPr/>
+        </p:nvSpPr>
+        <p:spPr>
+          <a:xfrm>
+            <a:off x="8513064" y="1499616"/>
+            <a:ext cx="3337560" cy="502920"/>
+          </a:xfrm>
+          <a:prstGeom prst="rect">
+            <a:avLst/>
+          </a:prstGeom>
+          <a:noFill/>
+          <a:ln/>
+        </p:spPr>
+        <p:txBody>
+          <a:bodyPr wrap="square" rtlCol="0" anchor="ctr"/>
+          <a:lstStyle/>
+          <a:p>
+            <a:pPr indent="0" marL="0">
+              <a:buNone/>
+            </a:pPr>
+            <a:r>
+              <a:rPr lang="en-US" sz="1250" b="1" dirty="0">
+                <a:solidFill>
+                  <a:srgbClr val="2563EB"/>
+                </a:solidFill>
+                <a:latin typeface="Segoe UI" pitchFamily="34" charset="0"/>
+                <a:ea typeface="Segoe UI" pitchFamily="34" charset="-122"/>
+                <a:cs typeface="Segoe UI" pitchFamily="34" charset="-120"/>
+              </a:rPr>
+              <a:t>engine-side 2PC</a:t>
+            </a:r>
+            <a:endParaRPr lang="en-US" sz="1250" dirty="0"/>
+          </a:p>
+        </p:txBody>
+      </p:sp>
+      <p:sp>
+        <p:nvSpPr>
+          <p:cNvPr id="14" name="Text 11"/>
+          <p:cNvSpPr/>
+          <p:nvPr/>
+        </p:nvSpPr>
+        <p:spPr>
+          <a:xfrm>
+            <a:off x="8513064" y="2029968"/>
+            <a:ext cx="3337560" cy="1325880"/>
+          </a:xfrm>
+          <a:prstGeom prst="rect">
+            <a:avLst/>
+          </a:prstGeom>
+          <a:noFill/>
+          <a:ln/>
+        </p:spPr>
+        <p:txBody>
+          <a:bodyPr wrap="square" rtlCol="0" anchor="ctr"/>
+          <a:lstStyle/>
+          <a:p>
+            <a:pPr indent="0" marL="0">
+              <a:buNone/>
+            </a:pPr>
+            <a:r>
+              <a:rPr lang="en-US" sz="1000" dirty="0">
                 <a:solidFill>
                   <a:srgbClr val="1C2733"/>
                 </a:solidFill>
@@ -10833,19 +11059,104 @@
                 <a:ea typeface="Segoe UI" pitchFamily="34" charset="-122"/>
                 <a:cs typeface="Segoe UI" pitchFamily="34" charset="-120"/>
               </a:rPr>
-              <a:t>Schedule chains (run A, then B)</a:t>
-            </a:r>
-            <a:endParaRPr lang="en-US" sz="1350" dirty="0"/>
-          </a:p>
-          <a:p>
-            <a:pPr indent="0" marL="0">
-              <a:lnSpc>
-                <a:spcPct val="140000"/>
-              </a:lnSpc>
-              <a:buNone/>
-            </a:pPr>
-            <a:r>
-              <a:rPr lang="en-US" sz="1350" dirty="0">
+              <a:t>aux database enlisted via EXECUTE STATEMENT … WITH COMMON TRANSACTION; the commit runs as a real two-phase commit</a:t>
+            </a:r>
+            <a:endParaRPr lang="en-US" sz="1000" dirty="0"/>
+          </a:p>
+        </p:txBody>
+      </p:sp>
+      <p:sp>
+        <p:nvSpPr>
+          <p:cNvPr id="15" name="Shape 12"/>
+          <p:cNvSpPr/>
+          <p:nvPr/>
+        </p:nvSpPr>
+        <p:spPr>
+          <a:xfrm>
+            <a:off x="502920" y="3611880"/>
+            <a:ext cx="3703320" cy="2057400"/>
+          </a:xfrm>
+          <a:prstGeom prst="roundRect">
+            <a:avLst>
+              <a:gd name="adj" fmla="val 2667"/>
+            </a:avLst>
+          </a:prstGeom>
+          <a:solidFill>
+            <a:srgbClr val="FFFFFF"/>
+          </a:solidFill>
+          <a:ln w="12700">
+            <a:solidFill>
+              <a:srgbClr val="D8DFE8"/>
+            </a:solidFill>
+            <a:prstDash val="solid"/>
+          </a:ln>
+        </p:spPr>
+      </p:sp>
+      <p:sp>
+        <p:nvSpPr>
+          <p:cNvPr id="16" name="Text 13"/>
+          <p:cNvSpPr/>
+          <p:nvPr/>
+        </p:nvSpPr>
+        <p:spPr>
+          <a:xfrm>
+            <a:off x="685800" y="3739896"/>
+            <a:ext cx="3337560" cy="502920"/>
+          </a:xfrm>
+          <a:prstGeom prst="rect">
+            <a:avLst/>
+          </a:prstGeom>
+          <a:noFill/>
+          <a:ln/>
+        </p:spPr>
+        <p:txBody>
+          <a:bodyPr wrap="square" rtlCol="0" anchor="ctr"/>
+          <a:lstStyle/>
+          <a:p>
+            <a:pPr indent="0" marL="0">
+              <a:buNone/>
+            </a:pPr>
+            <a:r>
+              <a:rPr lang="en-US" sz="1250" b="1" dirty="0">
+                <a:solidFill>
+                  <a:srgbClr val="2563EB"/>
+                </a:solidFill>
+                <a:latin typeface="Segoe UI" pitchFamily="34" charset="0"/>
+                <a:ea typeface="Segoe UI" pitchFamily="34" charset="-122"/>
+                <a:cs typeface="Segoe UI" pitchFamily="34" charset="-120"/>
+              </a:rPr>
+              <a:t>limbo (prepare-then-die)</a:t>
+            </a:r>
+            <a:endParaRPr lang="en-US" sz="1250" dirty="0"/>
+          </a:p>
+        </p:txBody>
+      </p:sp>
+      <p:sp>
+        <p:nvSpPr>
+          <p:cNvPr id="17" name="Text 14"/>
+          <p:cNvSpPr/>
+          <p:nvPr/>
+        </p:nvSpPr>
+        <p:spPr>
+          <a:xfrm>
+            <a:off x="685800" y="4270248"/>
+            <a:ext cx="3337560" cy="1325880"/>
+          </a:xfrm>
+          <a:prstGeom prst="rect">
+            <a:avLst/>
+          </a:prstGeom>
+          <a:noFill/>
+          <a:ln/>
+        </p:spPr>
+        <p:txBody>
+          <a:bodyPr wrap="square" rtlCol="0" anchor="ctr"/>
+          <a:lstStyle/>
+          <a:p>
+            <a:pPr indent="0" marL="0">
+              <a:buNone/>
+            </a:pPr>
+            <a:r>
+              <a:rPr lang="en-US" sz="1000" dirty="0">
                 <a:solidFill>
                   <a:srgbClr val="1C2733"/>
                 </a:solidFill>
@@ -10853,22 +11164,259 @@
                 <a:ea typeface="Segoe UI" pitchFamily="34" charset="-122"/>
                 <a:cs typeface="Segoe UI" pitchFamily="34" charset="-120"/>
               </a:rPr>
-              <a:t>Your use case here — tell us what you need</a:t>
-            </a:r>
-            <a:endParaRPr lang="en-US" sz="1350" dirty="0"/>
-          </a:p>
-        </p:txBody>
-      </p:sp>
-      <p:sp>
-        <p:nvSpPr>
-          <p:cNvPr id="11" name="Text 8"/>
-          <p:cNvSpPr/>
-          <p:nvPr/>
-        </p:nvSpPr>
-        <p:spPr>
-          <a:xfrm>
-            <a:off x="521208" y="5943600"/>
-            <a:ext cx="11155680" cy="365760"/>
+              <a:t>prepare, then the socket dies — a recovery sidecar polls the limbo list every 2 s and resolves commit / rollback / 2PC-recovery via the Services API</a:t>
+            </a:r>
+            <a:endParaRPr lang="en-US" sz="1000" dirty="0"/>
+          </a:p>
+        </p:txBody>
+      </p:sp>
+      <p:sp>
+        <p:nvSpPr>
+          <p:cNvPr id="18" name="Shape 15"/>
+          <p:cNvSpPr/>
+          <p:nvPr/>
+        </p:nvSpPr>
+        <p:spPr>
+          <a:xfrm>
+            <a:off x="4416552" y="3611880"/>
+            <a:ext cx="3703320" cy="2057400"/>
+          </a:xfrm>
+          <a:prstGeom prst="roundRect">
+            <a:avLst>
+              <a:gd name="adj" fmla="val 2667"/>
+            </a:avLst>
+          </a:prstGeom>
+          <a:solidFill>
+            <a:srgbClr val="FFFFFF"/>
+          </a:solidFill>
+          <a:ln w="12700">
+            <a:solidFill>
+              <a:srgbClr val="D8DFE8"/>
+            </a:solidFill>
+            <a:prstDash val="solid"/>
+          </a:ln>
+        </p:spPr>
+      </p:sp>
+      <p:sp>
+        <p:nvSpPr>
+          <p:cNvPr id="19" name="Text 16"/>
+          <p:cNvSpPr/>
+          <p:nvPr/>
+        </p:nvSpPr>
+        <p:spPr>
+          <a:xfrm>
+            <a:off x="4599432" y="3739896"/>
+            <a:ext cx="3337560" cy="502920"/>
+          </a:xfrm>
+          <a:prstGeom prst="rect">
+            <a:avLst/>
+          </a:prstGeom>
+          <a:noFill/>
+          <a:ln/>
+        </p:spPr>
+        <p:txBody>
+          <a:bodyPr wrap="square" rtlCol="0" anchor="ctr"/>
+          <a:lstStyle/>
+          <a:p>
+            <a:pPr indent="0" marL="0">
+              <a:buNone/>
+            </a:pPr>
+            <a:r>
+              <a:rPr lang="en-US" sz="1250" b="1" dirty="0">
+                <a:solidFill>
+                  <a:srgbClr val="2563EB"/>
+                </a:solidFill>
+                <a:latin typeface="Segoe UI" pitchFamily="34" charset="0"/>
+                <a:ea typeface="Segoe UI" pitchFamily="34" charset="-122"/>
+                <a:cs typeface="Segoe UI" pitchFamily="34" charset="-120"/>
+              </a:rPr>
+              <a:t>planned connection drop</a:t>
+            </a:r>
+            <a:endParaRPr lang="en-US" sz="1250" dirty="0"/>
+          </a:p>
+        </p:txBody>
+      </p:sp>
+      <p:sp>
+        <p:nvSpPr>
+          <p:cNvPr id="20" name="Text 17"/>
+          <p:cNvSpPr/>
+          <p:nvPr/>
+        </p:nvSpPr>
+        <p:spPr>
+          <a:xfrm>
+            <a:off x="4599432" y="4270248"/>
+            <a:ext cx="3337560" cy="1325880"/>
+          </a:xfrm>
+          <a:prstGeom prst="rect">
+            <a:avLst/>
+          </a:prstGeom>
+          <a:noFill/>
+          <a:ln/>
+        </p:spPr>
+        <p:txBody>
+          <a:bodyPr wrap="square" rtlCol="0" anchor="ctr"/>
+          <a:lstStyle/>
+          <a:p>
+            <a:pPr indent="0" marL="0">
+              <a:buNone/>
+            </a:pPr>
+            <a:r>
+              <a:rPr lang="en-US" sz="1000" dirty="0">
+                <a:solidFill>
+                  <a:srgbClr val="1C2733"/>
+                </a:solidFill>
+                <a:latin typeface="Segoe UI" pitchFamily="34" charset="0"/>
+                <a:ea typeface="Segoe UI" pitchFamily="34" charset="-122"/>
+                <a:cs typeface="Segoe UI" pitchFamily="34" charset="-120"/>
+              </a:rPr>
+              <a:t>the socket is killed on purpose; the worker rebuilds its pool in place and continues</a:t>
+            </a:r>
+            <a:endParaRPr lang="en-US" sz="1000" dirty="0"/>
+          </a:p>
+        </p:txBody>
+      </p:sp>
+      <p:sp>
+        <p:nvSpPr>
+          <p:cNvPr id="21" name="Shape 18"/>
+          <p:cNvSpPr/>
+          <p:nvPr/>
+        </p:nvSpPr>
+        <p:spPr>
+          <a:xfrm>
+            <a:off x="8330184" y="3611880"/>
+            <a:ext cx="3703320" cy="2057400"/>
+          </a:xfrm>
+          <a:prstGeom prst="roundRect">
+            <a:avLst>
+              <a:gd name="adj" fmla="val 2667"/>
+            </a:avLst>
+          </a:prstGeom>
+          <a:solidFill>
+            <a:srgbClr val="FFFFFF"/>
+          </a:solidFill>
+          <a:ln w="12700">
+            <a:solidFill>
+              <a:srgbClr val="D8DFE8"/>
+            </a:solidFill>
+            <a:prstDash val="solid"/>
+          </a:ln>
+        </p:spPr>
+      </p:sp>
+      <p:sp>
+        <p:nvSpPr>
+          <p:cNvPr id="22" name="Text 19"/>
+          <p:cNvSpPr/>
+          <p:nvPr/>
+        </p:nvSpPr>
+        <p:spPr>
+          <a:xfrm>
+            <a:off x="8513064" y="3739896"/>
+            <a:ext cx="3337560" cy="502920"/>
+          </a:xfrm>
+          <a:prstGeom prst="rect">
+            <a:avLst/>
+          </a:prstGeom>
+          <a:noFill/>
+          <a:ln/>
+        </p:spPr>
+        <p:txBody>
+          <a:bodyPr wrap="square" rtlCol="0" anchor="ctr"/>
+          <a:lstStyle/>
+          <a:p>
+            <a:pPr indent="0" marL="0">
+              <a:buNone/>
+            </a:pPr>
+            <a:r>
+              <a:rPr lang="en-US" sz="1250" b="1" dirty="0">
+                <a:solidFill>
+                  <a:srgbClr val="15803D"/>
+                </a:solidFill>
+                <a:latin typeface="Segoe UI" pitchFamily="34" charset="0"/>
+                <a:ea typeface="Segoe UI" pitchFamily="34" charset="-122"/>
+                <a:cs typeface="Segoe UI" pitchFamily="34" charset="-120"/>
+              </a:rPr>
+              <a:t>--no-limbo</a:t>
+            </a:r>
+            <a:endParaRPr lang="en-US" sz="1250" dirty="0"/>
+          </a:p>
+        </p:txBody>
+      </p:sp>
+      <p:sp>
+        <p:nvSpPr>
+          <p:cNvPr id="23" name="Text 20"/>
+          <p:cNvSpPr/>
+          <p:nvPr/>
+        </p:nvSpPr>
+        <p:spPr>
+          <a:xfrm>
+            <a:off x="8513064" y="4270248"/>
+            <a:ext cx="3337560" cy="1325880"/>
+          </a:xfrm>
+          <a:prstGeom prst="rect">
+            <a:avLst/>
+          </a:prstGeom>
+          <a:noFill/>
+          <a:ln/>
+        </p:spPr>
+        <p:txBody>
+          <a:bodyPr wrap="square" rtlCol="0" anchor="ctr"/>
+          <a:lstStyle/>
+          <a:p>
+            <a:pPr indent="0" marL="0">
+              <a:buNone/>
+            </a:pPr>
+            <a:r>
+              <a:rPr lang="en-US" sz="1000" dirty="0">
+                <a:solidFill>
+                  <a:srgbClr val="1C2733"/>
+                </a:solidFill>
+                <a:latin typeface="Segoe UI" pitchFamily="34" charset="0"/>
+                <a:ea typeface="Segoe UI" pitchFamily="34" charset="-122"/>
+                <a:cs typeface="Segoe UI" pitchFamily="34" charset="-120"/>
+              </a:rPr>
+              <a:t>the same mix with limbo generation switched off — for targets that must stay free of prepared transactions (flag, API parameter, UI checkbox)</a:t>
+            </a:r>
+            <a:endParaRPr lang="en-US" sz="1000" dirty="0"/>
+          </a:p>
+        </p:txBody>
+      </p:sp>
+      <p:sp>
+        <p:nvSpPr>
+          <p:cNvPr id="24" name="Shape 21"/>
+          <p:cNvSpPr/>
+          <p:nvPr/>
+        </p:nvSpPr>
+        <p:spPr>
+          <a:xfrm>
+            <a:off x="502920" y="5897880"/>
+            <a:ext cx="11201400" cy="384048"/>
+          </a:xfrm>
+          <a:prstGeom prst="roundRect">
+            <a:avLst>
+              <a:gd name="adj" fmla="val 47619"/>
+            </a:avLst>
+          </a:prstGeom>
+          <a:solidFill>
+            <a:srgbClr val="EEF2F7"/>
+          </a:solidFill>
+          <a:ln w="12700">
+            <a:solidFill>
+              <a:srgbClr val="D8DFE8"/>
+            </a:solidFill>
+            <a:prstDash val="solid"/>
+          </a:ln>
+        </p:spPr>
+      </p:sp>
+      <p:sp>
+        <p:nvSpPr>
+          <p:cNvPr id="25" name="Text 22"/>
+          <p:cNvSpPr/>
+          <p:nvPr/>
+        </p:nvSpPr>
+        <p:spPr>
+          <a:xfrm>
+            <a:off x="502920" y="5897880"/>
+            <a:ext cx="11201400" cy="384048"/>
           </a:xfrm>
           <a:prstGeom prst="rect">
             <a:avLst/>
@@ -10884,7 +11432,7 @@
               <a:buNone/>
             </a:pPr>
             <a:r>
-              <a:rPr lang="en-US" sz="1300" b="1" dirty="0">
+              <a:rPr lang="en-US" sz="1150" dirty="0">
                 <a:solidFill>
                   <a:srgbClr val="1C2733"/>
                 </a:solidFill>
@@ -10892,51 +11440,9 @@
                 <a:ea typeface="Segoe UI" pitchFamily="34" charset="-122"/>
                 <a:cs typeface="Segoe UI" pitchFamily="34" charset="-120"/>
               </a:rPr>
-              <a:t>Docs: </a:t>
-            </a:r>
-            <a:pPr algn="ctr" indent="0" marL="0">
-              <a:buNone/>
-            </a:pPr>
-            <a:r>
-              <a:rPr lang="en-US" sz="1300" dirty="0">
-                <a:solidFill>
-                  <a:srgbClr val="2563EB"/>
-                </a:solidFill>
-                <a:latin typeface="Segoe UI" pitchFamily="34" charset="0"/>
-                <a:ea typeface="Segoe UI" pitchFamily="34" charset="-122"/>
-                <a:cs typeface="Segoe UI" pitchFamily="34" charset="-120"/>
-              </a:rPr>
-              <a:t>README.md · API.md · IMPROVEMENTS.md</a:t>
-            </a:r>
-            <a:pPr algn="ctr" indent="0" marL="0">
-              <a:buNone/>
-            </a:pPr>
-            <a:r>
-              <a:rPr lang="en-US" sz="1300" b="1" dirty="0">
-                <a:solidFill>
-                  <a:srgbClr val="1C2733"/>
-                </a:solidFill>
-                <a:latin typeface="Segoe UI" pitchFamily="34" charset="0"/>
-                <a:ea typeface="Segoe UI" pitchFamily="34" charset="-122"/>
-                <a:cs typeface="Segoe UI" pitchFamily="34" charset="-120"/>
-              </a:rPr>
-              <a:t>      Start:  </a:t>
-            </a:r>
-            <a:pPr algn="ctr" indent="0" marL="0">
-              <a:buNone/>
-            </a:pPr>
-            <a:r>
-              <a:rPr lang="en-US" sz="1300" dirty="0">
-                <a:solidFill>
-                  <a:srgbClr val="2563EB"/>
-                </a:solidFill>
-                <a:latin typeface="Consolas" pitchFamily="34" charset="0"/>
-                <a:ea typeface="Consolas" pitchFamily="34" charset="-122"/>
-                <a:cs typeface="Consolas" pitchFamily="34" charset="-120"/>
-              </a:rPr>
-              <a:t>fb-loadgen --ui</a:t>
-            </a:r>
-            <a:endParaRPr lang="en-US" sz="1300" dirty="0"/>
+              <a:t>isolation families × read-only × wait / nowait / lock-timeout draw on top of the completion axis — emul-safe keeps every draw legal for the emul units</a:t>
+            </a:r>
+            <a:endParaRPr lang="en-US" sz="1150" dirty="0"/>
           </a:p>
         </p:txBody>
       </p:sp>
@@ -11988,7 +12494,7 @@
                 <a:ea typeface="Segoe UI" pitchFamily="34" charset="-122"/>
                 <a:cs typeface="Segoe UI" pitchFamily="34" charset="-120"/>
               </a:rPr>
-              <a:t>Appendix — quick reference</a:t>
+              <a:t>Field diagnostics — probe and reproduce what support asks for</a:t>
             </a:r>
             <a:endParaRPr lang="en-US" sz="2700" dirty="0"/>
           </a:p>
@@ -11997,6 +12503,45 @@
       <p:sp>
         <p:nvSpPr>
           <p:cNvPr id="3" name="Text 1"/>
+          <p:cNvSpPr/>
+          <p:nvPr/>
+        </p:nvSpPr>
+        <p:spPr>
+          <a:xfrm>
+            <a:off x="521208" y="786384"/>
+            <a:ext cx="11185855" cy="310896"/>
+          </a:xfrm>
+          <a:prstGeom prst="rect">
+            <a:avLst/>
+          </a:prstGeom>
+          <a:noFill/>
+          <a:ln/>
+        </p:spPr>
+        <p:txBody>
+          <a:bodyPr wrap="square" rtlCol="0" anchor="ctr"/>
+          <a:lstStyle/>
+          <a:p>
+            <a:pPr indent="0" marL="0">
+              <a:buNone/>
+            </a:pPr>
+            <a:r>
+              <a:rPr lang="en-US" sz="1300" dirty="0">
+                <a:solidFill>
+                  <a:srgbClr val="5F6F83"/>
+                </a:solidFill>
+                <a:latin typeface="Segoe UI" pitchFamily="34" charset="0"/>
+                <a:ea typeface="Segoe UI" pitchFamily="34" charset="-122"/>
+                <a:cs typeface="Segoe UI" pitchFamily="34" charset="-120"/>
+              </a:rPr>
+              <a:t>Two investigation toolkits ship with the generator: an HQbird LightWeight Monitoring probe and a minimal Firebird limbo-crash reproducer.</a:t>
+            </a:r>
+            <a:endParaRPr lang="en-US" sz="1300" dirty="0"/>
+          </a:p>
+        </p:txBody>
+      </p:sp>
+      <p:sp>
+        <p:nvSpPr>
+          <p:cNvPr id="4" name="Text 2"/>
           <p:cNvSpPr/>
           <p:nvPr/>
         </p:nvSpPr>
@@ -12042,6 +12587,2191 @@
                 <a:cs typeface="Segoe UI" pitchFamily="34" charset="-120"/>
               </a:rPr>
               <a:t>   |   20</a:t>
+            </a:r>
+            <a:endParaRPr lang="en-US" sz="900" dirty="0"/>
+          </a:p>
+        </p:txBody>
+      </p:sp>
+      <p:sp>
+        <p:nvSpPr>
+          <p:cNvPr id="6" name="Shape 3"/>
+          <p:cNvSpPr/>
+          <p:nvPr/>
+        </p:nvSpPr>
+        <p:spPr>
+          <a:xfrm>
+            <a:off x="502920" y="1371600"/>
+            <a:ext cx="5715000" cy="4343400"/>
+          </a:xfrm>
+          <a:prstGeom prst="roundRect">
+            <a:avLst>
+              <a:gd name="adj" fmla="val 1263"/>
+            </a:avLst>
+          </a:prstGeom>
+          <a:solidFill>
+            <a:srgbClr val="FFFFFF"/>
+          </a:solidFill>
+          <a:ln w="12700">
+            <a:solidFill>
+              <a:srgbClr val="D8DFE8"/>
+            </a:solidFill>
+            <a:prstDash val="solid"/>
+          </a:ln>
+        </p:spPr>
+      </p:sp>
+      <p:sp>
+        <p:nvSpPr>
+          <p:cNvPr id="7" name="Text 4"/>
+          <p:cNvSpPr/>
+          <p:nvPr/>
+        </p:nvSpPr>
+        <p:spPr>
+          <a:xfrm>
+            <a:off x="685800" y="1517904"/>
+            <a:ext cx="5349240" cy="365760"/>
+          </a:xfrm>
+          <a:prstGeom prst="rect">
+            <a:avLst/>
+          </a:prstGeom>
+          <a:noFill/>
+          <a:ln/>
+        </p:spPr>
+        <p:txBody>
+          <a:bodyPr wrap="square" rtlCol="0" anchor="ctr"/>
+          <a:lstStyle/>
+          <a:p>
+            <a:pPr indent="0" marL="0">
+              <a:buNone/>
+            </a:pPr>
+            <a:r>
+              <a:rPr lang="en-US" sz="1350" b="1" dirty="0">
+                <a:solidFill>
+                  <a:srgbClr val="2563EB"/>
+                </a:solidFill>
+                <a:latin typeface="Segoe UI" pitchFamily="34" charset="0"/>
+                <a:ea typeface="Segoe UI" pitchFamily="34" charset="-122"/>
+                <a:cs typeface="Segoe UI" pitchFamily="34" charset="-120"/>
+              </a:rPr>
+              <a:t>LWM probe — fb-loadgen lwmprobe</a:t>
+            </a:r>
+            <a:endParaRPr lang="en-US" sz="1350" dirty="0"/>
+          </a:p>
+        </p:txBody>
+      </p:sp>
+      <p:sp>
+        <p:nvSpPr>
+          <p:cNvPr id="8" name="Shape 5"/>
+          <p:cNvSpPr/>
+          <p:nvPr/>
+        </p:nvSpPr>
+        <p:spPr>
+          <a:xfrm>
+            <a:off x="685800" y="1965960"/>
+            <a:ext cx="5349240" cy="1737360"/>
+          </a:xfrm>
+          <a:prstGeom prst="roundRect">
+            <a:avLst>
+              <a:gd name="adj" fmla="val 3158"/>
+            </a:avLst>
+          </a:prstGeom>
+          <a:solidFill>
+            <a:srgbClr val="1C2733"/>
+          </a:solidFill>
+          <a:ln/>
+        </p:spPr>
+      </p:sp>
+      <p:sp>
+        <p:nvSpPr>
+          <p:cNvPr id="9" name="Text 6"/>
+          <p:cNvSpPr/>
+          <p:nvPr/>
+        </p:nvSpPr>
+        <p:spPr>
+          <a:xfrm>
+            <a:off x="822960" y="2057400"/>
+            <a:ext cx="5074920" cy="1554480"/>
+          </a:xfrm>
+          <a:prstGeom prst="rect">
+            <a:avLst/>
+          </a:prstGeom>
+          <a:noFill/>
+          <a:ln/>
+        </p:spPr>
+        <p:txBody>
+          <a:bodyPr wrap="square" rtlCol="0" anchor="t"/>
+          <a:lstStyle/>
+          <a:p>
+            <a:pPr indent="0" marL="0">
+              <a:buNone/>
+            </a:pPr>
+            <a:r>
+              <a:rPr lang="en-US" sz="1050" dirty="0">
+                <a:solidFill>
+                  <a:srgbClr val="E7ECF3"/>
+                </a:solidFill>
+                <a:latin typeface="Consolas" pitchFamily="34" charset="0"/>
+                <a:ea typeface="Consolas" pitchFamily="34" charset="-122"/>
+                <a:cs typeface="Consolas" pitchFamily="34" charset="-120"/>
+              </a:rPr>
+              <a:t>fb-loadgen lwmprobe --dsn "host/3055:db" \</a:t>
+            </a:r>
+            <a:endParaRPr lang="en-US" sz="1050" dirty="0"/>
+          </a:p>
+          <a:p>
+            <a:pPr indent="0" marL="0">
+              <a:buNone/>
+            </a:pPr>
+            <a:r>
+              <a:rPr lang="en-US" sz="1050" dirty="0">
+                <a:solidFill>
+                  <a:srgbClr val="E7ECF3"/>
+                </a:solidFill>
+                <a:latin typeface="Consolas" pitchFamily="34" charset="0"/>
+                <a:ea typeface="Consolas" pitchFamily="34" charset="-122"/>
+                <a:cs typeface="Consolas" pitchFamily="34" charset="-120"/>
+              </a:rPr>
+              <a:t>  --action select --c 2 --rate 5 --d 60s \</a:t>
+            </a:r>
+            <a:endParaRPr lang="en-US" sz="1050" dirty="0"/>
+          </a:p>
+          <a:p>
+            <a:pPr indent="0" marL="0">
+              <a:buNone/>
+            </a:pPr>
+            <a:r>
+              <a:rPr lang="en-US" sz="1050" dirty="0">
+                <a:solidFill>
+                  <a:srgbClr val="E7ECF3"/>
+                </a:solidFill>
+                <a:latin typeface="Consolas" pitchFamily="34" charset="0"/>
+                <a:ea typeface="Consolas" pitchFamily="34" charset="-122"/>
+                <a:cs typeface="Consolas" pitchFamily="34" charset="-120"/>
+              </a:rPr>
+              <a:t>  --fblog C:\HQbird\Firebird50\firebird.log</a:t>
+            </a:r>
+            <a:endParaRPr lang="en-US" sz="1050" dirty="0"/>
+          </a:p>
+          <a:p>
+            <a:pPr indent="0" marL="0">
+              <a:buNone/>
+            </a:pPr>
+            <a:endParaRPr lang="en-US" sz="1050" dirty="0"/>
+          </a:p>
+          <a:p>
+            <a:pPr indent="0" marL="0">
+              <a:buNone/>
+            </a:pPr>
+            <a:r>
+              <a:rPr lang="en-US" sz="1050" dirty="0">
+                <a:solidFill>
+                  <a:srgbClr val="E7ECF3"/>
+                </a:solidFill>
+                <a:latin typeface="Consolas" pitchFamily="34" charset="0"/>
+                <a:ea typeface="Consolas" pitchFamily="34" charset="-122"/>
+                <a:cs typeface="Consolas" pitchFamily="34" charset="-120"/>
+              </a:rPr>
+              <a:t># actions: attach | select | mon | monmem | drop</a:t>
+            </a:r>
+            <a:endParaRPr lang="en-US" sz="1050" dirty="0"/>
+          </a:p>
+          <a:p>
+            <a:pPr indent="0" marL="0">
+              <a:buNone/>
+            </a:pPr>
+            <a:r>
+              <a:rPr lang="en-US" sz="1050" dirty="0">
+                <a:solidFill>
+                  <a:srgbClr val="E7ECF3"/>
+                </a:solidFill>
+                <a:latin typeface="Consolas" pitchFamily="34" charset="0"/>
+                <a:ea typeface="Consolas" pitchFamily="34" charset="-122"/>
+                <a:cs typeface="Consolas" pitchFamily="34" charset="-120"/>
+              </a:rPr>
+              <a:t># --idle N persistent conns, --hold-dsn pins one more</a:t>
+            </a:r>
+            <a:endParaRPr lang="en-US" sz="1050" dirty="0"/>
+          </a:p>
+        </p:txBody>
+      </p:sp>
+      <p:sp>
+        <p:nvSpPr>
+          <p:cNvPr id="10" name="Text 7"/>
+          <p:cNvSpPr/>
+          <p:nvPr/>
+        </p:nvSpPr>
+        <p:spPr>
+          <a:xfrm>
+            <a:off x="685800" y="3840480"/>
+            <a:ext cx="5349240" cy="1737360"/>
+          </a:xfrm>
+          <a:prstGeom prst="rect">
+            <a:avLst/>
+          </a:prstGeom>
+          <a:noFill/>
+          <a:ln/>
+        </p:spPr>
+        <p:txBody>
+          <a:bodyPr wrap="square" rtlCol="0" anchor="ctr"/>
+          <a:lstStyle/>
+          <a:p>
+            <a:pPr indent="0" marL="0">
+              <a:buNone/>
+            </a:pPr>
+            <a:r>
+              <a:rPr lang="en-US" sz="1050" dirty="0">
+                <a:solidFill>
+                  <a:srgbClr val="1C2733"/>
+                </a:solidFill>
+                <a:latin typeface="Segoe UI" pitchFamily="34" charset="0"/>
+                <a:ea typeface="Segoe UI" pitchFamily="34" charset="-122"/>
+                <a:cs typeface="Segoe UI" pitchFamily="34" charset="-120"/>
+              </a:rPr>
+              <a:t>Reproduces the LightWeight Monitoring shared-memory version clash when several HQbird builds share one host: one fresh attachment per cycle, zero data operations, log watcher counts new LWMon lines — a go/no-go check for a machine.</a:t>
+            </a:r>
+            <a:endParaRPr lang="en-US" sz="1050" dirty="0"/>
+          </a:p>
+        </p:txBody>
+      </p:sp>
+      <p:sp>
+        <p:nvSpPr>
+          <p:cNvPr id="11" name="Shape 8"/>
+          <p:cNvSpPr/>
+          <p:nvPr/>
+        </p:nvSpPr>
+        <p:spPr>
+          <a:xfrm>
+            <a:off x="6400800" y="1371600"/>
+            <a:ext cx="5715000" cy="4343400"/>
+          </a:xfrm>
+          <a:prstGeom prst="roundRect">
+            <a:avLst>
+              <a:gd name="adj" fmla="val 1263"/>
+            </a:avLst>
+          </a:prstGeom>
+          <a:solidFill>
+            <a:srgbClr val="FFFFFF"/>
+          </a:solidFill>
+          <a:ln w="12700">
+            <a:solidFill>
+              <a:srgbClr val="D8DFE8"/>
+            </a:solidFill>
+            <a:prstDash val="solid"/>
+          </a:ln>
+        </p:spPr>
+      </p:sp>
+      <p:sp>
+        <p:nvSpPr>
+          <p:cNvPr id="12" name="Text 9"/>
+          <p:cNvSpPr/>
+          <p:nvPr/>
+        </p:nvSpPr>
+        <p:spPr>
+          <a:xfrm>
+            <a:off x="6583680" y="1517904"/>
+            <a:ext cx="5349240" cy="365760"/>
+          </a:xfrm>
+          <a:prstGeom prst="rect">
+            <a:avLst/>
+          </a:prstGeom>
+          <a:noFill/>
+          <a:ln/>
+        </p:spPr>
+        <p:txBody>
+          <a:bodyPr wrap="square" rtlCol="0" anchor="ctr"/>
+          <a:lstStyle/>
+          <a:p>
+            <a:pPr indent="0" marL="0">
+              <a:buNone/>
+            </a:pPr>
+            <a:r>
+              <a:rPr lang="en-US" sz="1350" b="1" dirty="0">
+                <a:solidFill>
+                  <a:srgbClr val="2563EB"/>
+                </a:solidFill>
+                <a:latin typeface="Segoe UI" pitchFamily="34" charset="0"/>
+                <a:ea typeface="Segoe UI" pitchFamily="34" charset="-122"/>
+                <a:cs typeface="Segoe UI" pitchFamily="34" charset="-120"/>
+              </a:rPr>
+              <a:t>Limbo crash reproducer — cmd/limbocrash</a:t>
+            </a:r>
+            <a:endParaRPr lang="en-US" sz="1350" dirty="0"/>
+          </a:p>
+        </p:txBody>
+      </p:sp>
+      <p:sp>
+        <p:nvSpPr>
+          <p:cNvPr id="13" name="Shape 10"/>
+          <p:cNvSpPr/>
+          <p:nvPr/>
+        </p:nvSpPr>
+        <p:spPr>
+          <a:xfrm>
+            <a:off x="6583680" y="1965960"/>
+            <a:ext cx="5349240" cy="1737360"/>
+          </a:xfrm>
+          <a:prstGeom prst="roundRect">
+            <a:avLst>
+              <a:gd name="adj" fmla="val 3158"/>
+            </a:avLst>
+          </a:prstGeom>
+          <a:solidFill>
+            <a:srgbClr val="1C2733"/>
+          </a:solidFill>
+          <a:ln/>
+        </p:spPr>
+      </p:sp>
+      <p:sp>
+        <p:nvSpPr>
+          <p:cNvPr id="14" name="Text 11"/>
+          <p:cNvSpPr/>
+          <p:nvPr/>
+        </p:nvSpPr>
+        <p:spPr>
+          <a:xfrm>
+            <a:off x="6720840" y="2057400"/>
+            <a:ext cx="5074920" cy="1554480"/>
+          </a:xfrm>
+          <a:prstGeom prst="rect">
+            <a:avLst/>
+          </a:prstGeom>
+          <a:noFill/>
+          <a:ln/>
+        </p:spPr>
+        <p:txBody>
+          <a:bodyPr wrap="square" rtlCol="0" anchor="t"/>
+          <a:lstStyle/>
+          <a:p>
+            <a:pPr indent="0" marL="0">
+              <a:buNone/>
+            </a:pPr>
+            <a:r>
+              <a:rPr lang="en-US" sz="1050" dirty="0">
+                <a:solidFill>
+                  <a:srgbClr val="E7ECF3"/>
+                </a:solidFill>
+                <a:latin typeface="Consolas" pitchFamily="34" charset="0"/>
+                <a:ea typeface="Consolas" pitchFamily="34" charset="-122"/>
+                <a:cs typeface="Consolas" pitchFamily="34" charset="-120"/>
+              </a:rPr>
+              <a:t>limbocrash -init -host localhost:3095 -db R.FDB</a:t>
+            </a:r>
+            <a:endParaRPr lang="en-US" sz="1050" dirty="0"/>
+          </a:p>
+          <a:p>
+            <a:pPr indent="0" marL="0">
+              <a:buNone/>
+            </a:pPr>
+            <a:r>
+              <a:rPr lang="en-US" sz="1050" dirty="0">
+                <a:solidFill>
+                  <a:srgbClr val="E7ECF3"/>
+                </a:solidFill>
+                <a:latin typeface="Consolas" pitchFamily="34" charset="0"/>
+                <a:ea typeface="Consolas" pitchFamily="34" charset="-122"/>
+                <a:cs typeface="Consolas" pitchFamily="34" charset="-120"/>
+              </a:rPr>
+              <a:t>limbocrash -host localhost:3095 -db R.FDB \</a:t>
+            </a:r>
+            <a:endParaRPr lang="en-US" sz="1050" dirty="0"/>
+          </a:p>
+          <a:p>
+            <a:pPr indent="0" marL="0">
+              <a:buNone/>
+            </a:pPr>
+            <a:r>
+              <a:rPr lang="en-US" sz="1050" dirty="0">
+                <a:solidFill>
+                  <a:srgbClr val="E7ECF3"/>
+                </a:solidFill>
+                <a:latin typeface="Consolas" pitchFamily="34" charset="0"/>
+                <a:ea typeface="Consolas" pitchFamily="34" charset="-122"/>
+                <a:cs typeface="Consolas" pitchFamily="34" charset="-120"/>
+              </a:rPr>
+              <a:t>  -mode die -loops 3</a:t>
+            </a:r>
+            <a:endParaRPr lang="en-US" sz="1050" dirty="0"/>
+          </a:p>
+          <a:p>
+            <a:pPr indent="0" marL="0">
+              <a:buNone/>
+            </a:pPr>
+            <a:endParaRPr lang="en-US" sz="1050" dirty="0"/>
+          </a:p>
+          <a:p>
+            <a:pPr indent="0" marL="0">
+              <a:buNone/>
+            </a:pPr>
+            <a:r>
+              <a:rPr lang="en-US" sz="1050" dirty="0">
+                <a:solidFill>
+                  <a:srgbClr val="E7ECF3"/>
+                </a:solidFill>
+                <a:latin typeface="Consolas" pitchFamily="34" charset="0"/>
+                <a:ea typeface="Consolas" pitchFamily="34" charset="-122"/>
+                <a:cs typeface="Consolas" pitchFamily="34" charset="-120"/>
+              </a:rPr>
+              <a:t># die = prepare, then close the socket;</a:t>
+            </a:r>
+            <a:endParaRPr lang="en-US" sz="1050" dirty="0"/>
+          </a:p>
+          <a:p>
+            <a:pPr indent="0" marL="0">
+              <a:buNone/>
+            </a:pPr>
+            <a:r>
+              <a:rPr lang="en-US" sz="1050" dirty="0">
+                <a:solidFill>
+                  <a:srgbClr val="E7ECF3"/>
+                </a:solidFill>
+                <a:latin typeface="Consolas" pitchFamily="34" charset="0"/>
+                <a:ea typeface="Consolas" pitchFamily="34" charset="-122"/>
+                <a:cs typeface="Consolas" pitchFamily="34" charset="-120"/>
+              </a:rPr>
+              <a:t># drop / commit are the controls</a:t>
+            </a:r>
+            <a:endParaRPr lang="en-US" sz="1050" dirty="0"/>
+          </a:p>
+        </p:txBody>
+      </p:sp>
+      <p:sp>
+        <p:nvSpPr>
+          <p:cNvPr id="15" name="Text 12"/>
+          <p:cNvSpPr/>
+          <p:nvPr/>
+        </p:nvSpPr>
+        <p:spPr>
+          <a:xfrm>
+            <a:off x="6583680" y="3840480"/>
+            <a:ext cx="5349240" cy="1737360"/>
+          </a:xfrm>
+          <a:prstGeom prst="rect">
+            <a:avLst/>
+          </a:prstGeom>
+          <a:noFill/>
+          <a:ln/>
+        </p:spPr>
+        <p:txBody>
+          <a:bodyPr wrap="square" rtlCol="0" anchor="ctr"/>
+          <a:lstStyle/>
+          <a:p>
+            <a:pPr indent="0" marL="0">
+              <a:buNone/>
+            </a:pPr>
+            <a:r>
+              <a:rPr lang="en-US" sz="1050" dirty="0">
+                <a:solidFill>
+                  <a:srgbClr val="1C2733"/>
+                </a:solidFill>
+                <a:latin typeface="Segoe UI" pitchFamily="34" charset="0"/>
+                <a:ea typeface="Segoe UI" pitchFamily="34" charset="-122"/>
+                <a:cs typeface="Segoe UI" pitchFamily="34" charset="-120"/>
+              </a:rPr>
+              <a:t>A prepared transaction whose connection dies crashes Firebird 4.0.7 / 5.0.x (0xC0000005) when replication is on — verified across vanilla and HQbird builds, Super/Classic/SuperClassic, Linux and Windows. Minimal script, build matrix and dump analysis in the repo.</a:t>
+            </a:r>
+            <a:endParaRPr lang="en-US" sz="1050" dirty="0"/>
+          </a:p>
+        </p:txBody>
+      </p:sp>
+      <p:sp>
+        <p:nvSpPr>
+          <p:cNvPr id="16" name="Shape 13"/>
+          <p:cNvSpPr/>
+          <p:nvPr/>
+        </p:nvSpPr>
+        <p:spPr>
+          <a:xfrm>
+            <a:off x="502920" y="5897880"/>
+            <a:ext cx="11201400" cy="384048"/>
+          </a:xfrm>
+          <a:prstGeom prst="roundRect">
+            <a:avLst>
+              <a:gd name="adj" fmla="val 47619"/>
+            </a:avLst>
+          </a:prstGeom>
+          <a:solidFill>
+            <a:srgbClr val="EEF2F7"/>
+          </a:solidFill>
+          <a:ln w="12700">
+            <a:solidFill>
+              <a:srgbClr val="D8DFE8"/>
+            </a:solidFill>
+            <a:prstDash val="solid"/>
+          </a:ln>
+        </p:spPr>
+      </p:sp>
+      <p:sp>
+        <p:nvSpPr>
+          <p:cNvPr id="17" name="Text 14"/>
+          <p:cNvSpPr/>
+          <p:nvPr/>
+        </p:nvSpPr>
+        <p:spPr>
+          <a:xfrm>
+            <a:off x="502920" y="5897880"/>
+            <a:ext cx="11201400" cy="384048"/>
+          </a:xfrm>
+          <a:prstGeom prst="rect">
+            <a:avLst/>
+          </a:prstGeom>
+          <a:noFill/>
+          <a:ln/>
+        </p:spPr>
+        <p:txBody>
+          <a:bodyPr wrap="square" rtlCol="0" anchor="ctr"/>
+          <a:lstStyle/>
+          <a:p>
+            <a:pPr algn="ctr" indent="0" marL="0">
+              <a:buNone/>
+            </a:pPr>
+            <a:r>
+              <a:rPr lang="en-US" sz="1150" dirty="0">
+                <a:solidFill>
+                  <a:srgbClr val="1C2733"/>
+                </a:solidFill>
+                <a:latin typeface="Segoe UI" pitchFamily="34" charset="0"/>
+                <a:ea typeface="Segoe UI" pitchFamily="34" charset="-122"/>
+                <a:cs typeface="Segoe UI" pitchFamily="34" charset="-120"/>
+              </a:rPr>
+              <a:t>both are read-only for your data — use them to qualify a server before a load campaign; --no-limbo keeps replicated targets safe meanwhile</a:t>
+            </a:r>
+            <a:endParaRPr lang="en-US" sz="1150" dirty="0"/>
+          </a:p>
+        </p:txBody>
+      </p:sp>
+    </p:spTree>
+  </p:cSld>
+  <p:clrMapOvr>
+    <a:masterClrMapping/>
+  </p:clrMapOvr>
+</p:sld>
+</file>
+
+<file path=ppt/slides/slide21.xml><?xml version="1.0" encoding="utf-8"?>
+<p:sld xmlns:a="http://schemas.openxmlformats.org/drawingml/2006/main" xmlns:r="http://schemas.openxmlformats.org/officeDocument/2006/relationships" xmlns:p="http://schemas.openxmlformats.org/presentationml/2006/main">
+  <p:cSld name="Slide 21">
+    <p:bg>
+      <p:bgPr>
+        <a:solidFill>
+          <a:srgbClr val="F5F7FA"/>
+        </a:solidFill>
+      </p:bgPr>
+    </p:bg>
+    <p:spTree>
+      <p:nvGrpSpPr>
+        <p:cNvPr id="1" name=""/>
+        <p:cNvGrpSpPr/>
+        <p:nvPr/>
+      </p:nvGrpSpPr>
+      <p:grpSpPr>
+        <a:xfrm>
+          <a:off x="0" y="0"/>
+          <a:ext cx="0" cy="0"/>
+          <a:chOff x="0" y="0"/>
+          <a:chExt cx="0" cy="0"/>
+        </a:xfrm>
+      </p:grpSpPr>
+      <p:sp>
+        <p:nvSpPr>
+          <p:cNvPr id="2" name="Text 0"/>
+          <p:cNvSpPr/>
+          <p:nvPr/>
+        </p:nvSpPr>
+        <p:spPr>
+          <a:xfrm>
+            <a:off x="502920" y="256032"/>
+            <a:ext cx="11185855" cy="548640"/>
+          </a:xfrm>
+          <a:prstGeom prst="rect">
+            <a:avLst/>
+          </a:prstGeom>
+          <a:noFill/>
+          <a:ln/>
+        </p:spPr>
+        <p:txBody>
+          <a:bodyPr wrap="square" rtlCol="0" anchor="ctr"/>
+          <a:lstStyle/>
+          <a:p>
+            <a:pPr indent="0" marL="0">
+              <a:buNone/>
+            </a:pPr>
+            <a:r>
+              <a:rPr lang="en-US" sz="2700" b="1" dirty="0">
+                <a:solidFill>
+                  <a:srgbClr val="1C2733"/>
+                </a:solidFill>
+                <a:latin typeface="Segoe UI" pitchFamily="34" charset="0"/>
+                <a:ea typeface="Segoe UI" pitchFamily="34" charset="-122"/>
+                <a:cs typeface="Segoe UI" pitchFamily="34" charset="-120"/>
+              </a:rPr>
+              <a:t>Typical scenarios</a:t>
+            </a:r>
+            <a:endParaRPr lang="en-US" sz="2700" dirty="0"/>
+          </a:p>
+        </p:txBody>
+      </p:sp>
+      <p:sp>
+        <p:nvSpPr>
+          <p:cNvPr id="3" name="Text 1"/>
+          <p:cNvSpPr/>
+          <p:nvPr/>
+        </p:nvSpPr>
+        <p:spPr>
+          <a:xfrm>
+            <a:off x="8899855" y="6473952"/>
+            <a:ext cx="3017520" cy="274320"/>
+          </a:xfrm>
+          <a:prstGeom prst="rect">
+            <a:avLst/>
+          </a:prstGeom>
+          <a:noFill/>
+          <a:ln/>
+        </p:spPr>
+        <p:txBody>
+          <a:bodyPr wrap="square" rtlCol="0" anchor="ctr"/>
+          <a:lstStyle/>
+          <a:p>
+            <a:pPr algn="r" indent="0" marL="0">
+              <a:buNone/>
+            </a:pPr>
+            <a:r>
+              <a:rPr lang="en-US" sz="900" dirty="0">
+                <a:solidFill>
+                  <a:srgbClr val="5F6F83"/>
+                </a:solidFill>
+                <a:latin typeface="Segoe UI" pitchFamily="34" charset="0"/>
+                <a:ea typeface="Segoe UI" pitchFamily="34" charset="-122"/>
+                <a:cs typeface="Segoe UI" pitchFamily="34" charset="-120"/>
+              </a:rPr>
+              <a:t>IBSurgeon Firebird Load Generator</a:t>
+            </a:r>
+            <a:pPr algn="r" indent="0" marL="0">
+              <a:buNone/>
+            </a:pPr>
+            <a:r>
+              <a:rPr lang="en-US" sz="900" b="1" dirty="0">
+                <a:solidFill>
+                  <a:srgbClr val="2563EB"/>
+                </a:solidFill>
+                <a:latin typeface="Segoe UI" pitchFamily="34" charset="0"/>
+                <a:ea typeface="Segoe UI" pitchFamily="34" charset="-122"/>
+                <a:cs typeface="Segoe UI" pitchFamily="34" charset="-120"/>
+              </a:rPr>
+              <a:t>   |   21</a:t>
+            </a:r>
+            <a:endParaRPr lang="en-US" sz="900" dirty="0"/>
+          </a:p>
+        </p:txBody>
+      </p:sp>
+      <p:sp>
+        <p:nvSpPr>
+          <p:cNvPr id="5" name="Shape 2"/>
+          <p:cNvSpPr/>
+          <p:nvPr/>
+        </p:nvSpPr>
+        <p:spPr>
+          <a:xfrm>
+            <a:off x="502920" y="1371600"/>
+            <a:ext cx="3703320" cy="4206240"/>
+          </a:xfrm>
+          <a:prstGeom prst="roundRect">
+            <a:avLst>
+              <a:gd name="adj" fmla="val 1481"/>
+            </a:avLst>
+          </a:prstGeom>
+          <a:solidFill>
+            <a:srgbClr val="FFFFFF"/>
+          </a:solidFill>
+          <a:ln w="12700">
+            <a:solidFill>
+              <a:srgbClr val="D8DFE8"/>
+            </a:solidFill>
+            <a:prstDash val="solid"/>
+          </a:ln>
+        </p:spPr>
+      </p:sp>
+      <p:sp>
+        <p:nvSpPr>
+          <p:cNvPr id="6" name="Text 3"/>
+          <p:cNvSpPr/>
+          <p:nvPr/>
+        </p:nvSpPr>
+        <p:spPr>
+          <a:xfrm>
+            <a:off x="685800" y="1536192"/>
+            <a:ext cx="3337560" cy="365760"/>
+          </a:xfrm>
+          <a:prstGeom prst="rect">
+            <a:avLst/>
+          </a:prstGeom>
+          <a:noFill/>
+          <a:ln/>
+        </p:spPr>
+        <p:txBody>
+          <a:bodyPr wrap="square" rtlCol="0" anchor="ctr"/>
+          <a:lstStyle/>
+          <a:p>
+            <a:pPr indent="0" marL="0">
+              <a:buNone/>
+            </a:pPr>
+            <a:r>
+              <a:rPr lang="en-US" sz="1500" b="1" dirty="0">
+                <a:solidFill>
+                  <a:srgbClr val="2563EB"/>
+                </a:solidFill>
+                <a:latin typeface="Segoe UI" pitchFamily="34" charset="0"/>
+                <a:ea typeface="Segoe UI" pitchFamily="34" charset="-122"/>
+                <a:cs typeface="Segoe UI" pitchFamily="34" charset="-120"/>
+              </a:rPr>
+              <a:t>Nightly soak</a:t>
+            </a:r>
+            <a:endParaRPr lang="en-US" sz="1500" dirty="0"/>
+          </a:p>
+        </p:txBody>
+      </p:sp>
+      <p:sp>
+        <p:nvSpPr>
+          <p:cNvPr id="7" name="Shape 4"/>
+          <p:cNvSpPr/>
+          <p:nvPr/>
+        </p:nvSpPr>
+        <p:spPr>
+          <a:xfrm>
+            <a:off x="685800" y="2011680"/>
+            <a:ext cx="3337560" cy="2743200"/>
+          </a:xfrm>
+          <a:prstGeom prst="roundRect">
+            <a:avLst>
+              <a:gd name="adj" fmla="val 2000"/>
+            </a:avLst>
+          </a:prstGeom>
+          <a:solidFill>
+            <a:srgbClr val="1C2733"/>
+          </a:solidFill>
+          <a:ln/>
+        </p:spPr>
+      </p:sp>
+      <p:sp>
+        <p:nvSpPr>
+          <p:cNvPr id="8" name="Text 5"/>
+          <p:cNvSpPr/>
+          <p:nvPr/>
+        </p:nvSpPr>
+        <p:spPr>
+          <a:xfrm>
+            <a:off x="822960" y="2103120"/>
+            <a:ext cx="3063240" cy="2560320"/>
+          </a:xfrm>
+          <a:prstGeom prst="rect">
+            <a:avLst/>
+          </a:prstGeom>
+          <a:noFill/>
+          <a:ln/>
+        </p:spPr>
+        <p:txBody>
+          <a:bodyPr wrap="square" rtlCol="0" anchor="t"/>
+          <a:lstStyle/>
+          <a:p>
+            <a:pPr indent="0" marL="0">
+              <a:buNone/>
+            </a:pPr>
+            <a:r>
+              <a:rPr lang="en-US" sz="1050" dirty="0">
+                <a:solidFill>
+                  <a:srgbClr val="E7ECF3"/>
+                </a:solidFill>
+                <a:latin typeface="Consolas" pitchFamily="34" charset="0"/>
+                <a:ea typeface="Consolas" pitchFamily="34" charset="-122"/>
+                <a:cs typeface="Consolas" pitchFamily="34" charset="-120"/>
+              </a:rPr>
+              <a:t>curl -X POST $BASE/api/schedules -d '{</a:t>
+            </a:r>
+            <a:endParaRPr lang="en-US" sz="1050" dirty="0"/>
+          </a:p>
+          <a:p>
+            <a:pPr indent="0" marL="0">
+              <a:buNone/>
+            </a:pPr>
+            <a:r>
+              <a:rPr lang="en-US" sz="1050" dirty="0">
+                <a:solidFill>
+                  <a:srgbClr val="E7ECF3"/>
+                </a:solidFill>
+                <a:latin typeface="Consolas" pitchFamily="34" charset="0"/>
+                <a:ea typeface="Consolas" pitchFamily="34" charset="-122"/>
+                <a:cs typeface="Consolas" pitchFamily="34" charset="-120"/>
+              </a:rPr>
+              <a:t>  "trigger": {"type":"cron",</a:t>
+            </a:r>
+            <a:endParaRPr lang="en-US" sz="1050" dirty="0"/>
+          </a:p>
+          <a:p>
+            <a:pPr indent="0" marL="0">
+              <a:buNone/>
+            </a:pPr>
+            <a:r>
+              <a:rPr lang="en-US" sz="1050" dirty="0">
+                <a:solidFill>
+                  <a:srgbClr val="E7ECF3"/>
+                </a:solidFill>
+                <a:latin typeface="Consolas" pitchFamily="34" charset="0"/>
+                <a:ea typeface="Consolas" pitchFamily="34" charset="-122"/>
+                <a:cs typeface="Consolas" pitchFamily="34" charset="-120"/>
+              </a:rPr>
+              <a:t>   "cron":"0 2 * * *"},</a:t>
+            </a:r>
+            <a:endParaRPr lang="en-US" sz="1050" dirty="0"/>
+          </a:p>
+          <a:p>
+            <a:pPr indent="0" marL="0">
+              <a:buNone/>
+            </a:pPr>
+            <a:r>
+              <a:rPr lang="en-US" sz="1050" dirty="0">
+                <a:solidFill>
+                  <a:srgbClr val="E7ECF3"/>
+                </a:solidFill>
+                <a:latin typeface="Consolas" pitchFamily="34" charset="0"/>
+                <a:ea typeface="Consolas" pitchFamily="34" charset="-122"/>
+                <a:cs typeface="Consolas" pitchFamily="34" charset="-120"/>
+              </a:rPr>
+              <a:t>  "run": {"timeLimitMin":30},</a:t>
+            </a:r>
+            <a:endParaRPr lang="en-US" sz="1050" dirty="0"/>
+          </a:p>
+          <a:p>
+            <a:pPr indent="0" marL="0">
+              <a:buNone/>
+            </a:pPr>
+            <a:r>
+              <a:rPr lang="en-US" sz="1050" dirty="0">
+                <a:solidFill>
+                  <a:srgbClr val="E7ECF3"/>
+                </a:solidFill>
+                <a:latin typeface="Consolas" pitchFamily="34" charset="0"/>
+                <a:ea typeface="Consolas" pitchFamily="34" charset="-122"/>
+                <a:cs typeface="Consolas" pitchFamily="34" charset="-120"/>
+              </a:rPr>
+              <a:t>  "notifyUrl":"https://hooks/…"}'</a:t>
+            </a:r>
+            <a:endParaRPr lang="en-US" sz="1050" dirty="0"/>
+          </a:p>
+        </p:txBody>
+      </p:sp>
+      <p:sp>
+        <p:nvSpPr>
+          <p:cNvPr id="9" name="Text 6"/>
+          <p:cNvSpPr/>
+          <p:nvPr/>
+        </p:nvSpPr>
+        <p:spPr>
+          <a:xfrm>
+            <a:off x="685800" y="4846320"/>
+            <a:ext cx="3337560" cy="640080"/>
+          </a:xfrm>
+          <a:prstGeom prst="rect">
+            <a:avLst/>
+          </a:prstGeom>
+          <a:noFill/>
+          <a:ln/>
+        </p:spPr>
+        <p:txBody>
+          <a:bodyPr wrap="square" rtlCol="0" anchor="ctr"/>
+          <a:lstStyle/>
+          <a:p>
+            <a:pPr indent="0" marL="0">
+              <a:buNone/>
+            </a:pPr>
+            <a:r>
+              <a:rPr lang="en-US" sz="1050" dirty="0">
+                <a:solidFill>
+                  <a:srgbClr val="5F6F83"/>
+                </a:solidFill>
+                <a:latin typeface="Segoe UI" pitchFamily="34" charset="0"/>
+                <a:ea typeface="Segoe UI" pitchFamily="34" charset="-122"/>
+                <a:cs typeface="Segoe UI" pitchFamily="34" charset="-120"/>
+              </a:rPr>
+              <a:t>Every night at 02:00, 30 minutes, webhook tells you the outcome</a:t>
+            </a:r>
+            <a:endParaRPr lang="en-US" sz="1050" dirty="0"/>
+          </a:p>
+        </p:txBody>
+      </p:sp>
+      <p:sp>
+        <p:nvSpPr>
+          <p:cNvPr id="10" name="Shape 7"/>
+          <p:cNvSpPr/>
+          <p:nvPr/>
+        </p:nvSpPr>
+        <p:spPr>
+          <a:xfrm>
+            <a:off x="4416552" y="1371600"/>
+            <a:ext cx="3703320" cy="4206240"/>
+          </a:xfrm>
+          <a:prstGeom prst="roundRect">
+            <a:avLst>
+              <a:gd name="adj" fmla="val 1481"/>
+            </a:avLst>
+          </a:prstGeom>
+          <a:solidFill>
+            <a:srgbClr val="FFFFFF"/>
+          </a:solidFill>
+          <a:ln w="12700">
+            <a:solidFill>
+              <a:srgbClr val="D8DFE8"/>
+            </a:solidFill>
+            <a:prstDash val="solid"/>
+          </a:ln>
+        </p:spPr>
+      </p:sp>
+      <p:sp>
+        <p:nvSpPr>
+          <p:cNvPr id="11" name="Text 8"/>
+          <p:cNvSpPr/>
+          <p:nvPr/>
+        </p:nvSpPr>
+        <p:spPr>
+          <a:xfrm>
+            <a:off x="4599432" y="1536192"/>
+            <a:ext cx="3337560" cy="365760"/>
+          </a:xfrm>
+          <a:prstGeom prst="rect">
+            <a:avLst/>
+          </a:prstGeom>
+          <a:noFill/>
+          <a:ln/>
+        </p:spPr>
+        <p:txBody>
+          <a:bodyPr wrap="square" rtlCol="0" anchor="ctr"/>
+          <a:lstStyle/>
+          <a:p>
+            <a:pPr indent="0" marL="0">
+              <a:buNone/>
+            </a:pPr>
+            <a:r>
+              <a:rPr lang="en-US" sz="1500" b="1" dirty="0">
+                <a:solidFill>
+                  <a:srgbClr val="2563EB"/>
+                </a:solidFill>
+                <a:latin typeface="Segoe UI" pitchFamily="34" charset="0"/>
+                <a:ea typeface="Segoe UI" pitchFamily="34" charset="-122"/>
+                <a:cs typeface="Segoe UI" pitchFamily="34" charset="-120"/>
+              </a:rPr>
+              <a:t>CI spike test</a:t>
+            </a:r>
+            <a:endParaRPr lang="en-US" sz="1500" dirty="0"/>
+          </a:p>
+        </p:txBody>
+      </p:sp>
+      <p:sp>
+        <p:nvSpPr>
+          <p:cNvPr id="12" name="Shape 9"/>
+          <p:cNvSpPr/>
+          <p:nvPr/>
+        </p:nvSpPr>
+        <p:spPr>
+          <a:xfrm>
+            <a:off x="4599432" y="2011680"/>
+            <a:ext cx="3337560" cy="2743200"/>
+          </a:xfrm>
+          <a:prstGeom prst="roundRect">
+            <a:avLst>
+              <a:gd name="adj" fmla="val 2000"/>
+            </a:avLst>
+          </a:prstGeom>
+          <a:solidFill>
+            <a:srgbClr val="1C2733"/>
+          </a:solidFill>
+          <a:ln/>
+        </p:spPr>
+      </p:sp>
+      <p:sp>
+        <p:nvSpPr>
+          <p:cNvPr id="13" name="Text 10"/>
+          <p:cNvSpPr/>
+          <p:nvPr/>
+        </p:nvSpPr>
+        <p:spPr>
+          <a:xfrm>
+            <a:off x="4736592" y="2103120"/>
+            <a:ext cx="3063240" cy="2560320"/>
+          </a:xfrm>
+          <a:prstGeom prst="rect">
+            <a:avLst/>
+          </a:prstGeom>
+          <a:noFill/>
+          <a:ln/>
+        </p:spPr>
+        <p:txBody>
+          <a:bodyPr wrap="square" rtlCol="0" anchor="t"/>
+          <a:lstStyle/>
+          <a:p>
+            <a:pPr indent="0" marL="0">
+              <a:buNone/>
+            </a:pPr>
+            <a:r>
+              <a:rPr lang="en-US" sz="1050" dirty="0">
+                <a:solidFill>
+                  <a:srgbClr val="E7ECF3"/>
+                </a:solidFill>
+                <a:latin typeface="Consolas" pitchFamily="34" charset="0"/>
+                <a:ea typeface="Consolas" pitchFamily="34" charset="-122"/>
+                <a:cs typeface="Consolas" pitchFamily="34" charset="-120"/>
+              </a:rPr>
+              <a:t>fb-loadgen --ui --api-only &amp;</a:t>
+            </a:r>
+            <a:endParaRPr lang="en-US" sz="1050" dirty="0"/>
+          </a:p>
+          <a:p>
+            <a:pPr indent="0" marL="0">
+              <a:buNone/>
+            </a:pPr>
+            <a:r>
+              <a:rPr lang="en-US" sz="1050" dirty="0">
+                <a:solidFill>
+                  <a:srgbClr val="E7ECF3"/>
+                </a:solidFill>
+                <a:latin typeface="Consolas" pitchFamily="34" charset="0"/>
+                <a:ea typeface="Consolas" pitchFamily="34" charset="-122"/>
+                <a:cs typeface="Consolas" pitchFamily="34" charset="-120"/>
+              </a:rPr>
+              <a:t>curl -X POST $BASE/api/schedules/</a:t>
+            </a:r>
+            <a:endParaRPr lang="en-US" sz="1050" dirty="0"/>
+          </a:p>
+          <a:p>
+            <a:pPr indent="0" marL="0">
+              <a:buNone/>
+            </a:pPr>
+            <a:r>
+              <a:rPr lang="en-US" sz="1050" dirty="0">
+                <a:solidFill>
+                  <a:srgbClr val="E7ECF3"/>
+                </a:solidFill>
+                <a:latin typeface="Consolas" pitchFamily="34" charset="0"/>
+                <a:ea typeface="Consolas" pitchFamily="34" charset="-122"/>
+                <a:cs typeface="Consolas" pitchFamily="34" charset="-120"/>
+              </a:rPr>
+              <a:t>  $SID/trigger        # fire now</a:t>
+            </a:r>
+            <a:endParaRPr lang="en-US" sz="1050" dirty="0"/>
+          </a:p>
+          <a:p>
+            <a:pPr indent="0" marL="0">
+              <a:buNone/>
+            </a:pPr>
+            <a:r>
+              <a:rPr lang="en-US" sz="1050" dirty="0">
+                <a:solidFill>
+                  <a:srgbClr val="E7ECF3"/>
+                </a:solidFill>
+                <a:latin typeface="Consolas" pitchFamily="34" charset="0"/>
+                <a:ea typeface="Consolas" pitchFamily="34" charset="-122"/>
+                <a:cs typeface="Consolas" pitchFamily="34" charset="-120"/>
+              </a:rPr>
+              <a:t>curl $BASE/api/runs/$RUN   # outcome</a:t>
+            </a:r>
+            <a:endParaRPr lang="en-US" sz="1050" dirty="0"/>
+          </a:p>
+          <a:p>
+            <a:pPr indent="0" marL="0">
+              <a:buNone/>
+            </a:pPr>
+            <a:r>
+              <a:rPr lang="en-US" sz="1050" dirty="0">
+                <a:solidFill>
+                  <a:srgbClr val="E7ECF3"/>
+                </a:solidFill>
+                <a:latin typeface="Consolas" pitchFamily="34" charset="0"/>
+                <a:ea typeface="Consolas" pitchFamily="34" charset="-122"/>
+                <a:cs typeface="Consolas" pitchFamily="34" charset="-120"/>
+              </a:rPr>
+              <a:t># fail the build on outcome != ok</a:t>
+            </a:r>
+            <a:endParaRPr lang="en-US" sz="1050" dirty="0"/>
+          </a:p>
+        </p:txBody>
+      </p:sp>
+      <p:sp>
+        <p:nvSpPr>
+          <p:cNvPr id="14" name="Text 11"/>
+          <p:cNvSpPr/>
+          <p:nvPr/>
+        </p:nvSpPr>
+        <p:spPr>
+          <a:xfrm>
+            <a:off x="4599432" y="4846320"/>
+            <a:ext cx="3337560" cy="640080"/>
+          </a:xfrm>
+          <a:prstGeom prst="rect">
+            <a:avLst/>
+          </a:prstGeom>
+          <a:noFill/>
+          <a:ln/>
+        </p:spPr>
+        <p:txBody>
+          <a:bodyPr wrap="square" rtlCol="0" anchor="ctr"/>
+          <a:lstStyle/>
+          <a:p>
+            <a:pPr indent="0" marL="0">
+              <a:buNone/>
+            </a:pPr>
+            <a:r>
+              <a:rPr lang="en-US" sz="1050" dirty="0">
+                <a:solidFill>
+                  <a:srgbClr val="5F6F83"/>
+                </a:solidFill>
+                <a:latin typeface="Segoe UI" pitchFamily="34" charset="0"/>
+                <a:ea typeface="Segoe UI" pitchFamily="34" charset="-122"/>
+                <a:cs typeface="Segoe UI" pitchFamily="34" charset="-120"/>
+              </a:rPr>
+              <a:t>Headless process in CI; build fails if the run fails</a:t>
+            </a:r>
+            <a:endParaRPr lang="en-US" sz="1050" dirty="0"/>
+          </a:p>
+        </p:txBody>
+      </p:sp>
+      <p:sp>
+        <p:nvSpPr>
+          <p:cNvPr id="15" name="Shape 12"/>
+          <p:cNvSpPr/>
+          <p:nvPr/>
+        </p:nvSpPr>
+        <p:spPr>
+          <a:xfrm>
+            <a:off x="8330184" y="1371600"/>
+            <a:ext cx="3703320" cy="4206240"/>
+          </a:xfrm>
+          <a:prstGeom prst="roundRect">
+            <a:avLst>
+              <a:gd name="adj" fmla="val 1481"/>
+            </a:avLst>
+          </a:prstGeom>
+          <a:solidFill>
+            <a:srgbClr val="FFFFFF"/>
+          </a:solidFill>
+          <a:ln w="12700">
+            <a:solidFill>
+              <a:srgbClr val="D8DFE8"/>
+            </a:solidFill>
+            <a:prstDash val="solid"/>
+          </a:ln>
+        </p:spPr>
+      </p:sp>
+      <p:sp>
+        <p:nvSpPr>
+          <p:cNvPr id="16" name="Text 13"/>
+          <p:cNvSpPr/>
+          <p:nvPr/>
+        </p:nvSpPr>
+        <p:spPr>
+          <a:xfrm>
+            <a:off x="8513064" y="1536192"/>
+            <a:ext cx="3337560" cy="365760"/>
+          </a:xfrm>
+          <a:prstGeom prst="rect">
+            <a:avLst/>
+          </a:prstGeom>
+          <a:noFill/>
+          <a:ln/>
+        </p:spPr>
+        <p:txBody>
+          <a:bodyPr wrap="square" rtlCol="0" anchor="ctr"/>
+          <a:lstStyle/>
+          <a:p>
+            <a:pPr indent="0" marL="0">
+              <a:buNone/>
+            </a:pPr>
+            <a:r>
+              <a:rPr lang="en-US" sz="1500" b="1" dirty="0">
+                <a:solidFill>
+                  <a:srgbClr val="2563EB"/>
+                </a:solidFill>
+                <a:latin typeface="Segoe UI" pitchFamily="34" charset="0"/>
+                <a:ea typeface="Segoe UI" pitchFamily="34" charset="-122"/>
+                <a:cs typeface="Segoe UI" pitchFamily="34" charset="-120"/>
+              </a:rPr>
+              <a:t>Fleet health</a:t>
+            </a:r>
+            <a:endParaRPr lang="en-US" sz="1500" dirty="0"/>
+          </a:p>
+        </p:txBody>
+      </p:sp>
+      <p:sp>
+        <p:nvSpPr>
+          <p:cNvPr id="17" name="Shape 14"/>
+          <p:cNvSpPr/>
+          <p:nvPr/>
+        </p:nvSpPr>
+        <p:spPr>
+          <a:xfrm>
+            <a:off x="8513064" y="2011680"/>
+            <a:ext cx="3337560" cy="2743200"/>
+          </a:xfrm>
+          <a:prstGeom prst="roundRect">
+            <a:avLst>
+              <a:gd name="adj" fmla="val 2000"/>
+            </a:avLst>
+          </a:prstGeom>
+          <a:solidFill>
+            <a:srgbClr val="1C2733"/>
+          </a:solidFill>
+          <a:ln/>
+        </p:spPr>
+      </p:sp>
+      <p:sp>
+        <p:nvSpPr>
+          <p:cNvPr id="18" name="Text 15"/>
+          <p:cNvSpPr/>
+          <p:nvPr/>
+        </p:nvSpPr>
+        <p:spPr>
+          <a:xfrm>
+            <a:off x="8650224" y="2103120"/>
+            <a:ext cx="3063240" cy="2560320"/>
+          </a:xfrm>
+          <a:prstGeom prst="rect">
+            <a:avLst/>
+          </a:prstGeom>
+          <a:noFill/>
+          <a:ln/>
+        </p:spPr>
+        <p:txBody>
+          <a:bodyPr wrap="square" rtlCol="0" anchor="t"/>
+          <a:lstStyle/>
+          <a:p>
+            <a:pPr indent="0" marL="0">
+              <a:buNone/>
+            </a:pPr>
+            <a:r>
+              <a:rPr lang="en-US" sz="1050" dirty="0">
+                <a:solidFill>
+                  <a:srgbClr val="E7ECF3"/>
+                </a:solidFill>
+                <a:latin typeface="Consolas" pitchFamily="34" charset="0"/>
+                <a:ea typeface="Consolas" pitchFamily="34" charset="-122"/>
+                <a:cs typeface="Consolas" pitchFamily="34" charset="-120"/>
+              </a:rPr>
+              <a:t>curl $BASE/api/fleet</a:t>
+            </a:r>
+            <a:endParaRPr lang="en-US" sz="1050" dirty="0"/>
+          </a:p>
+          <a:p>
+            <a:pPr indent="0" marL="0">
+              <a:buNone/>
+            </a:pPr>
+            <a:r>
+              <a:rPr lang="en-US" sz="1050" dirty="0">
+                <a:solidFill>
+                  <a:srgbClr val="E7ECF3"/>
+                </a:solidFill>
+                <a:latin typeface="Consolas" pitchFamily="34" charset="0"/>
+                <a:ea typeface="Consolas" pitchFamily="34" charset="-122"/>
+                <a:cs typeface="Consolas" pitchFamily="34" charset="-120"/>
+              </a:rPr>
+              <a:t>curl $BASE/metrics | grep fbloadgen</a:t>
+            </a:r>
+            <a:endParaRPr lang="en-US" sz="1050" dirty="0"/>
+          </a:p>
+          <a:p>
+            <a:pPr indent="0" marL="0">
+              <a:buNone/>
+            </a:pPr>
+            <a:endParaRPr lang="en-US" sz="1050" dirty="0"/>
+          </a:p>
+          <a:p>
+            <a:pPr indent="0" marL="0">
+              <a:buNone/>
+            </a:pPr>
+            <a:r>
+              <a:rPr lang="en-US" sz="1050" dirty="0">
+                <a:solidFill>
+                  <a:srgbClr val="E7ECF3"/>
+                </a:solidFill>
+                <a:latin typeface="Consolas" pitchFamily="34" charset="0"/>
+                <a:ea typeface="Consolas" pitchFamily="34" charset="-122"/>
+                <a:cs typeface="Consolas" pitchFamily="34" charset="-120"/>
+              </a:rPr>
+              <a:t># running, budget, TPS, errors,</a:t>
+            </a:r>
+            <a:endParaRPr lang="en-US" sz="1050" dirty="0"/>
+          </a:p>
+          <a:p>
+            <a:pPr indent="0" marL="0">
+              <a:buNone/>
+            </a:pPr>
+            <a:r>
+              <a:rPr lang="en-US" sz="1050" dirty="0">
+                <a:solidFill>
+                  <a:srgbClr val="E7ECF3"/>
+                </a:solidFill>
+                <a:latin typeface="Consolas" pitchFamily="34" charset="0"/>
+                <a:ea typeface="Consolas" pitchFamily="34" charset="-122"/>
+                <a:cs typeface="Consolas" pitchFamily="34" charset="-120"/>
+              </a:rPr>
+              <a:t># next scheduled fire — in Prometheus</a:t>
+            </a:r>
+            <a:endParaRPr lang="en-US" sz="1050" dirty="0"/>
+          </a:p>
+        </p:txBody>
+      </p:sp>
+      <p:sp>
+        <p:nvSpPr>
+          <p:cNvPr id="19" name="Text 16"/>
+          <p:cNvSpPr/>
+          <p:nvPr/>
+        </p:nvSpPr>
+        <p:spPr>
+          <a:xfrm>
+            <a:off x="8513064" y="4846320"/>
+            <a:ext cx="3337560" cy="640080"/>
+          </a:xfrm>
+          <a:prstGeom prst="rect">
+            <a:avLst/>
+          </a:prstGeom>
+          <a:noFill/>
+          <a:ln/>
+        </p:spPr>
+        <p:txBody>
+          <a:bodyPr wrap="square" rtlCol="0" anchor="ctr"/>
+          <a:lstStyle/>
+          <a:p>
+            <a:pPr indent="0" marL="0">
+              <a:buNone/>
+            </a:pPr>
+            <a:r>
+              <a:rPr lang="en-US" sz="1050" dirty="0">
+                <a:solidFill>
+                  <a:srgbClr val="5F6F83"/>
+                </a:solidFill>
+                <a:latin typeface="Segoe UI" pitchFamily="34" charset="0"/>
+                <a:ea typeface="Segoe UI" pitchFamily="34" charset="-122"/>
+                <a:cs typeface="Segoe UI" pitchFamily="34" charset="-120"/>
+              </a:rPr>
+              <a:t>One scrape shows the whole fleet's load state</a:t>
+            </a:r>
+            <a:endParaRPr lang="en-US" sz="1050" dirty="0"/>
+          </a:p>
+        </p:txBody>
+      </p:sp>
+      <p:sp>
+        <p:nvSpPr>
+          <p:cNvPr id="20" name="Text 17"/>
+          <p:cNvSpPr/>
+          <p:nvPr/>
+        </p:nvSpPr>
+        <p:spPr>
+          <a:xfrm>
+            <a:off x="521208" y="5897880"/>
+            <a:ext cx="11155680" cy="365760"/>
+          </a:xfrm>
+          <a:prstGeom prst="rect">
+            <a:avLst/>
+          </a:prstGeom>
+          <a:noFill/>
+          <a:ln/>
+        </p:spPr>
+        <p:txBody>
+          <a:bodyPr wrap="square" rtlCol="0" anchor="ctr"/>
+          <a:lstStyle/>
+          <a:p>
+            <a:pPr algn="ctr" indent="0" marL="0">
+              <a:buNone/>
+            </a:pPr>
+            <a:r>
+              <a:rPr lang="en-US" sz="1300" dirty="0">
+                <a:solidFill>
+                  <a:srgbClr val="5F6F83"/>
+                </a:solidFill>
+                <a:latin typeface="Segoe UI" pitchFamily="34" charset="0"/>
+                <a:ea typeface="Segoe UI" pitchFamily="34" charset="-122"/>
+                <a:cs typeface="Segoe UI" pitchFamily="34" charset="-120"/>
+              </a:rPr>
+              <a:t>Same API drives all three — the UI, CI and cron are interchangeable clients.</a:t>
+            </a:r>
+            <a:endParaRPr lang="en-US" sz="1300" dirty="0"/>
+          </a:p>
+        </p:txBody>
+      </p:sp>
+    </p:spTree>
+  </p:cSld>
+  <p:clrMapOvr>
+    <a:masterClrMapping/>
+  </p:clrMapOvr>
+</p:sld>
+</file>
+
+<file path=ppt/slides/slide22.xml><?xml version="1.0" encoding="utf-8"?>
+<p:sld xmlns:a="http://schemas.openxmlformats.org/drawingml/2006/main" xmlns:r="http://schemas.openxmlformats.org/officeDocument/2006/relationships" xmlns:p="http://schemas.openxmlformats.org/presentationml/2006/main">
+  <p:cSld name="Slide 22">
+    <p:bg>
+      <p:bgPr>
+        <a:solidFill>
+          <a:srgbClr val="F5F7FA"/>
+        </a:solidFill>
+      </p:bgPr>
+    </p:bg>
+    <p:spTree>
+      <p:nvGrpSpPr>
+        <p:cNvPr id="1" name=""/>
+        <p:cNvGrpSpPr/>
+        <p:nvPr/>
+      </p:nvGrpSpPr>
+      <p:grpSpPr>
+        <a:xfrm>
+          <a:off x="0" y="0"/>
+          <a:ext cx="0" cy="0"/>
+          <a:chOff x="0" y="0"/>
+          <a:chExt cx="0" cy="0"/>
+        </a:xfrm>
+      </p:grpSpPr>
+      <p:sp>
+        <p:nvSpPr>
+          <p:cNvPr id="2" name="Text 0"/>
+          <p:cNvSpPr/>
+          <p:nvPr/>
+        </p:nvSpPr>
+        <p:spPr>
+          <a:xfrm>
+            <a:off x="502920" y="256032"/>
+            <a:ext cx="11185855" cy="548640"/>
+          </a:xfrm>
+          <a:prstGeom prst="rect">
+            <a:avLst/>
+          </a:prstGeom>
+          <a:noFill/>
+          <a:ln/>
+        </p:spPr>
+        <p:txBody>
+          <a:bodyPr wrap="square" rtlCol="0" anchor="ctr"/>
+          <a:lstStyle/>
+          <a:p>
+            <a:pPr indent="0" marL="0">
+              <a:buNone/>
+            </a:pPr>
+            <a:r>
+              <a:rPr lang="en-US" sz="2700" b="1" dirty="0">
+                <a:solidFill>
+                  <a:srgbClr val="1C2733"/>
+                </a:solidFill>
+                <a:latin typeface="Segoe UI" pitchFamily="34" charset="0"/>
+                <a:ea typeface="Segoe UI" pitchFamily="34" charset="-122"/>
+                <a:cs typeface="Segoe UI" pitchFamily="34" charset="-120"/>
+              </a:rPr>
+              <a:t>Where we are, where we go</a:t>
+            </a:r>
+            <a:endParaRPr lang="en-US" sz="2700" dirty="0"/>
+          </a:p>
+        </p:txBody>
+      </p:sp>
+      <p:sp>
+        <p:nvSpPr>
+          <p:cNvPr id="3" name="Text 1"/>
+          <p:cNvSpPr/>
+          <p:nvPr/>
+        </p:nvSpPr>
+        <p:spPr>
+          <a:xfrm>
+            <a:off x="8899855" y="6473952"/>
+            <a:ext cx="3017520" cy="274320"/>
+          </a:xfrm>
+          <a:prstGeom prst="rect">
+            <a:avLst/>
+          </a:prstGeom>
+          <a:noFill/>
+          <a:ln/>
+        </p:spPr>
+        <p:txBody>
+          <a:bodyPr wrap="square" rtlCol="0" anchor="ctr"/>
+          <a:lstStyle/>
+          <a:p>
+            <a:pPr algn="r" indent="0" marL="0">
+              <a:buNone/>
+            </a:pPr>
+            <a:r>
+              <a:rPr lang="en-US" sz="900" dirty="0">
+                <a:solidFill>
+                  <a:srgbClr val="5F6F83"/>
+                </a:solidFill>
+                <a:latin typeface="Segoe UI" pitchFamily="34" charset="0"/>
+                <a:ea typeface="Segoe UI" pitchFamily="34" charset="-122"/>
+                <a:cs typeface="Segoe UI" pitchFamily="34" charset="-120"/>
+              </a:rPr>
+              <a:t>IBSurgeon Firebird Load Generator</a:t>
+            </a:r>
+            <a:pPr algn="r" indent="0" marL="0">
+              <a:buNone/>
+            </a:pPr>
+            <a:r>
+              <a:rPr lang="en-US" sz="900" b="1" dirty="0">
+                <a:solidFill>
+                  <a:srgbClr val="2563EB"/>
+                </a:solidFill>
+                <a:latin typeface="Segoe UI" pitchFamily="34" charset="0"/>
+                <a:ea typeface="Segoe UI" pitchFamily="34" charset="-122"/>
+                <a:cs typeface="Segoe UI" pitchFamily="34" charset="-120"/>
+              </a:rPr>
+              <a:t>   |   22</a:t>
+            </a:r>
+            <a:endParaRPr lang="en-US" sz="900" dirty="0"/>
+          </a:p>
+        </p:txBody>
+      </p:sp>
+      <p:sp>
+        <p:nvSpPr>
+          <p:cNvPr id="5" name="Shape 2"/>
+          <p:cNvSpPr/>
+          <p:nvPr/>
+        </p:nvSpPr>
+        <p:spPr>
+          <a:xfrm>
+            <a:off x="502920" y="1371600"/>
+            <a:ext cx="5486400" cy="4297680"/>
+          </a:xfrm>
+          <a:prstGeom prst="roundRect">
+            <a:avLst>
+              <a:gd name="adj" fmla="val 1277"/>
+            </a:avLst>
+          </a:prstGeom>
+          <a:solidFill>
+            <a:srgbClr val="FFFFFF"/>
+          </a:solidFill>
+          <a:ln w="12700">
+            <a:solidFill>
+              <a:srgbClr val="D8DFE8"/>
+            </a:solidFill>
+            <a:prstDash val="solid"/>
+          </a:ln>
+        </p:spPr>
+      </p:sp>
+      <p:sp>
+        <p:nvSpPr>
+          <p:cNvPr id="6" name="Text 3"/>
+          <p:cNvSpPr/>
+          <p:nvPr/>
+        </p:nvSpPr>
+        <p:spPr>
+          <a:xfrm>
+            <a:off x="731520" y="1554480"/>
+            <a:ext cx="5029200" cy="365760"/>
+          </a:xfrm>
+          <a:prstGeom prst="rect">
+            <a:avLst/>
+          </a:prstGeom>
+          <a:noFill/>
+          <a:ln/>
+        </p:spPr>
+        <p:txBody>
+          <a:bodyPr wrap="square" rtlCol="0" anchor="ctr"/>
+          <a:lstStyle/>
+          <a:p>
+            <a:pPr indent="0" marL="0">
+              <a:buNone/>
+            </a:pPr>
+            <a:r>
+              <a:rPr lang="en-US" sz="1500" b="1" dirty="0">
+                <a:solidFill>
+                  <a:srgbClr val="15803D"/>
+                </a:solidFill>
+                <a:latin typeface="Segoe UI" pitchFamily="34" charset="0"/>
+                <a:ea typeface="Segoe UI" pitchFamily="34" charset="-122"/>
+                <a:cs typeface="Segoe UI" pitchFamily="34" charset="-120"/>
+              </a:rPr>
+              <a:t>Shipped</a:t>
+            </a:r>
+            <a:endParaRPr lang="en-US" sz="1500" dirty="0"/>
+          </a:p>
+        </p:txBody>
+      </p:sp>
+      <p:sp>
+        <p:nvSpPr>
+          <p:cNvPr id="7" name="Text 4"/>
+          <p:cNvSpPr/>
+          <p:nvPr/>
+        </p:nvSpPr>
+        <p:spPr>
+          <a:xfrm>
+            <a:off x="731520" y="2011680"/>
+            <a:ext cx="5029200" cy="3291840"/>
+          </a:xfrm>
+          <a:prstGeom prst="rect">
+            <a:avLst/>
+          </a:prstGeom>
+          <a:noFill/>
+          <a:ln/>
+        </p:spPr>
+        <p:txBody>
+          <a:bodyPr wrap="square" rtlCol="0" anchor="ctr"/>
+          <a:lstStyle/>
+          <a:p>
+            <a:pPr indent="0" marL="0">
+              <a:lnSpc>
+                <a:spcPct val="130000"/>
+              </a:lnSpc>
+              <a:buNone/>
+            </a:pPr>
+            <a:r>
+              <a:rPr lang="en-US" sz="1200" dirty="0">
+                <a:solidFill>
+                  <a:srgbClr val="1C2733"/>
+                </a:solidFill>
+                <a:latin typeface="Segoe UI" pitchFamily="34" charset="0"/>
+                <a:ea typeface="Segoe UI" pitchFamily="34" charset="-122"/>
+                <a:cs typeface="Segoe UI" pitchFamily="34" charset="-120"/>
+              </a:rPr>
+              <a:t>Scheduled runs (once / interval / cron)</a:t>
+            </a:r>
+            <a:endParaRPr lang="en-US" sz="1200" dirty="0"/>
+          </a:p>
+          <a:p>
+            <a:pPr indent="0" marL="0">
+              <a:lnSpc>
+                <a:spcPct val="130000"/>
+              </a:lnSpc>
+              <a:buNone/>
+            </a:pPr>
+            <a:r>
+              <a:rPr lang="en-US" sz="1200" dirty="0">
+                <a:solidFill>
+                  <a:srgbClr val="1C2733"/>
+                </a:solidFill>
+                <a:latin typeface="Segoe UI" pitchFamily="34" charset="0"/>
+                <a:ea typeface="Segoe UI" pitchFamily="34" charset="-122"/>
+                <a:cs typeface="Segoe UI" pitchFamily="34" charset="-120"/>
+              </a:rPr>
+              <a:t>Run history with per-session outcomes</a:t>
+            </a:r>
+            <a:endParaRPr lang="en-US" sz="1200" dirty="0"/>
+          </a:p>
+          <a:p>
+            <a:pPr indent="0" marL="0">
+              <a:lnSpc>
+                <a:spcPct val="130000"/>
+              </a:lnSpc>
+              <a:buNone/>
+            </a:pPr>
+            <a:r>
+              <a:rPr lang="en-US" sz="1200" dirty="0">
+                <a:solidFill>
+                  <a:srgbClr val="1C2733"/>
+                </a:solidFill>
+                <a:latin typeface="Segoe UI" pitchFamily="34" charset="0"/>
+                <a:ea typeface="Segoe UI" pitchFamily="34" charset="-122"/>
+                <a:cs typeface="Segoe UI" pitchFamily="34" charset="-120"/>
+              </a:rPr>
+              <a:t>Webhooks + Prometheus /metrics</a:t>
+            </a:r>
+            <a:endParaRPr lang="en-US" sz="1200" dirty="0"/>
+          </a:p>
+          <a:p>
+            <a:pPr indent="0" marL="0">
+              <a:lnSpc>
+                <a:spcPct val="130000"/>
+              </a:lnSpc>
+              <a:buNone/>
+            </a:pPr>
+            <a:r>
+              <a:rPr lang="en-US" sz="1200" dirty="0">
+                <a:solidFill>
+                  <a:srgbClr val="1C2733"/>
+                </a:solidFill>
+                <a:latin typeface="Segoe UI" pitchFamily="34" charset="0"/>
+                <a:ea typeface="Segoe UI" pitchFamily="34" charset="-122"/>
+                <a:cs typeface="Segoe UI" pitchFamily="34" charset="-120"/>
+              </a:rPr>
+              <a:t>API hardening: auth, CORS, headless mode</a:t>
+            </a:r>
+            <a:endParaRPr lang="en-US" sz="1200" dirty="0"/>
+          </a:p>
+          <a:p>
+            <a:pPr indent="0" marL="0">
+              <a:lnSpc>
+                <a:spcPct val="130000"/>
+              </a:lnSpc>
+              <a:buNone/>
+            </a:pPr>
+            <a:r>
+              <a:rPr lang="en-US" sz="1200" dirty="0">
+                <a:solidFill>
+                  <a:srgbClr val="1C2733"/>
+                </a:solidFill>
+                <a:latin typeface="Segoe UI" pitchFamily="34" charset="0"/>
+                <a:ea typeface="Segoe UI" pitchFamily="34" charset="-122"/>
+                <a:cs typeface="Segoe UI" pitchFamily="34" charset="-120"/>
+              </a:rPr>
+              <a:t>OpenAPI 3.1 spec for the whole API</a:t>
+            </a:r>
+            <a:endParaRPr lang="en-US" sz="1200" dirty="0"/>
+          </a:p>
+          <a:p>
+            <a:pPr indent="0" marL="0">
+              <a:lnSpc>
+                <a:spcPct val="130000"/>
+              </a:lnSpc>
+              <a:buNone/>
+            </a:pPr>
+            <a:r>
+              <a:rPr lang="en-US" sz="1200" dirty="0">
+                <a:solidFill>
+                  <a:srgbClr val="1C2733"/>
+                </a:solidFill>
+                <a:latin typeface="Segoe UI" pitchFamily="34" charset="0"/>
+                <a:ea typeface="Segoe UI" pitchFamily="34" charset="-122"/>
+                <a:cs typeface="Segoe UI" pitchFamily="34" charset="-120"/>
+              </a:rPr>
+              <a:t>oltp-emul business-process mode + OLTPEMUL dashboard</a:t>
+            </a:r>
+            <a:endParaRPr lang="en-US" sz="1200" dirty="0"/>
+          </a:p>
+          <a:p>
+            <a:pPr indent="0" marL="0">
+              <a:lnSpc>
+                <a:spcPct val="130000"/>
+              </a:lnSpc>
+              <a:buNone/>
+            </a:pPr>
+            <a:r>
+              <a:rPr lang="en-US" sz="1200" dirty="0">
+                <a:solidFill>
+                  <a:srgbClr val="1C2733"/>
+                </a:solidFill>
+                <a:latin typeface="Segoe UI" pitchFamily="34" charset="0"/>
+                <a:ea typeface="Segoe UI" pitchFamily="34" charset="-122"/>
+                <a:cs typeface="Segoe UI" pitchFamily="34" charset="-120"/>
+              </a:rPr>
+              <a:t>Extended load mix: tx variants, operations log,</a:t>
+            </a:r>
+            <a:endParaRPr lang="en-US" sz="1200" dirty="0"/>
+          </a:p>
+          <a:p>
+            <a:pPr indent="0" marL="0">
+              <a:lnSpc>
+                <a:spcPct val="130000"/>
+              </a:lnSpc>
+              <a:buNone/>
+            </a:pPr>
+            <a:r>
+              <a:rPr lang="en-US" sz="1200" dirty="0">
+                <a:solidFill>
+                  <a:srgbClr val="1C2733"/>
+                </a:solidFill>
+                <a:latin typeface="Segoe UI" pitchFamily="34" charset="0"/>
+                <a:ea typeface="Segoe UI" pitchFamily="34" charset="-122"/>
+                <a:cs typeface="Segoe UI" pitchFamily="34" charset="-120"/>
+              </a:rPr>
+              <a:t>heavy/bulk sidecars, -plusddl, --no-limbo</a:t>
+            </a:r>
+            <a:endParaRPr lang="en-US" sz="1200" dirty="0"/>
+          </a:p>
+          <a:p>
+            <a:pPr indent="0" marL="0">
+              <a:lnSpc>
+                <a:spcPct val="130000"/>
+              </a:lnSpc>
+              <a:buNone/>
+            </a:pPr>
+            <a:r>
+              <a:rPr lang="en-US" sz="1200" dirty="0">
+                <a:solidFill>
+                  <a:srgbClr val="1C2733"/>
+                </a:solidFill>
+                <a:latin typeface="Segoe UI" pitchFamily="34" charset="0"/>
+                <a:ea typeface="Segoe UI" pitchFamily="34" charset="-122"/>
+                <a:cs typeface="Segoe UI" pitchFamily="34" charset="-120"/>
+              </a:rPr>
+              <a:t>Field diagnostics: LWM probe + limbo-crash reproducer</a:t>
+            </a:r>
+            <a:endParaRPr lang="en-US" sz="1200" dirty="0"/>
+          </a:p>
+          <a:p>
+            <a:pPr indent="0" marL="0">
+              <a:lnSpc>
+                <a:spcPct val="130000"/>
+              </a:lnSpc>
+              <a:buNone/>
+            </a:pPr>
+            <a:r>
+              <a:rPr lang="en-US" sz="1200" dirty="0">
+                <a:solidFill>
+                  <a:srgbClr val="1C2733"/>
+                </a:solidFill>
+                <a:latin typeface="Segoe UI" pitchFamily="34" charset="0"/>
+                <a:ea typeface="Segoe UI" pitchFamily="34" charset="-122"/>
+                <a:cs typeface="Segoe UI" pitchFamily="34" charset="-120"/>
+              </a:rPr>
+              <a:t>CI (vet + race + 3 OS) and multi-platform releases</a:t>
+            </a:r>
+            <a:endParaRPr lang="en-US" sz="1200" dirty="0"/>
+          </a:p>
+          <a:p>
+            <a:pPr indent="0" marL="0">
+              <a:lnSpc>
+                <a:spcPct val="130000"/>
+              </a:lnSpc>
+              <a:buNone/>
+            </a:pPr>
+            <a:r>
+              <a:rPr lang="en-US" sz="1200" dirty="0">
+                <a:solidFill>
+                  <a:srgbClr val="1C2733"/>
+                </a:solidFill>
+                <a:latin typeface="Segoe UI" pitchFamily="34" charset="0"/>
+                <a:ea typeface="Segoe UI" pitchFamily="34" charset="-122"/>
+                <a:cs typeface="Segoe UI" pitchFamily="34" charset="-120"/>
+              </a:rPr>
+              <a:t>IBSurgeon driver fork under the hood</a:t>
+            </a:r>
+            <a:endParaRPr lang="en-US" sz="1200" dirty="0"/>
+          </a:p>
+        </p:txBody>
+      </p:sp>
+      <p:sp>
+        <p:nvSpPr>
+          <p:cNvPr id="8" name="Shape 5"/>
+          <p:cNvSpPr/>
+          <p:nvPr/>
+        </p:nvSpPr>
+        <p:spPr>
+          <a:xfrm>
+            <a:off x="6217920" y="1371600"/>
+            <a:ext cx="5486400" cy="4297680"/>
+          </a:xfrm>
+          <a:prstGeom prst="roundRect">
+            <a:avLst>
+              <a:gd name="adj" fmla="val 1277"/>
+            </a:avLst>
+          </a:prstGeom>
+          <a:solidFill>
+            <a:srgbClr val="FFFFFF"/>
+          </a:solidFill>
+          <a:ln w="12700">
+            <a:solidFill>
+              <a:srgbClr val="D8DFE8"/>
+            </a:solidFill>
+            <a:prstDash val="solid"/>
+          </a:ln>
+        </p:spPr>
+      </p:sp>
+      <p:sp>
+        <p:nvSpPr>
+          <p:cNvPr id="9" name="Text 6"/>
+          <p:cNvSpPr/>
+          <p:nvPr/>
+        </p:nvSpPr>
+        <p:spPr>
+          <a:xfrm>
+            <a:off x="6446520" y="1554480"/>
+            <a:ext cx="5029200" cy="365760"/>
+          </a:xfrm>
+          <a:prstGeom prst="rect">
+            <a:avLst/>
+          </a:prstGeom>
+          <a:noFill/>
+          <a:ln/>
+        </p:spPr>
+        <p:txBody>
+          <a:bodyPr wrap="square" rtlCol="0" anchor="ctr"/>
+          <a:lstStyle/>
+          <a:p>
+            <a:pPr indent="0" marL="0">
+              <a:buNone/>
+            </a:pPr>
+            <a:r>
+              <a:rPr lang="en-US" sz="1500" b="1" dirty="0">
+                <a:solidFill>
+                  <a:srgbClr val="2563EB"/>
+                </a:solidFill>
+                <a:latin typeface="Segoe UI" pitchFamily="34" charset="0"/>
+                <a:ea typeface="Segoe UI" pitchFamily="34" charset="-122"/>
+                <a:cs typeface="Segoe UI" pitchFamily="34" charset="-120"/>
+              </a:rPr>
+              <a:t>Next</a:t>
+            </a:r>
+            <a:endParaRPr lang="en-US" sz="1500" dirty="0"/>
+          </a:p>
+        </p:txBody>
+      </p:sp>
+      <p:sp>
+        <p:nvSpPr>
+          <p:cNvPr id="10" name="Text 7"/>
+          <p:cNvSpPr/>
+          <p:nvPr/>
+        </p:nvSpPr>
+        <p:spPr>
+          <a:xfrm>
+            <a:off x="6446520" y="2011680"/>
+            <a:ext cx="5029200" cy="3291840"/>
+          </a:xfrm>
+          <a:prstGeom prst="rect">
+            <a:avLst/>
+          </a:prstGeom>
+          <a:noFill/>
+          <a:ln/>
+        </p:spPr>
+        <p:txBody>
+          <a:bodyPr wrap="square" rtlCol="0" anchor="ctr"/>
+          <a:lstStyle/>
+          <a:p>
+            <a:pPr indent="0" marL="0">
+              <a:lnSpc>
+                <a:spcPct val="140000"/>
+              </a:lnSpc>
+              <a:buNone/>
+            </a:pPr>
+            <a:r>
+              <a:rPr lang="en-US" sz="1350" dirty="0">
+                <a:solidFill>
+                  <a:srgbClr val="1C2733"/>
+                </a:solidFill>
+                <a:latin typeface="Segoe UI" pitchFamily="34" charset="0"/>
+                <a:ea typeface="Segoe UI" pitchFamily="34" charset="-122"/>
+                <a:cs typeface="Segoe UI" pitchFamily="34" charset="-120"/>
+              </a:rPr>
+              <a:t>Secure credential storage (no plaintext settings)</a:t>
+            </a:r>
+            <a:endParaRPr lang="en-US" sz="1350" dirty="0"/>
+          </a:p>
+          <a:p>
+            <a:pPr indent="0" marL="0">
+              <a:lnSpc>
+                <a:spcPct val="140000"/>
+              </a:lnSpc>
+              <a:buNone/>
+            </a:pPr>
+            <a:r>
+              <a:rPr lang="en-US" sz="1350" dirty="0">
+                <a:solidFill>
+                  <a:srgbClr val="1C2733"/>
+                </a:solidFill>
+                <a:latin typeface="Segoe UI" pitchFamily="34" charset="0"/>
+                <a:ea typeface="Segoe UI" pitchFamily="34" charset="-122"/>
+                <a:cs typeface="Segoe UI" pitchFamily="34" charset="-120"/>
+              </a:rPr>
+              <a:t>Schedule chains (run A, then B)</a:t>
+            </a:r>
+            <a:endParaRPr lang="en-US" sz="1350" dirty="0"/>
+          </a:p>
+          <a:p>
+            <a:pPr indent="0" marL="0">
+              <a:lnSpc>
+                <a:spcPct val="140000"/>
+              </a:lnSpc>
+              <a:buNone/>
+            </a:pPr>
+            <a:r>
+              <a:rPr lang="en-US" sz="1350" dirty="0">
+                <a:solidFill>
+                  <a:srgbClr val="1C2733"/>
+                </a:solidFill>
+                <a:latin typeface="Segoe UI" pitchFamily="34" charset="0"/>
+                <a:ea typeface="Segoe UI" pitchFamily="34" charset="-122"/>
+                <a:cs typeface="Segoe UI" pitchFamily="34" charset="-120"/>
+              </a:rPr>
+              <a:t>Your use case here — tell us what you need</a:t>
+            </a:r>
+            <a:endParaRPr lang="en-US" sz="1350" dirty="0"/>
+          </a:p>
+        </p:txBody>
+      </p:sp>
+      <p:sp>
+        <p:nvSpPr>
+          <p:cNvPr id="11" name="Text 8"/>
+          <p:cNvSpPr/>
+          <p:nvPr/>
+        </p:nvSpPr>
+        <p:spPr>
+          <a:xfrm>
+            <a:off x="521208" y="5943600"/>
+            <a:ext cx="11155680" cy="365760"/>
+          </a:xfrm>
+          <a:prstGeom prst="rect">
+            <a:avLst/>
+          </a:prstGeom>
+          <a:noFill/>
+          <a:ln/>
+        </p:spPr>
+        <p:txBody>
+          <a:bodyPr wrap="square" rtlCol="0" anchor="ctr"/>
+          <a:lstStyle/>
+          <a:p>
+            <a:pPr algn="ctr" indent="0" marL="0">
+              <a:buNone/>
+            </a:pPr>
+            <a:r>
+              <a:rPr lang="en-US" sz="1300" b="1" dirty="0">
+                <a:solidFill>
+                  <a:srgbClr val="1C2733"/>
+                </a:solidFill>
+                <a:latin typeface="Segoe UI" pitchFamily="34" charset="0"/>
+                <a:ea typeface="Segoe UI" pitchFamily="34" charset="-122"/>
+                <a:cs typeface="Segoe UI" pitchFamily="34" charset="-120"/>
+              </a:rPr>
+              <a:t>Docs: </a:t>
+            </a:r>
+            <a:pPr algn="ctr" indent="0" marL="0">
+              <a:buNone/>
+            </a:pPr>
+            <a:r>
+              <a:rPr lang="en-US" sz="1300" dirty="0">
+                <a:solidFill>
+                  <a:srgbClr val="2563EB"/>
+                </a:solidFill>
+                <a:latin typeface="Segoe UI" pitchFamily="34" charset="0"/>
+                <a:ea typeface="Segoe UI" pitchFamily="34" charset="-122"/>
+                <a:cs typeface="Segoe UI" pitchFamily="34" charset="-120"/>
+              </a:rPr>
+              <a:t>README.md · API.md · IMPROVEMENTS.md</a:t>
+            </a:r>
+            <a:pPr algn="ctr" indent="0" marL="0">
+              <a:buNone/>
+            </a:pPr>
+            <a:r>
+              <a:rPr lang="en-US" sz="1300" b="1" dirty="0">
+                <a:solidFill>
+                  <a:srgbClr val="1C2733"/>
+                </a:solidFill>
+                <a:latin typeface="Segoe UI" pitchFamily="34" charset="0"/>
+                <a:ea typeface="Segoe UI" pitchFamily="34" charset="-122"/>
+                <a:cs typeface="Segoe UI" pitchFamily="34" charset="-120"/>
+              </a:rPr>
+              <a:t>      Start:  </a:t>
+            </a:r>
+            <a:pPr algn="ctr" indent="0" marL="0">
+              <a:buNone/>
+            </a:pPr>
+            <a:r>
+              <a:rPr lang="en-US" sz="1300" dirty="0">
+                <a:solidFill>
+                  <a:srgbClr val="2563EB"/>
+                </a:solidFill>
+                <a:latin typeface="Consolas" pitchFamily="34" charset="0"/>
+                <a:ea typeface="Consolas" pitchFamily="34" charset="-122"/>
+                <a:cs typeface="Consolas" pitchFamily="34" charset="-120"/>
+              </a:rPr>
+              <a:t>fb-loadgen --ui</a:t>
+            </a:r>
+            <a:endParaRPr lang="en-US" sz="1300" dirty="0"/>
+          </a:p>
+        </p:txBody>
+      </p:sp>
+    </p:spTree>
+  </p:cSld>
+  <p:clrMapOvr>
+    <a:masterClrMapping/>
+  </p:clrMapOvr>
+</p:sld>
+</file>
+
+<file path=ppt/slides/slide23.xml><?xml version="1.0" encoding="utf-8"?>
+<p:sld xmlns:a="http://schemas.openxmlformats.org/drawingml/2006/main" xmlns:r="http://schemas.openxmlformats.org/officeDocument/2006/relationships" xmlns:p="http://schemas.openxmlformats.org/presentationml/2006/main">
+  <p:cSld name="Slide 23">
+    <p:bg>
+      <p:bgPr>
+        <a:solidFill>
+          <a:srgbClr val="F5F7FA"/>
+        </a:solidFill>
+      </p:bgPr>
+    </p:bg>
+    <p:spTree>
+      <p:nvGrpSpPr>
+        <p:cNvPr id="1" name=""/>
+        <p:cNvGrpSpPr/>
+        <p:nvPr/>
+      </p:nvGrpSpPr>
+      <p:grpSpPr>
+        <a:xfrm>
+          <a:off x="0" y="0"/>
+          <a:ext cx="0" cy="0"/>
+          <a:chOff x="0" y="0"/>
+          <a:chExt cx="0" cy="0"/>
+        </a:xfrm>
+      </p:grpSpPr>
+      <p:sp>
+        <p:nvSpPr>
+          <p:cNvPr id="2" name="Text 0"/>
+          <p:cNvSpPr/>
+          <p:nvPr/>
+        </p:nvSpPr>
+        <p:spPr>
+          <a:xfrm>
+            <a:off x="502920" y="256032"/>
+            <a:ext cx="11185855" cy="548640"/>
+          </a:xfrm>
+          <a:prstGeom prst="rect">
+            <a:avLst/>
+          </a:prstGeom>
+          <a:noFill/>
+          <a:ln/>
+        </p:spPr>
+        <p:txBody>
+          <a:bodyPr wrap="square" rtlCol="0" anchor="ctr"/>
+          <a:lstStyle/>
+          <a:p>
+            <a:pPr indent="0" marL="0">
+              <a:buNone/>
+            </a:pPr>
+            <a:r>
+              <a:rPr lang="en-US" sz="2700" b="1" dirty="0">
+                <a:solidFill>
+                  <a:srgbClr val="1C2733"/>
+                </a:solidFill>
+                <a:latin typeface="Segoe UI" pitchFamily="34" charset="0"/>
+                <a:ea typeface="Segoe UI" pitchFamily="34" charset="-122"/>
+                <a:cs typeface="Segoe UI" pitchFamily="34" charset="-120"/>
+              </a:rPr>
+              <a:t>Appendix — quick reference</a:t>
+            </a:r>
+            <a:endParaRPr lang="en-US" sz="2700" dirty="0"/>
+          </a:p>
+        </p:txBody>
+      </p:sp>
+      <p:sp>
+        <p:nvSpPr>
+          <p:cNvPr id="3" name="Text 1"/>
+          <p:cNvSpPr/>
+          <p:nvPr/>
+        </p:nvSpPr>
+        <p:spPr>
+          <a:xfrm>
+            <a:off x="8899855" y="6473952"/>
+            <a:ext cx="3017520" cy="274320"/>
+          </a:xfrm>
+          <a:prstGeom prst="rect">
+            <a:avLst/>
+          </a:prstGeom>
+          <a:noFill/>
+          <a:ln/>
+        </p:spPr>
+        <p:txBody>
+          <a:bodyPr wrap="square" rtlCol="0" anchor="ctr"/>
+          <a:lstStyle/>
+          <a:p>
+            <a:pPr algn="r" indent="0" marL="0">
+              <a:buNone/>
+            </a:pPr>
+            <a:r>
+              <a:rPr lang="en-US" sz="900" dirty="0">
+                <a:solidFill>
+                  <a:srgbClr val="5F6F83"/>
+                </a:solidFill>
+                <a:latin typeface="Segoe UI" pitchFamily="34" charset="0"/>
+                <a:ea typeface="Segoe UI" pitchFamily="34" charset="-122"/>
+                <a:cs typeface="Segoe UI" pitchFamily="34" charset="-120"/>
+              </a:rPr>
+              <a:t>IBSurgeon Firebird Load Generator</a:t>
+            </a:r>
+            <a:pPr algn="r" indent="0" marL="0">
+              <a:buNone/>
+            </a:pPr>
+            <a:r>
+              <a:rPr lang="en-US" sz="900" b="1" dirty="0">
+                <a:solidFill>
+                  <a:srgbClr val="2563EB"/>
+                </a:solidFill>
+                <a:latin typeface="Segoe UI" pitchFamily="34" charset="0"/>
+                <a:ea typeface="Segoe UI" pitchFamily="34" charset="-122"/>
+                <a:cs typeface="Segoe UI" pitchFamily="34" charset="-120"/>
+              </a:rPr>
+              <a:t>   |   23</a:t>
             </a:r>
             <a:endParaRPr lang="en-US" sz="900" dirty="0"/>
           </a:p>
@@ -12159,7 +14889,7 @@
                 <a:ea typeface="Consolas" pitchFamily="34" charset="-122"/>
                 <a:cs typeface="Consolas" pitchFamily="34" charset="-120"/>
               </a:rPr>
-              <a:t># control</a:t>
+              <a:t># extended load</a:t>
             </a:r>
             <a:endParaRPr lang="en-US" sz="1050" dirty="0"/>
           </a:p>
@@ -12176,7 +14906,7 @@
                 <a:ea typeface="Consolas" pitchFamily="34" charset="-122"/>
                 <a:cs typeface="Consolas" pitchFamily="34" charset="-120"/>
               </a:rPr>
-              <a:t>GET  /api/sessions            GET  /api/fleet</a:t>
+              <a:t>fb-loadgen --no-limbo        # same mix, no limbo generation</a:t>
             </a:r>
             <a:endParaRPr lang="en-US" sz="1050" dirty="0"/>
           </a:p>
@@ -12193,7 +14923,7 @@
                 <a:ea typeface="Consolas" pitchFamily="34" charset="-122"/>
                 <a:cs typeface="Consolas" pitchFamily="34" charset="-120"/>
               </a:rPr>
-              <a:t>POST /api/sessions/{id}/start      {"timeLimitMin": 15, "wait": false}</a:t>
+              <a:t>PATCH /api/sessions/{id}  {"extendedLoad":{"txVariants":{"noLimbo":true}}}</a:t>
             </a:r>
             <a:endParaRPr lang="en-US" sz="1050" dirty="0"/>
           </a:p>
@@ -12210,8 +14940,14 @@
                 <a:ea typeface="Consolas" pitchFamily="34" charset="-122"/>
                 <a:cs typeface="Consolas" pitchFamily="34" charset="-120"/>
               </a:rPr>
-              <a:t>POST /api/sessions/{id}/stop | pause | resume | validate</a:t>
-            </a:r>
+              <a:t>fb-loadgen lwmprobe --action select --fblog &lt;firebird.log&gt;</a:t>
+            </a:r>
+            <a:endParaRPr lang="en-US" sz="1050" dirty="0"/>
+          </a:p>
+          <a:p>
+            <a:pPr indent="0" marL="0">
+              <a:buNone/>
+            </a:pPr>
             <a:endParaRPr lang="en-US" sz="1050" dirty="0"/>
           </a:p>
           <a:p>
@@ -12227,14 +14963,8 @@
                 <a:ea typeface="Consolas" pitchFamily="34" charset="-122"/>
                 <a:cs typeface="Consolas" pitchFamily="34" charset="-120"/>
               </a:rPr>
-              <a:t>POST /api/sessions/start-all | stop-all | pause-all</a:t>
-            </a:r>
-            <a:endParaRPr lang="en-US" sz="1050" dirty="0"/>
-          </a:p>
-          <a:p>
-            <a:pPr indent="0" marL="0">
-              <a:buNone/>
-            </a:pPr>
+              <a:t># control</a:t>
+            </a:r>
             <a:endParaRPr lang="en-US" sz="1050" dirty="0"/>
           </a:p>
           <a:p>
@@ -12250,7 +14980,7 @@
                 <a:ea typeface="Consolas" pitchFamily="34" charset="-122"/>
                 <a:cs typeface="Consolas" pitchFamily="34" charset="-120"/>
               </a:rPr>
-              <a:t># schedule + history</a:t>
+              <a:t>GET  /api/sessions            GET  /api/fleet</a:t>
             </a:r>
             <a:endParaRPr lang="en-US" sz="1050" dirty="0"/>
           </a:p>
@@ -12267,7 +14997,7 @@
                 <a:ea typeface="Consolas" pitchFamily="34" charset="-122"/>
                 <a:cs typeface="Consolas" pitchFamily="34" charset="-120"/>
               </a:rPr>
-              <a:t>GET|POST /api/schedules       PATCH|DELETE /api/schedules/{id}</a:t>
+              <a:t>POST /api/sessions/{id}/start      {"timeLimitMin": 15, "wait": false}</a:t>
             </a:r>
             <a:endParaRPr lang="en-US" sz="1050" dirty="0"/>
           </a:p>
@@ -12284,8 +15014,14 @@
                 <a:ea typeface="Consolas" pitchFamily="34" charset="-122"/>
                 <a:cs typeface="Consolas" pitchFamily="34" charset="-120"/>
               </a:rPr>
-              <a:t>POST /api/schedules/{id}/trigger</a:t>
-            </a:r>
+              <a:t>POST /api/sessions/{id}/stop | pause | resume | validate</a:t>
+            </a:r>
+            <a:endParaRPr lang="en-US" sz="1050" dirty="0"/>
+          </a:p>
+          <a:p>
+            <a:pPr indent="0" marL="0">
+              <a:buNone/>
+            </a:pPr>
             <a:endParaRPr lang="en-US" sz="1050" dirty="0"/>
           </a:p>
           <a:p>
@@ -12301,7 +15037,7 @@
                 <a:ea typeface="Consolas" pitchFamily="34" charset="-122"/>
                 <a:cs typeface="Consolas" pitchFamily="34" charset="-120"/>
               </a:rPr>
-              <a:t>GET  /api/runs | /api/runs/{id} | POST /api/runs/{id}/cancel</a:t>
+              <a:t># schedule + history</a:t>
             </a:r>
             <a:endParaRPr lang="en-US" sz="1050" dirty="0"/>
           </a:p>
@@ -12318,7 +15054,41 @@
                 <a:ea typeface="Consolas" pitchFamily="34" charset="-122"/>
                 <a:cs typeface="Consolas" pitchFamily="34" charset="-120"/>
               </a:rPr>
-              <a:t>GET  /api/sessions/{id}/runs | /report | /report/{file}</a:t>
+              <a:t>GET|POST /api/schedules       PATCH|DELETE /api/schedules/{id}</a:t>
+            </a:r>
+            <a:endParaRPr lang="en-US" sz="1050" dirty="0"/>
+          </a:p>
+          <a:p>
+            <a:pPr indent="0" marL="0">
+              <a:buNone/>
+            </a:pPr>
+            <a:r>
+              <a:rPr lang="en-US" sz="1050" dirty="0">
+                <a:solidFill>
+                  <a:srgbClr val="E7ECF3"/>
+                </a:solidFill>
+                <a:latin typeface="Consolas" pitchFamily="34" charset="0"/>
+                <a:ea typeface="Consolas" pitchFamily="34" charset="-122"/>
+                <a:cs typeface="Consolas" pitchFamily="34" charset="-120"/>
+              </a:rPr>
+              <a:t>POST /api/schedules/{id}/trigger</a:t>
+            </a:r>
+            <a:endParaRPr lang="en-US" sz="1050" dirty="0"/>
+          </a:p>
+          <a:p>
+            <a:pPr indent="0" marL="0">
+              <a:buNone/>
+            </a:pPr>
+            <a:r>
+              <a:rPr lang="en-US" sz="1050" dirty="0">
+                <a:solidFill>
+                  <a:srgbClr val="E7ECF3"/>
+                </a:solidFill>
+                <a:latin typeface="Consolas" pitchFamily="34" charset="0"/>
+                <a:ea typeface="Consolas" pitchFamily="34" charset="-122"/>
+                <a:cs typeface="Consolas" pitchFamily="34" charset="-120"/>
+              </a:rPr>
+              <a:t>GET  /api/runs | /api/runs/{id} | POST /api/runs/{id}/cancel</a:t>
             </a:r>
             <a:endParaRPr lang="en-US" sz="1050" dirty="0"/>
           </a:p>

</xml_diff>

<commit_message>
Deck: 24 slides — 'Hardened & verified' review-round slide, roadmap/appendix updates
</commit_message>
<xml_diff>
--- a/IBSurgeon_LoadGenerator.pptx
+++ b/IBSurgeon_LoadGenerator.pptx
@@ -28,9 +28,10 @@
     <p:sldId id="276" r:id="rId22"/>
     <p:sldId id="277" r:id="rId23"/>
     <p:sldId id="278" r:id="rId24"/>
+    <p:sldId id="279" r:id="rId25"/>
   </p:sldIdLst>
   <p:notesMasterIdLst>
-    <p:notesMasterId r:id="rId25"/>
+    <p:notesMasterId r:id="rId26"/>
   </p:notesMasterIdLst>
   <p:sldSz cx="12191695" cy="6858000"/>
   <p:notesSz cx="6858000" cy="12191695"/>
@@ -2303,7 +2304,7 @@
           <a:p>
             <a:r>
               <a:rPr lang="en-US" dirty="0"/>
-              <a:t>Full tables live in API.md and README.md.</a:t>
+              <a:t>Report: CODE_REVIEW_2026-09-28.md. The sidecar pool starvation surfaced only when every workload variant was run on a three-server lab (FB 3/4/5) — exactly the failure mode a silent BeginTx block produces. All other criticals came from the review and carry regression tests; CI now runs a live Firebird 5.0 smoke.</a:t>
             </a:r>
             <a:endParaRPr lang="en-US" dirty="0"/>
           </a:p>
@@ -2327,6 +2328,94 @@
             <a:fld id="{F7021451-1387-4CA6-816F-3879F97B5CBC}" type="slidenum">
               <a:rPr lang="en-US"/>
               <a:t>23</a:t>
+            </a:fld>
+            <a:endParaRPr lang="en-US"/>
+          </a:p>
+        </p:txBody>
+      </p:sp>
+    </p:spTree>
+    <p:extLst>
+      <p:ext uri="{BB962C8B-B14F-4D97-AF65-F5344CB8AC3E}">
+        <p14:creationId xmlns:p14="http://schemas.microsoft.com/office/powerpoint/2010/main" val="1024086991"/>
+      </p:ext>
+    </p:extLst>
+  </p:cSld>
+  <p:clrMapOvr>
+    <a:masterClrMapping/>
+  </p:clrMapOvr>
+</p:notes>
+</file>
+
+<file path=ppt/notesSlides/notesSlide24.xml><?xml version="1.0" encoding="utf-8"?>
+<p:notes xmlns:a="http://schemas.openxmlformats.org/drawingml/2006/main" xmlns:r="http://schemas.openxmlformats.org/officeDocument/2006/relationships" xmlns:p="http://schemas.openxmlformats.org/presentationml/2006/main">
+  <p:cSld>
+    <p:spTree>
+      <p:nvGrpSpPr>
+        <p:cNvPr id="1" name=""/>
+        <p:cNvGrpSpPr/>
+        <p:nvPr/>
+      </p:nvGrpSpPr>
+      <p:grpSpPr>
+        <a:xfrm>
+          <a:off x="0" y="0"/>
+          <a:ext cx="0" cy="0"/>
+          <a:chOff x="0" y="0"/>
+          <a:chExt cx="0" cy="0"/>
+        </a:xfrm>
+      </p:grpSpPr>
+      <p:sp>
+        <p:nvSpPr>
+          <p:cNvPr id="2" name="Slide Image Placeholder 1"/>
+          <p:cNvSpPr>
+            <a:spLocks noGrp="1" noRot="1" noChangeAspect="1"/>
+          </p:cNvSpPr>
+          <p:nvPr>
+            <p:ph type="sldImg"/>
+          </p:nvPr>
+        </p:nvSpPr>
+        <p:spPr/>
+      </p:sp>
+      <p:sp>
+        <p:nvSpPr>
+          <p:cNvPr id="3" name="Notes Placeholder 2"/>
+          <p:cNvSpPr>
+            <a:spLocks noGrp="1"/>
+          </p:cNvSpPr>
+          <p:nvPr>
+            <p:ph type="body" idx="1"/>
+          </p:nvPr>
+        </p:nvSpPr>
+        <p:spPr/>
+        <p:txBody>
+          <a:bodyPr/>
+          <a:lstStyle/>
+          <a:p>
+            <a:r>
+              <a:rPr lang="en-US" dirty="0"/>
+              <a:t>Full tables live in API.md and README.md.</a:t>
+            </a:r>
+            <a:endParaRPr lang="en-US" dirty="0"/>
+          </a:p>
+        </p:txBody>
+      </p:sp>
+      <p:sp>
+        <p:nvSpPr>
+          <p:cNvPr id="4" name="Slide Number Placeholder 3"/>
+          <p:cNvSpPr>
+            <a:spLocks noGrp="1"/>
+          </p:cNvSpPr>
+          <p:nvPr>
+            <p:ph type="sldNum" sz="quarter" idx="10"/>
+          </p:nvPr>
+        </p:nvSpPr>
+        <p:spPr/>
+        <p:txBody>
+          <a:bodyPr/>
+          <a:lstStyle/>
+          <a:p>
+            <a:fld id="{F7021451-1387-4CA6-816F-3879F97B5CBC}" type="slidenum">
+              <a:rPr lang="en-US"/>
+              <a:t>24</a:t>
             </a:fld>
             <a:endParaRPr lang="en-US"/>
           </a:p>
@@ -14218,7 +14307,7 @@
                 <a:ea typeface="Segoe UI" pitchFamily="34" charset="-122"/>
                 <a:cs typeface="Segoe UI" pitchFamily="34" charset="-120"/>
               </a:rPr>
-              <a:t>Scheduled runs (once / interval / cron)</a:t>
+              <a:t>Scheduled runs (cron / interval) + run history</a:t>
             </a:r>
             <a:endParaRPr lang="en-US" sz="1200" dirty="0"/>
           </a:p>
@@ -14238,7 +14327,7 @@
                 <a:ea typeface="Segoe UI" pitchFamily="34" charset="-122"/>
                 <a:cs typeface="Segoe UI" pitchFamily="34" charset="-120"/>
               </a:rPr>
-              <a:t>Run history with per-session outcomes</a:t>
+              <a:t>Webhooks + Prometheus /metrics</a:t>
             </a:r>
             <a:endParaRPr lang="en-US" sz="1200" dirty="0"/>
           </a:p>
@@ -14258,7 +14347,7 @@
                 <a:ea typeface="Segoe UI" pitchFamily="34" charset="-122"/>
                 <a:cs typeface="Segoe UI" pitchFamily="34" charset="-120"/>
               </a:rPr>
-              <a:t>Webhooks + Prometheus /metrics</a:t>
+              <a:t>API hardening: auth, CORS, headless mode</a:t>
             </a:r>
             <a:endParaRPr lang="en-US" sz="1200" dirty="0"/>
           </a:p>
@@ -14278,7 +14367,7 @@
                 <a:ea typeface="Segoe UI" pitchFamily="34" charset="-122"/>
                 <a:cs typeface="Segoe UI" pitchFamily="34" charset="-120"/>
               </a:rPr>
-              <a:t>API hardening: auth, CORS, headless mode</a:t>
+              <a:t>OpenAPI 3.1 spec for the whole API</a:t>
             </a:r>
             <a:endParaRPr lang="en-US" sz="1200" dirty="0"/>
           </a:p>
@@ -14298,7 +14387,7 @@
                 <a:ea typeface="Segoe UI" pitchFamily="34" charset="-122"/>
                 <a:cs typeface="Segoe UI" pitchFamily="34" charset="-120"/>
               </a:rPr>
-              <a:t>OpenAPI 3.1 spec for the whole API</a:t>
+              <a:t>oltp-emul business-process mode + OLTPEMUL dashboard</a:t>
             </a:r>
             <a:endParaRPr lang="en-US" sz="1200" dirty="0"/>
           </a:p>
@@ -14318,7 +14407,7 @@
                 <a:ea typeface="Segoe UI" pitchFamily="34" charset="-122"/>
                 <a:cs typeface="Segoe UI" pitchFamily="34" charset="-120"/>
               </a:rPr>
-              <a:t>oltp-emul business-process mode + OLTPEMUL dashboard</a:t>
+              <a:t>Extended load mix: tx variants, operations log,</a:t>
             </a:r>
             <a:endParaRPr lang="en-US" sz="1200" dirty="0"/>
           </a:p>
@@ -14338,7 +14427,7 @@
                 <a:ea typeface="Segoe UI" pitchFamily="34" charset="-122"/>
                 <a:cs typeface="Segoe UI" pitchFamily="34" charset="-120"/>
               </a:rPr>
-              <a:t>Extended load mix: tx variants, operations log,</a:t>
+              <a:t>heavy/bulk sidecars, -plusddl, --no-limbo</a:t>
             </a:r>
             <a:endParaRPr lang="en-US" sz="1200" dirty="0"/>
           </a:p>
@@ -14358,7 +14447,7 @@
                 <a:ea typeface="Segoe UI" pitchFamily="34" charset="-122"/>
                 <a:cs typeface="Segoe UI" pitchFamily="34" charset="-120"/>
               </a:rPr>
-              <a:t>heavy/bulk sidecars, -plusddl, --no-limbo</a:t>
+              <a:t>Field diagnostics: LWM probe + limbo-crash reproducer</a:t>
             </a:r>
             <a:endParaRPr lang="en-US" sz="1200" dirty="0"/>
           </a:p>
@@ -14378,7 +14467,7 @@
                 <a:ea typeface="Segoe UI" pitchFamily="34" charset="-122"/>
                 <a:cs typeface="Segoe UI" pitchFamily="34" charset="-120"/>
               </a:rPr>
-              <a:t>Field diagnostics: LWM probe + limbo-crash reproducer</a:t>
+              <a:t>Hardening round: race fixes, worker self-heal,</a:t>
             </a:r>
             <a:endParaRPr lang="en-US" sz="1200" dirty="0"/>
           </a:p>
@@ -14398,7 +14487,27 @@
                 <a:ea typeface="Segoe UI" pitchFamily="34" charset="-122"/>
                 <a:cs typeface="Segoe UI" pitchFamily="34" charset="-120"/>
               </a:rPr>
-              <a:t>CI (vet + race + 3 OS) and multi-platform releases</a:t>
+              <a:t>invariant isolation, secure-by-default UI</a:t>
+            </a:r>
+            <a:endParaRPr lang="en-US" sz="1200" dirty="0"/>
+          </a:p>
+          <a:p>
+            <a:pPr indent="0" marL="0">
+              <a:lnSpc>
+                <a:spcPct val="130000"/>
+              </a:lnSpc>
+              <a:buNone/>
+            </a:pPr>
+            <a:r>
+              <a:rPr lang="en-US" sz="1200" dirty="0">
+                <a:solidFill>
+                  <a:srgbClr val="1C2733"/>
+                </a:solidFill>
+                <a:latin typeface="Segoe UI" pitchFamily="34" charset="0"/>
+                <a:ea typeface="Segoe UI" pitchFamily="34" charset="-122"/>
+                <a:cs typeface="Segoe UI" pitchFamily="34" charset="-120"/>
+              </a:rPr>
+              <a:t>CI (gofmt + vet + race + Firebird smoke), multi-platform releases</a:t>
             </a:r>
             <a:endParaRPr lang="en-US" sz="1200" dirty="0"/>
           </a:p>
@@ -14619,7 +14728,7 @@
                 <a:ea typeface="Segoe UI" pitchFamily="34" charset="-122"/>
                 <a:cs typeface="Segoe UI" pitchFamily="34" charset="-120"/>
               </a:rPr>
-              <a:t>README.md · API.md · IMPROVEMENTS.md</a:t>
+              <a:t>README.md · API.md · docs/history/</a:t>
             </a:r>
             <a:pPr algn="ctr" indent="0" marL="0">
               <a:buNone/>
@@ -14718,7 +14827,7 @@
                 <a:ea typeface="Segoe UI" pitchFamily="34" charset="-122"/>
                 <a:cs typeface="Segoe UI" pitchFamily="34" charset="-120"/>
               </a:rPr>
-              <a:t>Appendix — quick reference</a:t>
+              <a:t>Hardened &amp; verified — the review round</a:t>
             </a:r>
             <a:endParaRPr lang="en-US" sz="2700" dirty="0"/>
           </a:p>
@@ -14727,6 +14836,45 @@
       <p:sp>
         <p:nvSpPr>
           <p:cNvPr id="3" name="Text 1"/>
+          <p:cNvSpPr/>
+          <p:nvPr/>
+        </p:nvSpPr>
+        <p:spPr>
+          <a:xfrm>
+            <a:off x="521208" y="786384"/>
+            <a:ext cx="11185855" cy="310896"/>
+          </a:xfrm>
+          <a:prstGeom prst="rect">
+            <a:avLst/>
+          </a:prstGeom>
+          <a:noFill/>
+          <a:ln/>
+        </p:spPr>
+        <p:txBody>
+          <a:bodyPr wrap="square" rtlCol="0" anchor="ctr"/>
+          <a:lstStyle/>
+          <a:p>
+            <a:pPr indent="0" marL="0">
+              <a:buNone/>
+            </a:pPr>
+            <a:r>
+              <a:rPr lang="en-US" sz="1300" dirty="0">
+                <a:solidFill>
+                  <a:srgbClr val="5F6F83"/>
+                </a:solidFill>
+                <a:latin typeface="Segoe UI" pitchFamily="34" charset="0"/>
+                <a:ea typeface="Segoe UI" pitchFamily="34" charset="-122"/>
+                <a:cs typeface="Segoe UI" pitchFamily="34" charset="-120"/>
+              </a:rPr>
+              <a:t>A full source code review, every fix regression-tested and verified against live Firebird 3.0 / 4.0 / 5.0.</a:t>
+            </a:r>
+            <a:endParaRPr lang="en-US" sz="1300" dirty="0"/>
+          </a:p>
+        </p:txBody>
+      </p:sp>
+      <p:sp>
+        <p:nvSpPr>
+          <p:cNvPr id="4" name="Text 2"/>
           <p:cNvSpPr/>
           <p:nvPr/>
         </p:nvSpPr>
@@ -14772,6 +14920,732 @@
                 <a:cs typeface="Segoe UI" pitchFamily="34" charset="-120"/>
               </a:rPr>
               <a:t>   |   23</a:t>
+            </a:r>
+            <a:endParaRPr lang="en-US" sz="900" dirty="0"/>
+          </a:p>
+        </p:txBody>
+      </p:sp>
+      <p:sp>
+        <p:nvSpPr>
+          <p:cNvPr id="6" name="Shape 3"/>
+          <p:cNvSpPr/>
+          <p:nvPr/>
+        </p:nvSpPr>
+        <p:spPr>
+          <a:xfrm>
+            <a:off x="502920" y="1371600"/>
+            <a:ext cx="5486400" cy="4297680"/>
+          </a:xfrm>
+          <a:prstGeom prst="roundRect">
+            <a:avLst>
+              <a:gd name="adj" fmla="val 1277"/>
+            </a:avLst>
+          </a:prstGeom>
+          <a:solidFill>
+            <a:srgbClr val="FFFFFF"/>
+          </a:solidFill>
+          <a:ln w="12700">
+            <a:solidFill>
+              <a:srgbClr val="D8DFE8"/>
+            </a:solidFill>
+            <a:prstDash val="solid"/>
+          </a:ln>
+        </p:spPr>
+      </p:sp>
+      <p:sp>
+        <p:nvSpPr>
+          <p:cNvPr id="7" name="Text 4"/>
+          <p:cNvSpPr/>
+          <p:nvPr/>
+        </p:nvSpPr>
+        <p:spPr>
+          <a:xfrm>
+            <a:off x="731520" y="1554480"/>
+            <a:ext cx="5029200" cy="365760"/>
+          </a:xfrm>
+          <a:prstGeom prst="rect">
+            <a:avLst/>
+          </a:prstGeom>
+          <a:noFill/>
+          <a:ln/>
+        </p:spPr>
+        <p:txBody>
+          <a:bodyPr wrap="square" rtlCol="0" anchor="ctr"/>
+          <a:lstStyle/>
+          <a:p>
+            <a:pPr indent="0" marL="0">
+              <a:buNone/>
+            </a:pPr>
+            <a:r>
+              <a:rPr lang="en-US" sz="1500" b="1" dirty="0">
+                <a:solidFill>
+                  <a:srgbClr val="DC2626"/>
+                </a:solidFill>
+                <a:latin typeface="Segoe UI" pitchFamily="34" charset="0"/>
+                <a:ea typeface="Segoe UI" pitchFamily="34" charset="-122"/>
+                <a:cs typeface="Segoe UI" pitchFamily="34" charset="-120"/>
+              </a:rPr>
+              <a:t>Found &amp; fixed</a:t>
+            </a:r>
+            <a:endParaRPr lang="en-US" sz="1500" dirty="0"/>
+          </a:p>
+        </p:txBody>
+      </p:sp>
+      <p:sp>
+        <p:nvSpPr>
+          <p:cNvPr id="8" name="Text 5"/>
+          <p:cNvSpPr/>
+          <p:nvPr/>
+        </p:nvSpPr>
+        <p:spPr>
+          <a:xfrm>
+            <a:off x="731520" y="2011680"/>
+            <a:ext cx="5029200" cy="3383280"/>
+          </a:xfrm>
+          <a:prstGeom prst="rect">
+            <a:avLst/>
+          </a:prstGeom>
+          <a:noFill/>
+          <a:ln/>
+        </p:spPr>
+        <p:txBody>
+          <a:bodyPr wrap="square" rtlCol="0" anchor="ctr"/>
+          <a:lstStyle/>
+          <a:p>
+            <a:pPr indent="0" marL="0">
+              <a:lnSpc>
+                <a:spcPct val="125000"/>
+              </a:lnSpc>
+              <a:buNone/>
+            </a:pPr>
+            <a:r>
+              <a:rPr lang="en-US" sz="1200" dirty="0">
+                <a:solidFill>
+                  <a:srgbClr val="1C2733"/>
+                </a:solidFill>
+                <a:latin typeface="Segoe UI" pitchFamily="34" charset="0"/>
+                <a:ea typeface="Segoe UI" pitchFamily="34" charset="-122"/>
+                <a:cs typeface="Segoe UI" pitchFamily="34" charset="-120"/>
+              </a:rPr>
+              <a:t>Recurring schedules fired once per process</a:t>
+            </a:r>
+            <a:endParaRPr lang="en-US" sz="1200" dirty="0"/>
+          </a:p>
+          <a:p>
+            <a:pPr indent="0" marL="0">
+              <a:lnSpc>
+                <a:spcPct val="125000"/>
+              </a:lnSpc>
+              <a:buNone/>
+            </a:pPr>
+            <a:r>
+              <a:rPr lang="en-US" sz="1200" dirty="0">
+                <a:solidFill>
+                  <a:srgbClr val="1C2733"/>
+                </a:solidFill>
+                <a:latin typeface="Segoe UI" pitchFamily="34" charset="0"/>
+                <a:ea typeface="Segoe UI" pitchFamily="34" charset="-122"/>
+                <a:cs typeface="Segoe UI" pitchFamily="34" charset="-120"/>
+              </a:rPr>
+              <a:t>Shared random source raced across 20 workers</a:t>
+            </a:r>
+            <a:endParaRPr lang="en-US" sz="1200" dirty="0"/>
+          </a:p>
+          <a:p>
+            <a:pPr indent="0" marL="0">
+              <a:lnSpc>
+                <a:spcPct val="125000"/>
+              </a:lnSpc>
+              <a:buNone/>
+            </a:pPr>
+            <a:r>
+              <a:rPr lang="en-US" sz="1200" dirty="0">
+                <a:solidFill>
+                  <a:srgbClr val="1C2733"/>
+                </a:solidFill>
+                <a:latin typeface="Segoe UI" pitchFamily="34" charset="0"/>
+                <a:ea typeface="Segoe UI" pitchFamily="34" charset="-122"/>
+                <a:cs typeface="Segoe UI" pitchFamily="34" charset="-120"/>
+              </a:rPr>
+              <a:t>Per-op timeout silently retired workers —</a:t>
+            </a:r>
+            <a:endParaRPr lang="en-US" sz="1200" dirty="0"/>
+          </a:p>
+          <a:p>
+            <a:pPr indent="0" marL="0">
+              <a:lnSpc>
+                <a:spcPct val="125000"/>
+              </a:lnSpc>
+              <a:buNone/>
+            </a:pPr>
+            <a:r>
+              <a:rPr lang="en-US" sz="1200" dirty="0">
+                <a:solidFill>
+                  <a:srgbClr val="1C2733"/>
+                </a:solidFill>
+                <a:latin typeface="Segoe UI" pitchFamily="34" charset="0"/>
+                <a:ea typeface="Segoe UI" pitchFamily="34" charset="-122"/>
+                <a:cs typeface="Segoe UI" pitchFamily="34" charset="-120"/>
+              </a:rPr>
+              <a:t>the pool decayed under lock waits; now self-heals</a:t>
+            </a:r>
+            <a:endParaRPr lang="en-US" sz="1200" dirty="0"/>
+          </a:p>
+          <a:p>
+            <a:pPr indent="0" marL="0">
+              <a:lnSpc>
+                <a:spcPct val="125000"/>
+              </a:lnSpc>
+              <a:buNone/>
+            </a:pPr>
+            <a:r>
+              <a:rPr lang="en-US" sz="1200" dirty="0">
+                <a:solidFill>
+                  <a:srgbClr val="1C2733"/>
+                </a:solidFill>
+                <a:latin typeface="Segoe UI" pitchFamily="34" charset="0"/>
+                <a:ea typeface="Segoe UI" pitchFamily="34" charset="-122"/>
+                <a:cs typeface="Segoe UI" pitchFamily="34" charset="-120"/>
+              </a:rPr>
+              <a:t>Invariant self-checks ran in the wrong</a:t>
+            </a:r>
+            <a:endParaRPr lang="en-US" sz="1200" dirty="0"/>
+          </a:p>
+          <a:p>
+            <a:pPr indent="0" marL="0">
+              <a:lnSpc>
+                <a:spcPct val="125000"/>
+              </a:lnSpc>
+              <a:buNone/>
+            </a:pPr>
+            <a:r>
+              <a:rPr lang="en-US" sz="1200" dirty="0">
+                <a:solidFill>
+                  <a:srgbClr val="1C2733"/>
+                </a:solidFill>
+                <a:latin typeface="Segoe UI" pitchFamily="34" charset="0"/>
+                <a:ea typeface="Segoe UI" pitchFamily="34" charset="-122"/>
+                <a:cs typeface="Segoe UI" pitchFamily="34" charset="-120"/>
+              </a:rPr>
+              <a:t>isolation — now real SNAPSHOT + NOWAIT</a:t>
+            </a:r>
+            <a:endParaRPr lang="en-US" sz="1200" dirty="0"/>
+          </a:p>
+          <a:p>
+            <a:pPr indent="0" marL="0">
+              <a:lnSpc>
+                <a:spcPct val="125000"/>
+              </a:lnSpc>
+              <a:buNone/>
+            </a:pPr>
+            <a:r>
+              <a:rPr lang="en-US" sz="1200" dirty="0">
+                <a:solidFill>
+                  <a:srgbClr val="1C2733"/>
+                </a:solidFill>
+                <a:latin typeface="Segoe UI" pitchFamily="34" charset="0"/>
+                <a:ea typeface="Segoe UI" pitchFamily="34" charset="-122"/>
+                <a:cs typeface="Segoe UI" pitchFamily="34" charset="-120"/>
+              </a:rPr>
+              <a:t>Classic mode starved its sidecars behind the</a:t>
+            </a:r>
+            <a:endParaRPr lang="en-US" sz="1200" dirty="0"/>
+          </a:p>
+          <a:p>
+            <a:pPr indent="0" marL="0">
+              <a:lnSpc>
+                <a:spcPct val="125000"/>
+              </a:lnSpc>
+              <a:buNone/>
+            </a:pPr>
+            <a:r>
+              <a:rPr lang="en-US" sz="1200" dirty="0">
+                <a:solidFill>
+                  <a:srgbClr val="1C2733"/>
+                </a:solidFill>
+                <a:latin typeface="Segoe UI" pitchFamily="34" charset="0"/>
+                <a:ea typeface="Segoe UI" pitchFamily="34" charset="-122"/>
+                <a:cs typeface="Segoe UI" pitchFamily="34" charset="-120"/>
+              </a:rPr>
+              <a:t>memory monitor — pool auto-sizes, blocked</a:t>
+            </a:r>
+            <a:endParaRPr lang="en-US" sz="1200" dirty="0"/>
+          </a:p>
+          <a:p>
+            <a:pPr indent="0" marL="0">
+              <a:lnSpc>
+                <a:spcPct val="125000"/>
+              </a:lnSpc>
+              <a:buNone/>
+            </a:pPr>
+            <a:r>
+              <a:rPr lang="en-US" sz="1200" dirty="0">
+                <a:solidFill>
+                  <a:srgbClr val="1C2733"/>
+                </a:solidFill>
+                <a:latin typeface="Segoe UI" pitchFamily="34" charset="0"/>
+                <a:ea typeface="Segoe UI" pitchFamily="34" charset="-122"/>
+                <a:cs typeface="Segoe UI" pitchFamily="34" charset="-120"/>
+              </a:rPr>
+              <a:t>BeginTx warns instead of hanging forever</a:t>
+            </a:r>
+            <a:endParaRPr lang="en-US" sz="1200" dirty="0"/>
+          </a:p>
+        </p:txBody>
+      </p:sp>
+      <p:sp>
+        <p:nvSpPr>
+          <p:cNvPr id="9" name="Shape 6"/>
+          <p:cNvSpPr/>
+          <p:nvPr/>
+        </p:nvSpPr>
+        <p:spPr>
+          <a:xfrm>
+            <a:off x="6217920" y="1371600"/>
+            <a:ext cx="5486400" cy="4297680"/>
+          </a:xfrm>
+          <a:prstGeom prst="roundRect">
+            <a:avLst>
+              <a:gd name="adj" fmla="val 1277"/>
+            </a:avLst>
+          </a:prstGeom>
+          <a:solidFill>
+            <a:srgbClr val="FFFFFF"/>
+          </a:solidFill>
+          <a:ln w="12700">
+            <a:solidFill>
+              <a:srgbClr val="D8DFE8"/>
+            </a:solidFill>
+            <a:prstDash val="solid"/>
+          </a:ln>
+        </p:spPr>
+      </p:sp>
+      <p:sp>
+        <p:nvSpPr>
+          <p:cNvPr id="10" name="Text 7"/>
+          <p:cNvSpPr/>
+          <p:nvPr/>
+        </p:nvSpPr>
+        <p:spPr>
+          <a:xfrm>
+            <a:off x="6446520" y="1554480"/>
+            <a:ext cx="5029200" cy="365760"/>
+          </a:xfrm>
+          <a:prstGeom prst="rect">
+            <a:avLst/>
+          </a:prstGeom>
+          <a:noFill/>
+          <a:ln/>
+        </p:spPr>
+        <p:txBody>
+          <a:bodyPr wrap="square" rtlCol="0" anchor="ctr"/>
+          <a:lstStyle/>
+          <a:p>
+            <a:pPr indent="0" marL="0">
+              <a:buNone/>
+            </a:pPr>
+            <a:r>
+              <a:rPr lang="en-US" sz="1500" b="1" dirty="0">
+                <a:solidFill>
+                  <a:srgbClr val="2563EB"/>
+                </a:solidFill>
+                <a:latin typeface="Segoe UI" pitchFamily="34" charset="0"/>
+                <a:ea typeface="Segoe UI" pitchFamily="34" charset="-122"/>
+                <a:cs typeface="Segoe UI" pitchFamily="34" charset="-120"/>
+              </a:rPr>
+              <a:t>Secure by default &amp; CI</a:t>
+            </a:r>
+            <a:endParaRPr lang="en-US" sz="1500" dirty="0"/>
+          </a:p>
+        </p:txBody>
+      </p:sp>
+      <p:sp>
+        <p:nvSpPr>
+          <p:cNvPr id="11" name="Text 8"/>
+          <p:cNvSpPr/>
+          <p:nvPr/>
+        </p:nvSpPr>
+        <p:spPr>
+          <a:xfrm>
+            <a:off x="6446520" y="2011680"/>
+            <a:ext cx="5029200" cy="3383280"/>
+          </a:xfrm>
+          <a:prstGeom prst="rect">
+            <a:avLst/>
+          </a:prstGeom>
+          <a:noFill/>
+          <a:ln/>
+        </p:spPr>
+        <p:txBody>
+          <a:bodyPr wrap="square" rtlCol="0" anchor="ctr"/>
+          <a:lstStyle/>
+          <a:p>
+            <a:pPr indent="0" marL="0">
+              <a:lnSpc>
+                <a:spcPct val="125000"/>
+              </a:lnSpc>
+              <a:buNone/>
+            </a:pPr>
+            <a:r>
+              <a:rPr lang="en-US" sz="1200" dirty="0">
+                <a:solidFill>
+                  <a:srgbClr val="1C2733"/>
+                </a:solidFill>
+                <a:latin typeface="Segoe UI" pitchFamily="34" charset="0"/>
+                <a:ea typeface="Segoe UI" pitchFamily="34" charset="-122"/>
+                <a:cs typeface="Segoe UI" pitchFamily="34" charset="-120"/>
+              </a:rPr>
+              <a:t>UI binds localhost only — a remote address</a:t>
+            </a:r>
+            <a:endParaRPr lang="en-US" sz="1200" dirty="0"/>
+          </a:p>
+          <a:p>
+            <a:pPr indent="0" marL="0">
+              <a:lnSpc>
+                <a:spcPct val="125000"/>
+              </a:lnSpc>
+              <a:buNone/>
+            </a:pPr>
+            <a:r>
+              <a:rPr lang="en-US" sz="1200" dirty="0">
+                <a:solidFill>
+                  <a:srgbClr val="1C2733"/>
+                </a:solidFill>
+                <a:latin typeface="Segoe UI" pitchFamily="34" charset="0"/>
+                <a:ea typeface="Segoe UI" pitchFamily="34" charset="-122"/>
+                <a:cs typeface="Segoe UI" pitchFamily="34" charset="-120"/>
+              </a:rPr>
+              <a:t>requires a bearer token or an explicit risk flag</a:t>
+            </a:r>
+            <a:endParaRPr lang="en-US" sz="1200" dirty="0"/>
+          </a:p>
+          <a:p>
+            <a:pPr indent="0" marL="0">
+              <a:lnSpc>
+                <a:spcPct val="125000"/>
+              </a:lnSpc>
+              <a:buNone/>
+            </a:pPr>
+            <a:r>
+              <a:rPr lang="en-US" sz="1200" dirty="0">
+                <a:solidFill>
+                  <a:srgbClr val="1C2733"/>
+                </a:solidFill>
+                <a:latin typeface="Segoe UI" pitchFamily="34" charset="0"/>
+                <a:ea typeface="Segoe UI" pitchFamily="34" charset="-122"/>
+                <a:cs typeface="Segoe UI" pitchFamily="34" charset="-120"/>
+              </a:rPr>
+              <a:t>Same-origin + Content-Type checks on every</a:t>
+            </a:r>
+            <a:endParaRPr lang="en-US" sz="1200" dirty="0"/>
+          </a:p>
+          <a:p>
+            <a:pPr indent="0" marL="0">
+              <a:lnSpc>
+                <a:spcPct val="125000"/>
+              </a:lnSpc>
+              <a:buNone/>
+            </a:pPr>
+            <a:r>
+              <a:rPr lang="en-US" sz="1200" dirty="0">
+                <a:solidFill>
+                  <a:srgbClr val="1C2733"/>
+                </a:solidFill>
+                <a:latin typeface="Segoe UI" pitchFamily="34" charset="0"/>
+                <a:ea typeface="Segoe UI" pitchFamily="34" charset="-122"/>
+                <a:cs typeface="Segoe UI" pitchFamily="34" charset="-120"/>
+              </a:rPr>
+              <a:t>mutating endpoint; secrets redacted everywhere</a:t>
+            </a:r>
+            <a:endParaRPr lang="en-US" sz="1200" dirty="0"/>
+          </a:p>
+          <a:p>
+            <a:pPr indent="0" marL="0">
+              <a:lnSpc>
+                <a:spcPct val="125000"/>
+              </a:lnSpc>
+              <a:buNone/>
+            </a:pPr>
+            <a:r>
+              <a:rPr lang="en-US" sz="1200" dirty="0">
+                <a:solidFill>
+                  <a:srgbClr val="1C2733"/>
+                </a:solidFill>
+                <a:latin typeface="Segoe UI" pitchFamily="34" charset="0"/>
+                <a:ea typeface="Segoe UI" pitchFamily="34" charset="-122"/>
+                <a:cs typeface="Segoe UI" pitchFamily="34" charset="-120"/>
+              </a:rPr>
+              <a:t>CI: gofmt, go vet, -race, a live Firebird 5.0</a:t>
+            </a:r>
+            <a:endParaRPr lang="en-US" sz="1200" dirty="0"/>
+          </a:p>
+          <a:p>
+            <a:pPr indent="0" marL="0">
+              <a:lnSpc>
+                <a:spcPct val="125000"/>
+              </a:lnSpc>
+              <a:buNone/>
+            </a:pPr>
+            <a:r>
+              <a:rPr lang="en-US" sz="1200" dirty="0">
+                <a:solidFill>
+                  <a:srgbClr val="1C2733"/>
+                </a:solidFill>
+                <a:latin typeface="Segoe UI" pitchFamily="34" charset="0"/>
+                <a:ea typeface="Segoe UI" pitchFamily="34" charset="-122"/>
+                <a:cs typeface="Segoe UI" pitchFamily="34" charset="-120"/>
+              </a:rPr>
+              <a:t>smoke job, 3-OS compile checks</a:t>
+            </a:r>
+            <a:endParaRPr lang="en-US" sz="1200" dirty="0"/>
+          </a:p>
+          <a:p>
+            <a:pPr indent="0" marL="0">
+              <a:lnSpc>
+                <a:spcPct val="125000"/>
+              </a:lnSpc>
+              <a:buNone/>
+            </a:pPr>
+            <a:r>
+              <a:rPr lang="en-US" sz="1200" dirty="0">
+                <a:solidFill>
+                  <a:srgbClr val="1C2733"/>
+                </a:solidFill>
+                <a:latin typeface="Segoe UI" pitchFamily="34" charset="0"/>
+                <a:ea typeface="Segoe UI" pitchFamily="34" charset="-122"/>
+                <a:cs typeface="Segoe UI" pitchFamily="34" charset="-120"/>
+              </a:rPr>
+              <a:t>Every fix ships with a regression test;</a:t>
+            </a:r>
+            <a:endParaRPr lang="en-US" sz="1200" dirty="0"/>
+          </a:p>
+          <a:p>
+            <a:pPr indent="0" marL="0">
+              <a:lnSpc>
+                <a:spcPct val="125000"/>
+              </a:lnSpc>
+              <a:buNone/>
+            </a:pPr>
+            <a:r>
+              <a:rPr lang="en-US" sz="1200" dirty="0">
+                <a:solidFill>
+                  <a:srgbClr val="1C2733"/>
+                </a:solidFill>
+                <a:latin typeface="Segoe UI" pitchFamily="34" charset="0"/>
+                <a:ea typeface="Segoe UI" pitchFamily="34" charset="-122"/>
+                <a:cs typeface="Segoe UI" pitchFamily="34" charset="-120"/>
+              </a:rPr>
+              <a:t>lab matrix: FB3 / FB4 / FB5, all workload</a:t>
+            </a:r>
+            <a:endParaRPr lang="en-US" sz="1200" dirty="0"/>
+          </a:p>
+          <a:p>
+            <a:pPr indent="0" marL="0">
+              <a:lnSpc>
+                <a:spcPct val="125000"/>
+              </a:lnSpc>
+              <a:buNone/>
+            </a:pPr>
+            <a:r>
+              <a:rPr lang="en-US" sz="1200" dirty="0">
+                <a:solidFill>
+                  <a:srgbClr val="1C2733"/>
+                </a:solidFill>
+                <a:latin typeface="Segoe UI" pitchFamily="34" charset="0"/>
+                <a:ea typeface="Segoe UI" pitchFamily="34" charset="-122"/>
+                <a:cs typeface="Segoe UI" pitchFamily="34" charset="-120"/>
+              </a:rPr>
+              <a:t>variants, all invariants OK</a:t>
+            </a:r>
+            <a:endParaRPr lang="en-US" sz="1200" dirty="0"/>
+          </a:p>
+        </p:txBody>
+      </p:sp>
+      <p:sp>
+        <p:nvSpPr>
+          <p:cNvPr id="12" name="Shape 9"/>
+          <p:cNvSpPr/>
+          <p:nvPr/>
+        </p:nvSpPr>
+        <p:spPr>
+          <a:xfrm>
+            <a:off x="502920" y="5897880"/>
+            <a:ext cx="11201400" cy="384048"/>
+          </a:xfrm>
+          <a:prstGeom prst="roundRect">
+            <a:avLst>
+              <a:gd name="adj" fmla="val 47619"/>
+            </a:avLst>
+          </a:prstGeom>
+          <a:solidFill>
+            <a:srgbClr val="EEF2F7"/>
+          </a:solidFill>
+          <a:ln w="12700">
+            <a:solidFill>
+              <a:srgbClr val="D8DFE8"/>
+            </a:solidFill>
+            <a:prstDash val="solid"/>
+          </a:ln>
+        </p:spPr>
+      </p:sp>
+      <p:sp>
+        <p:nvSpPr>
+          <p:cNvPr id="13" name="Text 10"/>
+          <p:cNvSpPr/>
+          <p:nvPr/>
+        </p:nvSpPr>
+        <p:spPr>
+          <a:xfrm>
+            <a:off x="502920" y="5897880"/>
+            <a:ext cx="11201400" cy="384048"/>
+          </a:xfrm>
+          <a:prstGeom prst="rect">
+            <a:avLst/>
+          </a:prstGeom>
+          <a:noFill/>
+          <a:ln/>
+        </p:spPr>
+        <p:txBody>
+          <a:bodyPr wrap="square" rtlCol="0" anchor="ctr"/>
+          <a:lstStyle/>
+          <a:p>
+            <a:pPr algn="ctr" indent="0" marL="0">
+              <a:buNone/>
+            </a:pPr>
+            <a:r>
+              <a:rPr lang="en-US" sz="1150" dirty="0">
+                <a:solidFill>
+                  <a:srgbClr val="1C2733"/>
+                </a:solidFill>
+                <a:latin typeface="Segoe UI" pitchFamily="34" charset="0"/>
+                <a:ea typeface="Segoe UI" pitchFamily="34" charset="-122"/>
+                <a:cs typeface="Segoe UI" pitchFamily="34" charset="-120"/>
+              </a:rPr>
+              <a:t>found by review + verified by running every workload variant on a three-server lab</a:t>
+            </a:r>
+            <a:endParaRPr lang="en-US" sz="1150" dirty="0"/>
+          </a:p>
+        </p:txBody>
+      </p:sp>
+    </p:spTree>
+  </p:cSld>
+  <p:clrMapOvr>
+    <a:masterClrMapping/>
+  </p:clrMapOvr>
+</p:sld>
+</file>
+
+<file path=ppt/slides/slide24.xml><?xml version="1.0" encoding="utf-8"?>
+<p:sld xmlns:a="http://schemas.openxmlformats.org/drawingml/2006/main" xmlns:r="http://schemas.openxmlformats.org/officeDocument/2006/relationships" xmlns:p="http://schemas.openxmlformats.org/presentationml/2006/main">
+  <p:cSld name="Slide 24">
+    <p:bg>
+      <p:bgPr>
+        <a:solidFill>
+          <a:srgbClr val="F5F7FA"/>
+        </a:solidFill>
+      </p:bgPr>
+    </p:bg>
+    <p:spTree>
+      <p:nvGrpSpPr>
+        <p:cNvPr id="1" name=""/>
+        <p:cNvGrpSpPr/>
+        <p:nvPr/>
+      </p:nvGrpSpPr>
+      <p:grpSpPr>
+        <a:xfrm>
+          <a:off x="0" y="0"/>
+          <a:ext cx="0" cy="0"/>
+          <a:chOff x="0" y="0"/>
+          <a:chExt cx="0" cy="0"/>
+        </a:xfrm>
+      </p:grpSpPr>
+      <p:sp>
+        <p:nvSpPr>
+          <p:cNvPr id="2" name="Text 0"/>
+          <p:cNvSpPr/>
+          <p:nvPr/>
+        </p:nvSpPr>
+        <p:spPr>
+          <a:xfrm>
+            <a:off x="502920" y="256032"/>
+            <a:ext cx="11185855" cy="548640"/>
+          </a:xfrm>
+          <a:prstGeom prst="rect">
+            <a:avLst/>
+          </a:prstGeom>
+          <a:noFill/>
+          <a:ln/>
+        </p:spPr>
+        <p:txBody>
+          <a:bodyPr wrap="square" rtlCol="0" anchor="ctr"/>
+          <a:lstStyle/>
+          <a:p>
+            <a:pPr indent="0" marL="0">
+              <a:buNone/>
+            </a:pPr>
+            <a:r>
+              <a:rPr lang="en-US" sz="2700" b="1" dirty="0">
+                <a:solidFill>
+                  <a:srgbClr val="1C2733"/>
+                </a:solidFill>
+                <a:latin typeface="Segoe UI" pitchFamily="34" charset="0"/>
+                <a:ea typeface="Segoe UI" pitchFamily="34" charset="-122"/>
+                <a:cs typeface="Segoe UI" pitchFamily="34" charset="-120"/>
+              </a:rPr>
+              <a:t>Appendix — quick reference</a:t>
+            </a:r>
+            <a:endParaRPr lang="en-US" sz="2700" dirty="0"/>
+          </a:p>
+        </p:txBody>
+      </p:sp>
+      <p:sp>
+        <p:nvSpPr>
+          <p:cNvPr id="3" name="Text 1"/>
+          <p:cNvSpPr/>
+          <p:nvPr/>
+        </p:nvSpPr>
+        <p:spPr>
+          <a:xfrm>
+            <a:off x="8899855" y="6473952"/>
+            <a:ext cx="3017520" cy="274320"/>
+          </a:xfrm>
+          <a:prstGeom prst="rect">
+            <a:avLst/>
+          </a:prstGeom>
+          <a:noFill/>
+          <a:ln/>
+        </p:spPr>
+        <p:txBody>
+          <a:bodyPr wrap="square" rtlCol="0" anchor="ctr"/>
+          <a:lstStyle/>
+          <a:p>
+            <a:pPr algn="r" indent="0" marL="0">
+              <a:buNone/>
+            </a:pPr>
+            <a:r>
+              <a:rPr lang="en-US" sz="900" dirty="0">
+                <a:solidFill>
+                  <a:srgbClr val="5F6F83"/>
+                </a:solidFill>
+                <a:latin typeface="Segoe UI" pitchFamily="34" charset="0"/>
+                <a:ea typeface="Segoe UI" pitchFamily="34" charset="-122"/>
+                <a:cs typeface="Segoe UI" pitchFamily="34" charset="-120"/>
+              </a:rPr>
+              <a:t>IBSurgeon Firebird Load Generator</a:t>
+            </a:r>
+            <a:pPr algn="r" indent="0" marL="0">
+              <a:buNone/>
+            </a:pPr>
+            <a:r>
+              <a:rPr lang="en-US" sz="900" b="1" dirty="0">
+                <a:solidFill>
+                  <a:srgbClr val="2563EB"/>
+                </a:solidFill>
+                <a:latin typeface="Segoe UI" pitchFamily="34" charset="0"/>
+                <a:ea typeface="Segoe UI" pitchFamily="34" charset="-122"/>
+                <a:cs typeface="Segoe UI" pitchFamily="34" charset="-120"/>
+              </a:rPr>
+              <a:t>   |   24</a:t>
             </a:r>
             <a:endParaRPr lang="en-US" sz="900" dirty="0"/>
           </a:p>
@@ -14941,6 +15815,46 @@
                 <a:cs typeface="Consolas" pitchFamily="34" charset="-120"/>
               </a:rPr>
               <a:t>fb-loadgen lwmprobe --action select --fblog &lt;firebird.log&gt;</a:t>
+            </a:r>
+            <a:endParaRPr lang="en-US" sz="1050" dirty="0"/>
+          </a:p>
+          <a:p>
+            <a:pPr indent="0" marL="0">
+              <a:buNone/>
+            </a:pPr>
+            <a:endParaRPr lang="en-US" sz="1050" dirty="0"/>
+          </a:p>
+          <a:p>
+            <a:pPr indent="0" marL="0">
+              <a:buNone/>
+            </a:pPr>
+            <a:r>
+              <a:rPr lang="en-US" sz="1050" dirty="0">
+                <a:solidFill>
+                  <a:srgbClr val="E7ECF3"/>
+                </a:solidFill>
+                <a:latin typeface="Consolas" pitchFamily="34" charset="0"/>
+                <a:ea typeface="Consolas" pitchFamily="34" charset="-122"/>
+                <a:cs typeface="Consolas" pitchFamily="34" charset="-120"/>
+              </a:rPr>
+              <a:t># UI security</a:t>
+            </a:r>
+            <a:endParaRPr lang="en-US" sz="1050" dirty="0"/>
+          </a:p>
+          <a:p>
+            <a:pPr indent="0" marL="0">
+              <a:buNone/>
+            </a:pPr>
+            <a:r>
+              <a:rPr lang="en-US" sz="1050" dirty="0">
+                <a:solidFill>
+                  <a:srgbClr val="E7ECF3"/>
+                </a:solidFill>
+                <a:latin typeface="Consolas" pitchFamily="34" charset="0"/>
+                <a:ea typeface="Consolas" pitchFamily="34" charset="-122"/>
+                <a:cs typeface="Consolas" pitchFamily="34" charset="-120"/>
+              </a:rPr>
+              <a:t>fb-loadgen --ui --ui-token T   # non-localhost addr needs a token</a:t>
             </a:r>
             <a:endParaRPr lang="en-US" sz="1050" dirty="0"/>
           </a:p>

</xml_diff>